<commit_message>
add filter and kernel to paper
</commit_message>
<xml_diff>
--- a/Presentation1.pptx
+++ b/Presentation1.pptx
@@ -263,7 +263,7 @@
           <a:p>
             <a:fld id="{ED0FC01E-52E7-E248-9225-B6E184C589D0}" type="datetimeFigureOut">
               <a:rPr lang="en-US" smtClean="0"/>
-              <a:t>11/18/2024</a:t>
+              <a:t>11/19/2024</a:t>
             </a:fld>
             <a:endParaRPr lang="en-US"/>
           </a:p>
@@ -463,7 +463,7 @@
           <a:p>
             <a:fld id="{ED0FC01E-52E7-E248-9225-B6E184C589D0}" type="datetimeFigureOut">
               <a:rPr lang="en-US" smtClean="0"/>
-              <a:t>11/18/2024</a:t>
+              <a:t>11/19/2024</a:t>
             </a:fld>
             <a:endParaRPr lang="en-US"/>
           </a:p>
@@ -673,7 +673,7 @@
           <a:p>
             <a:fld id="{ED0FC01E-52E7-E248-9225-B6E184C589D0}" type="datetimeFigureOut">
               <a:rPr lang="en-US" smtClean="0"/>
-              <a:t>11/18/2024</a:t>
+              <a:t>11/19/2024</a:t>
             </a:fld>
             <a:endParaRPr lang="en-US"/>
           </a:p>
@@ -873,7 +873,7 @@
           <a:p>
             <a:fld id="{ED0FC01E-52E7-E248-9225-B6E184C589D0}" type="datetimeFigureOut">
               <a:rPr lang="en-US" smtClean="0"/>
-              <a:t>11/18/2024</a:t>
+              <a:t>11/19/2024</a:t>
             </a:fld>
             <a:endParaRPr lang="en-US"/>
           </a:p>
@@ -1149,7 +1149,7 @@
           <a:p>
             <a:fld id="{ED0FC01E-52E7-E248-9225-B6E184C589D0}" type="datetimeFigureOut">
               <a:rPr lang="en-US" smtClean="0"/>
-              <a:t>11/18/2024</a:t>
+              <a:t>11/19/2024</a:t>
             </a:fld>
             <a:endParaRPr lang="en-US"/>
           </a:p>
@@ -1417,7 +1417,7 @@
           <a:p>
             <a:fld id="{ED0FC01E-52E7-E248-9225-B6E184C589D0}" type="datetimeFigureOut">
               <a:rPr lang="en-US" smtClean="0"/>
-              <a:t>11/18/2024</a:t>
+              <a:t>11/19/2024</a:t>
             </a:fld>
             <a:endParaRPr lang="en-US"/>
           </a:p>
@@ -1832,7 +1832,7 @@
           <a:p>
             <a:fld id="{ED0FC01E-52E7-E248-9225-B6E184C589D0}" type="datetimeFigureOut">
               <a:rPr lang="en-US" smtClean="0"/>
-              <a:t>11/18/2024</a:t>
+              <a:t>11/19/2024</a:t>
             </a:fld>
             <a:endParaRPr lang="en-US"/>
           </a:p>
@@ -1974,7 +1974,7 @@
           <a:p>
             <a:fld id="{ED0FC01E-52E7-E248-9225-B6E184C589D0}" type="datetimeFigureOut">
               <a:rPr lang="en-US" smtClean="0"/>
-              <a:t>11/18/2024</a:t>
+              <a:t>11/19/2024</a:t>
             </a:fld>
             <a:endParaRPr lang="en-US"/>
           </a:p>
@@ -2087,7 +2087,7 @@
           <a:p>
             <a:fld id="{ED0FC01E-52E7-E248-9225-B6E184C589D0}" type="datetimeFigureOut">
               <a:rPr lang="en-US" smtClean="0"/>
-              <a:t>11/18/2024</a:t>
+              <a:t>11/19/2024</a:t>
             </a:fld>
             <a:endParaRPr lang="en-US"/>
           </a:p>
@@ -2400,7 +2400,7 @@
           <a:p>
             <a:fld id="{ED0FC01E-52E7-E248-9225-B6E184C589D0}" type="datetimeFigureOut">
               <a:rPr lang="en-US" smtClean="0"/>
-              <a:t>11/18/2024</a:t>
+              <a:t>11/19/2024</a:t>
             </a:fld>
             <a:endParaRPr lang="en-US"/>
           </a:p>
@@ -2689,7 +2689,7 @@
           <a:p>
             <a:fld id="{ED0FC01E-52E7-E248-9225-B6E184C589D0}" type="datetimeFigureOut">
               <a:rPr lang="en-US" smtClean="0"/>
-              <a:t>11/18/2024</a:t>
+              <a:t>11/19/2024</a:t>
             </a:fld>
             <a:endParaRPr lang="en-US"/>
           </a:p>
@@ -2932,7 +2932,7 @@
           <a:p>
             <a:fld id="{ED0FC01E-52E7-E248-9225-B6E184C589D0}" type="datetimeFigureOut">
               <a:rPr lang="en-US" smtClean="0"/>
-              <a:t>11/18/2024</a:t>
+              <a:t>11/19/2024</a:t>
             </a:fld>
             <a:endParaRPr lang="en-US"/>
           </a:p>
@@ -3849,42 +3849,12 @@
           <a:chExt cx="0" cy="0"/>
         </a:xfrm>
       </p:grpSpPr>
-      <p:pic>
-        <p:nvPicPr>
-          <p:cNvPr id="9" name="圖片 8">
+      <p:grpSp>
+        <p:nvGrpSpPr>
+          <p:cNvPr id="2" name="群組 1">
             <a:extLst>
               <a:ext uri="{FF2B5EF4-FFF2-40B4-BE49-F238E27FC236}">
-                <a16:creationId xmlns:a16="http://schemas.microsoft.com/office/drawing/2014/main" id="{C93A6D5B-A69F-4656-B6B6-8AF0E1FC21A0}"/>
-              </a:ext>
-            </a:extLst>
-          </p:cNvPr>
-          <p:cNvPicPr preferRelativeResize="0">
-            <a:picLocks/>
-          </p:cNvPicPr>
-          <p:nvPr/>
-        </p:nvPicPr>
-        <p:blipFill>
-          <a:blip r:embed="rId2"/>
-          <a:stretch>
-            <a:fillRect/>
-          </a:stretch>
-        </p:blipFill>
-        <p:spPr>
-          <a:xfrm>
-            <a:off x="2142837" y="1224015"/>
-            <a:ext cx="1496152" cy="1475313"/>
-          </a:xfrm>
-          <a:prstGeom prst="rect">
-            <a:avLst/>
-          </a:prstGeom>
-        </p:spPr>
-      </p:pic>
-      <p:grpSp>
-        <p:nvGrpSpPr>
-          <p:cNvPr id="23" name="群組 22">
-            <a:extLst>
-              <a:ext uri="{FF2B5EF4-FFF2-40B4-BE49-F238E27FC236}">
-                <a16:creationId xmlns:a16="http://schemas.microsoft.com/office/drawing/2014/main" id="{2EC3CF09-606A-41E8-BDAD-BB4954084973}"/>
+                <a16:creationId xmlns:a16="http://schemas.microsoft.com/office/drawing/2014/main" id="{AA649827-8E97-4DFF-A661-1C3C42A34F44}"/>
               </a:ext>
             </a:extLst>
           </p:cNvPr>
@@ -3893,65 +3863,435 @@
         </p:nvGrpSpPr>
         <p:grpSpPr>
           <a:xfrm>
-            <a:off x="4418666" y="1224015"/>
-            <a:ext cx="1524622" cy="1395536"/>
-            <a:chOff x="3648363" y="1953687"/>
-            <a:chExt cx="1524622" cy="1395536"/>
+            <a:off x="551703" y="159350"/>
+            <a:ext cx="7667246" cy="1807344"/>
+            <a:chOff x="2142837" y="1038240"/>
+            <a:chExt cx="7667246" cy="1807344"/>
           </a:xfrm>
         </p:grpSpPr>
         <p:pic>
           <p:nvPicPr>
-            <p:cNvPr id="11" name="圖片 10">
-              <a:extLst>
-                <a:ext uri="{FF2B5EF4-FFF2-40B4-BE49-F238E27FC236}">
-                  <a16:creationId xmlns:a16="http://schemas.microsoft.com/office/drawing/2014/main" id="{9BE9D09C-2989-45A1-88F3-1DC4C236161C}"/>
-                </a:ext>
-              </a:extLst>
-            </p:cNvPr>
-            <p:cNvPicPr>
-              <a:picLocks noChangeAspect="1"/>
-            </p:cNvPicPr>
-            <p:nvPr/>
-          </p:nvPicPr>
-          <p:blipFill rotWithShape="1">
-            <a:blip r:embed="rId3"/>
-            <a:srcRect r="24697" b="25417"/>
-            <a:stretch/>
-          </p:blipFill>
-          <p:spPr>
-            <a:xfrm>
-              <a:off x="3648363" y="1953687"/>
-              <a:ext cx="979055" cy="969686"/>
-            </a:xfrm>
-            <a:prstGeom prst="rect">
-              <a:avLst/>
-            </a:prstGeom>
-          </p:spPr>
-        </p:pic>
-        <p:pic>
-          <p:nvPicPr>
-            <p:cNvPr id="13" name="圖片 12">
-              <a:extLst>
-                <a:ext uri="{FF2B5EF4-FFF2-40B4-BE49-F238E27FC236}">
-                  <a16:creationId xmlns:a16="http://schemas.microsoft.com/office/drawing/2014/main" id="{C281E78A-7E2E-4B24-A5DF-7EF7331F3177}"/>
-                </a:ext>
-              </a:extLst>
-            </p:cNvPr>
-            <p:cNvPicPr>
-              <a:picLocks noChangeAspect="1"/>
+            <p:cNvPr id="9" name="圖片 8">
+              <a:extLst>
+                <a:ext uri="{FF2B5EF4-FFF2-40B4-BE49-F238E27FC236}">
+                  <a16:creationId xmlns:a16="http://schemas.microsoft.com/office/drawing/2014/main" id="{C93A6D5B-A69F-4656-B6B6-8AF0E1FC21A0}"/>
+                </a:ext>
+              </a:extLst>
+            </p:cNvPr>
+            <p:cNvPicPr preferRelativeResize="0">
+              <a:picLocks/>
             </p:cNvPicPr>
             <p:nvPr/>
           </p:nvPicPr>
           <p:blipFill>
-            <a:blip r:embed="rId4"/>
+            <a:blip r:embed="rId2"/>
             <a:stretch>
               <a:fillRect/>
             </a:stretch>
           </p:blipFill>
           <p:spPr>
             <a:xfrm>
-              <a:off x="3757956" y="2036114"/>
-              <a:ext cx="981541" cy="975445"/>
+              <a:off x="2142837" y="1224015"/>
+              <a:ext cx="1496152" cy="1475313"/>
+            </a:xfrm>
+            <a:prstGeom prst="rect">
+              <a:avLst/>
+            </a:prstGeom>
+          </p:spPr>
+        </p:pic>
+        <p:grpSp>
+          <p:nvGrpSpPr>
+            <p:cNvPr id="23" name="群組 22">
+              <a:extLst>
+                <a:ext uri="{FF2B5EF4-FFF2-40B4-BE49-F238E27FC236}">
+                  <a16:creationId xmlns:a16="http://schemas.microsoft.com/office/drawing/2014/main" id="{2EC3CF09-606A-41E8-BDAD-BB4954084973}"/>
+                </a:ext>
+              </a:extLst>
+            </p:cNvPr>
+            <p:cNvGrpSpPr/>
+            <p:nvPr/>
+          </p:nvGrpSpPr>
+          <p:grpSpPr>
+            <a:xfrm>
+              <a:off x="4418666" y="1224015"/>
+              <a:ext cx="1524622" cy="1395536"/>
+              <a:chOff x="3648363" y="1953687"/>
+              <a:chExt cx="1524622" cy="1395536"/>
+            </a:xfrm>
+          </p:grpSpPr>
+          <p:pic>
+            <p:nvPicPr>
+              <p:cNvPr id="11" name="圖片 10">
+                <a:extLst>
+                  <a:ext uri="{FF2B5EF4-FFF2-40B4-BE49-F238E27FC236}">
+                    <a16:creationId xmlns:a16="http://schemas.microsoft.com/office/drawing/2014/main" id="{9BE9D09C-2989-45A1-88F3-1DC4C236161C}"/>
+                  </a:ext>
+                </a:extLst>
+              </p:cNvPr>
+              <p:cNvPicPr>
+                <a:picLocks noChangeAspect="1"/>
+              </p:cNvPicPr>
+              <p:nvPr/>
+            </p:nvPicPr>
+            <p:blipFill rotWithShape="1">
+              <a:blip r:embed="rId3"/>
+              <a:srcRect r="24697" b="25417"/>
+              <a:stretch/>
+            </p:blipFill>
+            <p:spPr>
+              <a:xfrm>
+                <a:off x="3648363" y="1953687"/>
+                <a:ext cx="979055" cy="969686"/>
+              </a:xfrm>
+              <a:prstGeom prst="rect">
+                <a:avLst/>
+              </a:prstGeom>
+            </p:spPr>
+          </p:pic>
+          <p:pic>
+            <p:nvPicPr>
+              <p:cNvPr id="13" name="圖片 12">
+                <a:extLst>
+                  <a:ext uri="{FF2B5EF4-FFF2-40B4-BE49-F238E27FC236}">
+                    <a16:creationId xmlns:a16="http://schemas.microsoft.com/office/drawing/2014/main" id="{C281E78A-7E2E-4B24-A5DF-7EF7331F3177}"/>
+                  </a:ext>
+                </a:extLst>
+              </p:cNvPr>
+              <p:cNvPicPr>
+                <a:picLocks noChangeAspect="1"/>
+              </p:cNvPicPr>
+              <p:nvPr/>
+            </p:nvPicPr>
+            <p:blipFill>
+              <a:blip r:embed="rId4"/>
+              <a:stretch>
+                <a:fillRect/>
+              </a:stretch>
+            </p:blipFill>
+            <p:spPr>
+              <a:xfrm>
+                <a:off x="3757956" y="2036114"/>
+                <a:ext cx="981541" cy="975445"/>
+              </a:xfrm>
+              <a:prstGeom prst="rect">
+                <a:avLst/>
+              </a:prstGeom>
+            </p:spPr>
+          </p:pic>
+          <p:pic>
+            <p:nvPicPr>
+              <p:cNvPr id="14" name="圖片 13">
+                <a:extLst>
+                  <a:ext uri="{FF2B5EF4-FFF2-40B4-BE49-F238E27FC236}">
+                    <a16:creationId xmlns:a16="http://schemas.microsoft.com/office/drawing/2014/main" id="{655B1F52-A864-4570-993D-1E715A0C378B}"/>
+                  </a:ext>
+                </a:extLst>
+              </p:cNvPr>
+              <p:cNvPicPr>
+                <a:picLocks noChangeAspect="1"/>
+              </p:cNvPicPr>
+              <p:nvPr/>
+            </p:nvPicPr>
+            <p:blipFill>
+              <a:blip r:embed="rId4"/>
+              <a:stretch>
+                <a:fillRect/>
+              </a:stretch>
+            </p:blipFill>
+            <p:spPr>
+              <a:xfrm>
+                <a:off x="3867549" y="2118541"/>
+                <a:ext cx="981541" cy="975445"/>
+              </a:xfrm>
+              <a:prstGeom prst="rect">
+                <a:avLst/>
+              </a:prstGeom>
+            </p:spPr>
+          </p:pic>
+          <p:pic>
+            <p:nvPicPr>
+              <p:cNvPr id="15" name="圖片 14">
+                <a:extLst>
+                  <a:ext uri="{FF2B5EF4-FFF2-40B4-BE49-F238E27FC236}">
+                    <a16:creationId xmlns:a16="http://schemas.microsoft.com/office/drawing/2014/main" id="{6F81EE84-91D7-4528-B3AA-511137C55374}"/>
+                  </a:ext>
+                </a:extLst>
+              </p:cNvPr>
+              <p:cNvPicPr>
+                <a:picLocks noChangeAspect="1"/>
+              </p:cNvPicPr>
+              <p:nvPr/>
+            </p:nvPicPr>
+            <p:blipFill>
+              <a:blip r:embed="rId4"/>
+              <a:stretch>
+                <a:fillRect/>
+              </a:stretch>
+            </p:blipFill>
+            <p:spPr>
+              <a:xfrm>
+                <a:off x="3977142" y="2203620"/>
+                <a:ext cx="981541" cy="975445"/>
+              </a:xfrm>
+              <a:prstGeom prst="rect">
+                <a:avLst/>
+              </a:prstGeom>
+            </p:spPr>
+          </p:pic>
+          <p:pic>
+            <p:nvPicPr>
+              <p:cNvPr id="16" name="圖片 15">
+                <a:extLst>
+                  <a:ext uri="{FF2B5EF4-FFF2-40B4-BE49-F238E27FC236}">
+                    <a16:creationId xmlns:a16="http://schemas.microsoft.com/office/drawing/2014/main" id="{D15EDF46-8293-4253-BB12-FFDB0A2F8242}"/>
+                  </a:ext>
+                </a:extLst>
+              </p:cNvPr>
+              <p:cNvPicPr>
+                <a:picLocks noChangeAspect="1"/>
+              </p:cNvPicPr>
+              <p:nvPr/>
+            </p:nvPicPr>
+            <p:blipFill>
+              <a:blip r:embed="rId4"/>
+              <a:stretch>
+                <a:fillRect/>
+              </a:stretch>
+            </p:blipFill>
+            <p:spPr>
+              <a:xfrm>
+                <a:off x="4086735" y="2288699"/>
+                <a:ext cx="981541" cy="975445"/>
+              </a:xfrm>
+              <a:prstGeom prst="rect">
+                <a:avLst/>
+              </a:prstGeom>
+            </p:spPr>
+          </p:pic>
+          <p:pic>
+            <p:nvPicPr>
+              <p:cNvPr id="17" name="圖片 16">
+                <a:extLst>
+                  <a:ext uri="{FF2B5EF4-FFF2-40B4-BE49-F238E27FC236}">
+                    <a16:creationId xmlns:a16="http://schemas.microsoft.com/office/drawing/2014/main" id="{2842978E-0583-48ED-9822-36C5900F27F5}"/>
+                  </a:ext>
+                </a:extLst>
+              </p:cNvPr>
+              <p:cNvPicPr>
+                <a:picLocks noChangeAspect="1"/>
+              </p:cNvPicPr>
+              <p:nvPr/>
+            </p:nvPicPr>
+            <p:blipFill>
+              <a:blip r:embed="rId4"/>
+              <a:stretch>
+                <a:fillRect/>
+              </a:stretch>
+            </p:blipFill>
+            <p:spPr>
+              <a:xfrm>
+                <a:off x="4191444" y="2373778"/>
+                <a:ext cx="981541" cy="975445"/>
+              </a:xfrm>
+              <a:prstGeom prst="rect">
+                <a:avLst/>
+              </a:prstGeom>
+            </p:spPr>
+          </p:pic>
+        </p:grpSp>
+        <p:grpSp>
+          <p:nvGrpSpPr>
+            <p:cNvPr id="24" name="群組 23">
+              <a:extLst>
+                <a:ext uri="{FF2B5EF4-FFF2-40B4-BE49-F238E27FC236}">
+                  <a16:creationId xmlns:a16="http://schemas.microsoft.com/office/drawing/2014/main" id="{55294A14-C7A5-4C54-A992-B1EAE499BDA8}"/>
+                </a:ext>
+              </a:extLst>
+            </p:cNvPr>
+            <p:cNvGrpSpPr/>
+            <p:nvPr/>
+          </p:nvGrpSpPr>
+          <p:grpSpPr>
+            <a:xfrm>
+              <a:off x="6508492" y="1537362"/>
+              <a:ext cx="954812" cy="914741"/>
+              <a:chOff x="6642592" y="2425096"/>
+              <a:chExt cx="954812" cy="914741"/>
+            </a:xfrm>
+          </p:grpSpPr>
+          <p:pic>
+            <p:nvPicPr>
+              <p:cNvPr id="12" name="圖片 11">
+                <a:extLst>
+                  <a:ext uri="{FF2B5EF4-FFF2-40B4-BE49-F238E27FC236}">
+                    <a16:creationId xmlns:a16="http://schemas.microsoft.com/office/drawing/2014/main" id="{914FACF0-54CE-437D-B834-837CFA2C31E8}"/>
+                  </a:ext>
+                </a:extLst>
+              </p:cNvPr>
+              <p:cNvPicPr>
+                <a:picLocks noChangeAspect="1"/>
+              </p:cNvPicPr>
+              <p:nvPr/>
+            </p:nvPicPr>
+            <p:blipFill rotWithShape="1">
+              <a:blip r:embed="rId3"/>
+              <a:srcRect r="49679" b="50080"/>
+              <a:stretch/>
+            </p:blipFill>
+            <p:spPr>
+              <a:xfrm>
+                <a:off x="6642592" y="2425096"/>
+                <a:ext cx="674255" cy="668890"/>
+              </a:xfrm>
+              <a:prstGeom prst="rect">
+                <a:avLst/>
+              </a:prstGeom>
+            </p:spPr>
+          </p:pic>
+          <p:pic>
+            <p:nvPicPr>
+              <p:cNvPr id="19" name="圖片 18">
+                <a:extLst>
+                  <a:ext uri="{FF2B5EF4-FFF2-40B4-BE49-F238E27FC236}">
+                    <a16:creationId xmlns:a16="http://schemas.microsoft.com/office/drawing/2014/main" id="{3A6CA27A-030A-42F8-B5B0-A37E4BE9065C}"/>
+                  </a:ext>
+                </a:extLst>
+              </p:cNvPr>
+              <p:cNvPicPr>
+                <a:picLocks noChangeAspect="1"/>
+              </p:cNvPicPr>
+              <p:nvPr/>
+            </p:nvPicPr>
+            <p:blipFill>
+              <a:blip r:embed="rId5"/>
+              <a:stretch>
+                <a:fillRect/>
+              </a:stretch>
+            </p:blipFill>
+            <p:spPr>
+              <a:xfrm>
+                <a:off x="6705116" y="2483047"/>
+                <a:ext cx="670618" cy="670618"/>
+              </a:xfrm>
+              <a:prstGeom prst="rect">
+                <a:avLst/>
+              </a:prstGeom>
+            </p:spPr>
+          </p:pic>
+          <p:pic>
+            <p:nvPicPr>
+              <p:cNvPr id="20" name="圖片 19">
+                <a:extLst>
+                  <a:ext uri="{FF2B5EF4-FFF2-40B4-BE49-F238E27FC236}">
+                    <a16:creationId xmlns:a16="http://schemas.microsoft.com/office/drawing/2014/main" id="{869B156A-B2EE-46C7-9329-00ABEFC237F2}"/>
+                  </a:ext>
+                </a:extLst>
+              </p:cNvPr>
+              <p:cNvPicPr>
+                <a:picLocks noChangeAspect="1"/>
+              </p:cNvPicPr>
+              <p:nvPr/>
+            </p:nvPicPr>
+            <p:blipFill>
+              <a:blip r:embed="rId5"/>
+              <a:stretch>
+                <a:fillRect/>
+              </a:stretch>
+            </p:blipFill>
+            <p:spPr>
+              <a:xfrm>
+                <a:off x="6779006" y="2543307"/>
+                <a:ext cx="670618" cy="670618"/>
+              </a:xfrm>
+              <a:prstGeom prst="rect">
+                <a:avLst/>
+              </a:prstGeom>
+            </p:spPr>
+          </p:pic>
+          <p:pic>
+            <p:nvPicPr>
+              <p:cNvPr id="21" name="圖片 20">
+                <a:extLst>
+                  <a:ext uri="{FF2B5EF4-FFF2-40B4-BE49-F238E27FC236}">
+                    <a16:creationId xmlns:a16="http://schemas.microsoft.com/office/drawing/2014/main" id="{DF11FD97-F2B3-48A8-A0D9-A61EE5C7E507}"/>
+                  </a:ext>
+                </a:extLst>
+              </p:cNvPr>
+              <p:cNvPicPr>
+                <a:picLocks noChangeAspect="1"/>
+              </p:cNvPicPr>
+              <p:nvPr/>
+            </p:nvPicPr>
+            <p:blipFill>
+              <a:blip r:embed="rId5"/>
+              <a:stretch>
+                <a:fillRect/>
+              </a:stretch>
+            </p:blipFill>
+            <p:spPr>
+              <a:xfrm>
+                <a:off x="6852896" y="2606263"/>
+                <a:ext cx="670618" cy="670618"/>
+              </a:xfrm>
+              <a:prstGeom prst="rect">
+                <a:avLst/>
+              </a:prstGeom>
+            </p:spPr>
+          </p:pic>
+          <p:pic>
+            <p:nvPicPr>
+              <p:cNvPr id="22" name="圖片 21">
+                <a:extLst>
+                  <a:ext uri="{FF2B5EF4-FFF2-40B4-BE49-F238E27FC236}">
+                    <a16:creationId xmlns:a16="http://schemas.microsoft.com/office/drawing/2014/main" id="{B295639C-F4F7-473F-91CD-F672D6A85391}"/>
+                  </a:ext>
+                </a:extLst>
+              </p:cNvPr>
+              <p:cNvPicPr>
+                <a:picLocks noChangeAspect="1"/>
+              </p:cNvPicPr>
+              <p:nvPr/>
+            </p:nvPicPr>
+            <p:blipFill>
+              <a:blip r:embed="rId5"/>
+              <a:stretch>
+                <a:fillRect/>
+              </a:stretch>
+            </p:blipFill>
+            <p:spPr>
+              <a:xfrm>
+                <a:off x="6926786" y="2669219"/>
+                <a:ext cx="670618" cy="670618"/>
+              </a:xfrm>
+              <a:prstGeom prst="rect">
+                <a:avLst/>
+              </a:prstGeom>
+            </p:spPr>
+          </p:pic>
+        </p:grpSp>
+        <p:pic>
+          <p:nvPicPr>
+            <p:cNvPr id="25" name="圖片 24">
+              <a:extLst>
+                <a:ext uri="{FF2B5EF4-FFF2-40B4-BE49-F238E27FC236}">
+                  <a16:creationId xmlns:a16="http://schemas.microsoft.com/office/drawing/2014/main" id="{4FF51D5A-1568-4717-9F95-759F375F2B37}"/>
+                </a:ext>
+              </a:extLst>
+            </p:cNvPr>
+            <p:cNvPicPr>
+              <a:picLocks noChangeAspect="1"/>
+            </p:cNvPicPr>
+            <p:nvPr/>
+          </p:nvPicPr>
+          <p:blipFill rotWithShape="1">
+            <a:blip r:embed="rId5"/>
+            <a:srcRect l="-1" r="75206"/>
+            <a:stretch/>
+          </p:blipFill>
+          <p:spPr>
+            <a:xfrm>
+              <a:off x="8238812" y="1038240"/>
+              <a:ext cx="166279" cy="670618"/>
             </a:xfrm>
             <a:prstGeom prst="rect">
               <a:avLst/>
@@ -3960,10 +4300,10 @@
         </p:pic>
         <p:pic>
           <p:nvPicPr>
-            <p:cNvPr id="14" name="圖片 13">
-              <a:extLst>
-                <a:ext uri="{FF2B5EF4-FFF2-40B4-BE49-F238E27FC236}">
-                  <a16:creationId xmlns:a16="http://schemas.microsoft.com/office/drawing/2014/main" id="{655B1F52-A864-4570-993D-1E715A0C378B}"/>
+            <p:cNvPr id="26" name="圖片 25">
+              <a:extLst>
+                <a:ext uri="{FF2B5EF4-FFF2-40B4-BE49-F238E27FC236}">
+                  <a16:creationId xmlns:a16="http://schemas.microsoft.com/office/drawing/2014/main" id="{0021B9F1-9128-450E-A3B8-A1DCCA3B9378}"/>
                 </a:ext>
               </a:extLst>
             </p:cNvPr>
@@ -3973,15 +4313,15 @@
             <p:nvPr/>
           </p:nvPicPr>
           <p:blipFill>
-            <a:blip r:embed="rId4"/>
+            <a:blip r:embed="rId6"/>
             <a:stretch>
               <a:fillRect/>
             </a:stretch>
           </p:blipFill>
           <p:spPr>
             <a:xfrm>
-              <a:off x="3867549" y="2118541"/>
-              <a:ext cx="981541" cy="975445"/>
+              <a:off x="8239648" y="2174966"/>
+              <a:ext cx="164606" cy="670618"/>
             </a:xfrm>
             <a:prstGeom prst="rect">
               <a:avLst/>
@@ -3990,10 +4330,10 @@
         </p:pic>
         <p:pic>
           <p:nvPicPr>
-            <p:cNvPr id="15" name="圖片 14">
-              <a:extLst>
-                <a:ext uri="{FF2B5EF4-FFF2-40B4-BE49-F238E27FC236}">
-                  <a16:creationId xmlns:a16="http://schemas.microsoft.com/office/drawing/2014/main" id="{6F81EE84-91D7-4528-B3AA-511137C55374}"/>
+            <p:cNvPr id="27" name="圖片 26">
+              <a:extLst>
+                <a:ext uri="{FF2B5EF4-FFF2-40B4-BE49-F238E27FC236}">
+                  <a16:creationId xmlns:a16="http://schemas.microsoft.com/office/drawing/2014/main" id="{5026C78D-450B-4131-9EA1-39CC3E5EF6A9}"/>
                 </a:ext>
               </a:extLst>
             </p:cNvPr>
@@ -4003,15 +4343,15 @@
             <p:nvPr/>
           </p:nvPicPr>
           <p:blipFill>
-            <a:blip r:embed="rId4"/>
+            <a:blip r:embed="rId6"/>
             <a:stretch>
               <a:fillRect/>
             </a:stretch>
           </p:blipFill>
           <p:spPr>
             <a:xfrm>
-              <a:off x="3977142" y="2203620"/>
-              <a:ext cx="981541" cy="975445"/>
+              <a:off x="8858497" y="1584060"/>
+              <a:ext cx="164606" cy="670618"/>
             </a:xfrm>
             <a:prstGeom prst="rect">
               <a:avLst/>
@@ -4020,10 +4360,10 @@
         </p:pic>
         <p:pic>
           <p:nvPicPr>
-            <p:cNvPr id="16" name="圖片 15">
-              <a:extLst>
-                <a:ext uri="{FF2B5EF4-FFF2-40B4-BE49-F238E27FC236}">
-                  <a16:creationId xmlns:a16="http://schemas.microsoft.com/office/drawing/2014/main" id="{D15EDF46-8293-4253-BB12-FFDB0A2F8242}"/>
+            <p:cNvPr id="28" name="圖片 27">
+              <a:extLst>
+                <a:ext uri="{FF2B5EF4-FFF2-40B4-BE49-F238E27FC236}">
+                  <a16:creationId xmlns:a16="http://schemas.microsoft.com/office/drawing/2014/main" id="{B9555DB1-3FC6-4E92-911F-32126E949EDF}"/>
                 </a:ext>
               </a:extLst>
             </p:cNvPr>
@@ -4032,1068 +4372,749 @@
             </p:cNvPicPr>
             <p:nvPr/>
           </p:nvPicPr>
-          <p:blipFill>
-            <a:blip r:embed="rId4"/>
-            <a:stretch>
-              <a:fillRect/>
-            </a:stretch>
-          </p:blipFill>
-          <p:spPr>
-            <a:xfrm>
-              <a:off x="4086735" y="2288699"/>
-              <a:ext cx="981541" cy="975445"/>
-            </a:xfrm>
-            <a:prstGeom prst="rect">
-              <a:avLst/>
-            </a:prstGeom>
-          </p:spPr>
-        </p:pic>
-        <p:pic>
-          <p:nvPicPr>
-            <p:cNvPr id="17" name="圖片 16">
-              <a:extLst>
-                <a:ext uri="{FF2B5EF4-FFF2-40B4-BE49-F238E27FC236}">
-                  <a16:creationId xmlns:a16="http://schemas.microsoft.com/office/drawing/2014/main" id="{2842978E-0583-48ED-9822-36C5900F27F5}"/>
-                </a:ext>
-              </a:extLst>
-            </p:cNvPr>
-            <p:cNvPicPr>
-              <a:picLocks noChangeAspect="1"/>
-            </p:cNvPicPr>
-            <p:nvPr/>
-          </p:nvPicPr>
-          <p:blipFill>
-            <a:blip r:embed="rId4"/>
-            <a:stretch>
-              <a:fillRect/>
-            </a:stretch>
-          </p:blipFill>
-          <p:spPr>
-            <a:xfrm>
-              <a:off x="4191444" y="2373778"/>
-              <a:ext cx="981541" cy="975445"/>
-            </a:xfrm>
-            <a:prstGeom prst="rect">
-              <a:avLst/>
-            </a:prstGeom>
-          </p:spPr>
-        </p:pic>
-      </p:grpSp>
-      <p:grpSp>
-        <p:nvGrpSpPr>
-          <p:cNvPr id="24" name="群組 23">
-            <a:extLst>
-              <a:ext uri="{FF2B5EF4-FFF2-40B4-BE49-F238E27FC236}">
-                <a16:creationId xmlns:a16="http://schemas.microsoft.com/office/drawing/2014/main" id="{55294A14-C7A5-4C54-A992-B1EAE499BDA8}"/>
-              </a:ext>
-            </a:extLst>
-          </p:cNvPr>
-          <p:cNvGrpSpPr/>
-          <p:nvPr/>
-        </p:nvGrpSpPr>
-        <p:grpSpPr>
-          <a:xfrm>
-            <a:off x="6508492" y="1537362"/>
-            <a:ext cx="954812" cy="914741"/>
-            <a:chOff x="6642592" y="2425096"/>
-            <a:chExt cx="954812" cy="914741"/>
-          </a:xfrm>
-        </p:grpSpPr>
-        <p:pic>
-          <p:nvPicPr>
-            <p:cNvPr id="12" name="圖片 11">
-              <a:extLst>
-                <a:ext uri="{FF2B5EF4-FFF2-40B4-BE49-F238E27FC236}">
-                  <a16:creationId xmlns:a16="http://schemas.microsoft.com/office/drawing/2014/main" id="{914FACF0-54CE-437D-B834-837CFA2C31E8}"/>
-                </a:ext>
-              </a:extLst>
-            </p:cNvPr>
-            <p:cNvPicPr>
-              <a:picLocks noChangeAspect="1"/>
-            </p:cNvPicPr>
-            <p:nvPr/>
-          </p:nvPicPr>
           <p:blipFill rotWithShape="1">
-            <a:blip r:embed="rId3"/>
-            <a:srcRect r="49679" b="50080"/>
+            <a:blip r:embed="rId6"/>
+            <a:srcRect b="48355"/>
             <a:stretch/>
           </p:blipFill>
           <p:spPr>
             <a:xfrm>
-              <a:off x="6642592" y="2425096"/>
-              <a:ext cx="674255" cy="668890"/>
+              <a:off x="9426165" y="1757451"/>
+              <a:ext cx="164606" cy="346341"/>
             </a:xfrm>
             <a:prstGeom prst="rect">
               <a:avLst/>
             </a:prstGeom>
           </p:spPr>
         </p:pic>
-        <p:pic>
-          <p:nvPicPr>
-            <p:cNvPr id="19" name="圖片 18">
-              <a:extLst>
-                <a:ext uri="{FF2B5EF4-FFF2-40B4-BE49-F238E27FC236}">
-                  <a16:creationId xmlns:a16="http://schemas.microsoft.com/office/drawing/2014/main" id="{3A6CA27A-030A-42F8-B5B0-A37E4BE9065C}"/>
-                </a:ext>
-              </a:extLst>
-            </p:cNvPr>
-            <p:cNvPicPr>
-              <a:picLocks noChangeAspect="1"/>
-            </p:cNvPicPr>
-            <p:nvPr/>
-          </p:nvPicPr>
-          <p:blipFill>
-            <a:blip r:embed="rId5"/>
-            <a:stretch>
-              <a:fillRect/>
-            </a:stretch>
-          </p:blipFill>
+        <p:cxnSp>
+          <p:nvCxnSpPr>
+            <p:cNvPr id="30" name="直線單箭頭接點 29">
+              <a:extLst>
+                <a:ext uri="{FF2B5EF4-FFF2-40B4-BE49-F238E27FC236}">
+                  <a16:creationId xmlns:a16="http://schemas.microsoft.com/office/drawing/2014/main" id="{6943ACD9-CCAB-49C0-8379-1D9F1C63BD5E}"/>
+                </a:ext>
+              </a:extLst>
+            </p:cNvPr>
+            <p:cNvCxnSpPr>
+              <a:cxnSpLocks/>
+              <a:stCxn id="9" idx="3"/>
+            </p:cNvCxnSpPr>
+            <p:nvPr/>
+          </p:nvCxnSpPr>
+          <p:spPr>
+            <a:xfrm flipV="1">
+              <a:off x="3638989" y="1961670"/>
+              <a:ext cx="779677" cy="2"/>
+            </a:xfrm>
+            <a:prstGeom prst="straightConnector1">
+              <a:avLst/>
+            </a:prstGeom>
+            <a:ln>
+              <a:solidFill>
+                <a:schemeClr val="accent1">
+                  <a:lumMod val="20000"/>
+                  <a:lumOff val="80000"/>
+                </a:schemeClr>
+              </a:solidFill>
+              <a:tailEnd type="triangle"/>
+            </a:ln>
+          </p:spPr>
+          <p:style>
+            <a:lnRef idx="2">
+              <a:schemeClr val="accent1"/>
+            </a:lnRef>
+            <a:fillRef idx="0">
+              <a:schemeClr val="accent1"/>
+            </a:fillRef>
+            <a:effectRef idx="1">
+              <a:schemeClr val="accent1"/>
+            </a:effectRef>
+            <a:fontRef idx="minor">
+              <a:schemeClr val="tx1"/>
+            </a:fontRef>
+          </p:style>
+        </p:cxnSp>
+        <p:cxnSp>
+          <p:nvCxnSpPr>
+            <p:cNvPr id="32" name="直線單箭頭接點 31">
+              <a:extLst>
+                <a:ext uri="{FF2B5EF4-FFF2-40B4-BE49-F238E27FC236}">
+                  <a16:creationId xmlns:a16="http://schemas.microsoft.com/office/drawing/2014/main" id="{76D55E2E-2E9D-45DA-A4B5-258D1A6E663B}"/>
+                </a:ext>
+              </a:extLst>
+            </p:cNvPr>
+            <p:cNvCxnSpPr/>
+            <p:nvPr/>
+          </p:nvCxnSpPr>
           <p:spPr>
             <a:xfrm>
-              <a:off x="6705116" y="2483047"/>
-              <a:ext cx="670618" cy="670618"/>
+              <a:off x="5943288" y="1961670"/>
+              <a:ext cx="565204" cy="0"/>
+            </a:xfrm>
+            <a:prstGeom prst="straightConnector1">
+              <a:avLst/>
+            </a:prstGeom>
+            <a:ln>
+              <a:solidFill>
+                <a:schemeClr val="accent1">
+                  <a:lumMod val="20000"/>
+                  <a:lumOff val="80000"/>
+                </a:schemeClr>
+              </a:solidFill>
+              <a:tailEnd type="triangle"/>
+            </a:ln>
+          </p:spPr>
+          <p:style>
+            <a:lnRef idx="2">
+              <a:schemeClr val="accent1"/>
+            </a:lnRef>
+            <a:fillRef idx="0">
+              <a:schemeClr val="accent1"/>
+            </a:fillRef>
+            <a:effectRef idx="1">
+              <a:schemeClr val="accent1"/>
+            </a:effectRef>
+            <a:fontRef idx="minor">
+              <a:schemeClr val="tx1"/>
+            </a:fontRef>
+          </p:style>
+        </p:cxnSp>
+        <p:cxnSp>
+          <p:nvCxnSpPr>
+            <p:cNvPr id="34" name="直線單箭頭接點 33">
+              <a:extLst>
+                <a:ext uri="{FF2B5EF4-FFF2-40B4-BE49-F238E27FC236}">
+                  <a16:creationId xmlns:a16="http://schemas.microsoft.com/office/drawing/2014/main" id="{5214CB30-B388-405F-B222-19049A4D92BF}"/>
+                </a:ext>
+              </a:extLst>
+            </p:cNvPr>
+            <p:cNvCxnSpPr>
+              <a:cxnSpLocks/>
+            </p:cNvCxnSpPr>
+            <p:nvPr/>
+          </p:nvCxnSpPr>
+          <p:spPr>
+            <a:xfrm flipV="1">
+              <a:off x="7233772" y="1136073"/>
+              <a:ext cx="931174" cy="337875"/>
+            </a:xfrm>
+            <a:prstGeom prst="straightConnector1">
+              <a:avLst/>
+            </a:prstGeom>
+            <a:ln>
+              <a:solidFill>
+                <a:schemeClr val="accent1">
+                  <a:lumMod val="20000"/>
+                  <a:lumOff val="80000"/>
+                </a:schemeClr>
+              </a:solidFill>
+              <a:tailEnd type="triangle"/>
+            </a:ln>
+          </p:spPr>
+          <p:style>
+            <a:lnRef idx="2">
+              <a:schemeClr val="accent1"/>
+            </a:lnRef>
+            <a:fillRef idx="0">
+              <a:schemeClr val="accent1"/>
+            </a:fillRef>
+            <a:effectRef idx="1">
+              <a:schemeClr val="accent1"/>
+            </a:effectRef>
+            <a:fontRef idx="minor">
+              <a:schemeClr val="tx1"/>
+            </a:fontRef>
+          </p:style>
+        </p:cxnSp>
+        <p:cxnSp>
+          <p:nvCxnSpPr>
+            <p:cNvPr id="36" name="直線單箭頭接點 35">
+              <a:extLst>
+                <a:ext uri="{FF2B5EF4-FFF2-40B4-BE49-F238E27FC236}">
+                  <a16:creationId xmlns:a16="http://schemas.microsoft.com/office/drawing/2014/main" id="{92DF8390-AC72-402B-A0FA-3FBD10D770CD}"/>
+                </a:ext>
+              </a:extLst>
+            </p:cNvPr>
+            <p:cNvCxnSpPr>
+              <a:cxnSpLocks/>
+            </p:cNvCxnSpPr>
+            <p:nvPr/>
+          </p:nvCxnSpPr>
+          <p:spPr>
+            <a:xfrm>
+              <a:off x="6845619" y="2493199"/>
+              <a:ext cx="1393193" cy="286947"/>
+            </a:xfrm>
+            <a:prstGeom prst="straightConnector1">
+              <a:avLst/>
+            </a:prstGeom>
+            <a:ln>
+              <a:solidFill>
+                <a:schemeClr val="accent1">
+                  <a:lumMod val="20000"/>
+                  <a:lumOff val="80000"/>
+                </a:schemeClr>
+              </a:solidFill>
+              <a:tailEnd type="triangle"/>
+            </a:ln>
+          </p:spPr>
+          <p:style>
+            <a:lnRef idx="2">
+              <a:schemeClr val="accent1"/>
+            </a:lnRef>
+            <a:fillRef idx="0">
+              <a:schemeClr val="accent1"/>
+            </a:fillRef>
+            <a:effectRef idx="1">
+              <a:schemeClr val="accent1"/>
+            </a:effectRef>
+            <a:fontRef idx="minor">
+              <a:schemeClr val="tx1"/>
+            </a:fontRef>
+          </p:style>
+        </p:cxnSp>
+        <p:cxnSp>
+          <p:nvCxnSpPr>
+            <p:cNvPr id="38" name="直線單箭頭接點 37">
+              <a:extLst>
+                <a:ext uri="{FF2B5EF4-FFF2-40B4-BE49-F238E27FC236}">
+                  <a16:creationId xmlns:a16="http://schemas.microsoft.com/office/drawing/2014/main" id="{A692F329-BDD2-4739-8249-BCB5BB407D8A}"/>
+                </a:ext>
+              </a:extLst>
+            </p:cNvPr>
+            <p:cNvCxnSpPr/>
+            <p:nvPr/>
+          </p:nvCxnSpPr>
+          <p:spPr>
+            <a:xfrm>
+              <a:off x="8404254" y="1136073"/>
+              <a:ext cx="454243" cy="519500"/>
+            </a:xfrm>
+            <a:prstGeom prst="straightConnector1">
+              <a:avLst/>
+            </a:prstGeom>
+            <a:ln>
+              <a:solidFill>
+                <a:schemeClr val="accent1">
+                  <a:lumMod val="20000"/>
+                  <a:lumOff val="80000"/>
+                </a:schemeClr>
+              </a:solidFill>
+              <a:tailEnd type="triangle"/>
+            </a:ln>
+          </p:spPr>
+          <p:style>
+            <a:lnRef idx="2">
+              <a:schemeClr val="accent1"/>
+            </a:lnRef>
+            <a:fillRef idx="0">
+              <a:schemeClr val="accent1"/>
+            </a:fillRef>
+            <a:effectRef idx="1">
+              <a:schemeClr val="accent1"/>
+            </a:effectRef>
+            <a:fontRef idx="minor">
+              <a:schemeClr val="tx1"/>
+            </a:fontRef>
+          </p:style>
+        </p:cxnSp>
+        <p:cxnSp>
+          <p:nvCxnSpPr>
+            <p:cNvPr id="40" name="直線單箭頭接點 39">
+              <a:extLst>
+                <a:ext uri="{FF2B5EF4-FFF2-40B4-BE49-F238E27FC236}">
+                  <a16:creationId xmlns:a16="http://schemas.microsoft.com/office/drawing/2014/main" id="{BA8DB398-918F-490A-AC29-8D0C01A0DED8}"/>
+                </a:ext>
+              </a:extLst>
+            </p:cNvPr>
+            <p:cNvCxnSpPr>
+              <a:cxnSpLocks/>
+            </p:cNvCxnSpPr>
+            <p:nvPr/>
+          </p:nvCxnSpPr>
+          <p:spPr>
+            <a:xfrm flipV="1">
+              <a:off x="8404254" y="2206252"/>
+              <a:ext cx="454243" cy="573894"/>
+            </a:xfrm>
+            <a:prstGeom prst="straightConnector1">
+              <a:avLst/>
+            </a:prstGeom>
+            <a:ln>
+              <a:solidFill>
+                <a:schemeClr val="accent1">
+                  <a:lumMod val="20000"/>
+                  <a:lumOff val="80000"/>
+                </a:schemeClr>
+              </a:solidFill>
+              <a:tailEnd type="triangle"/>
+            </a:ln>
+          </p:spPr>
+          <p:style>
+            <a:lnRef idx="2">
+              <a:schemeClr val="accent1"/>
+            </a:lnRef>
+            <a:fillRef idx="0">
+              <a:schemeClr val="accent1"/>
+            </a:fillRef>
+            <a:effectRef idx="1">
+              <a:schemeClr val="accent1"/>
+            </a:effectRef>
+            <a:fontRef idx="minor">
+              <a:schemeClr val="tx1"/>
+            </a:fontRef>
+          </p:style>
+        </p:cxnSp>
+        <p:cxnSp>
+          <p:nvCxnSpPr>
+            <p:cNvPr id="43" name="直線單箭頭接點 42">
+              <a:extLst>
+                <a:ext uri="{FF2B5EF4-FFF2-40B4-BE49-F238E27FC236}">
+                  <a16:creationId xmlns:a16="http://schemas.microsoft.com/office/drawing/2014/main" id="{7BBA1143-BD4E-4143-A71C-F2C0E5F7F4DC}"/>
+                </a:ext>
+              </a:extLst>
+            </p:cNvPr>
+            <p:cNvCxnSpPr/>
+            <p:nvPr/>
+          </p:nvCxnSpPr>
+          <p:spPr>
+            <a:xfrm>
+              <a:off x="9023103" y="1708858"/>
+              <a:ext cx="403062" cy="85306"/>
+            </a:xfrm>
+            <a:prstGeom prst="straightConnector1">
+              <a:avLst/>
+            </a:prstGeom>
+            <a:ln>
+              <a:solidFill>
+                <a:schemeClr val="accent1">
+                  <a:lumMod val="20000"/>
+                  <a:lumOff val="80000"/>
+                </a:schemeClr>
+              </a:solidFill>
+              <a:tailEnd type="triangle"/>
+            </a:ln>
+          </p:spPr>
+          <p:style>
+            <a:lnRef idx="2">
+              <a:schemeClr val="accent1"/>
+            </a:lnRef>
+            <a:fillRef idx="0">
+              <a:schemeClr val="accent1"/>
+            </a:fillRef>
+            <a:effectRef idx="1">
+              <a:schemeClr val="accent1"/>
+            </a:effectRef>
+            <a:fontRef idx="minor">
+              <a:schemeClr val="tx1"/>
+            </a:fontRef>
+          </p:style>
+        </p:cxnSp>
+        <p:cxnSp>
+          <p:nvCxnSpPr>
+            <p:cNvPr id="45" name="直線單箭頭接點 44">
+              <a:extLst>
+                <a:ext uri="{FF2B5EF4-FFF2-40B4-BE49-F238E27FC236}">
+                  <a16:creationId xmlns:a16="http://schemas.microsoft.com/office/drawing/2014/main" id="{A2627054-7607-469E-BD6E-3199A1697217}"/>
+                </a:ext>
+              </a:extLst>
+            </p:cNvPr>
+            <p:cNvCxnSpPr>
+              <a:cxnSpLocks/>
+            </p:cNvCxnSpPr>
+            <p:nvPr/>
+          </p:nvCxnSpPr>
+          <p:spPr>
+            <a:xfrm flipV="1">
+              <a:off x="9049842" y="2053838"/>
+              <a:ext cx="376323" cy="121129"/>
+            </a:xfrm>
+            <a:prstGeom prst="straightConnector1">
+              <a:avLst/>
+            </a:prstGeom>
+            <a:ln>
+              <a:solidFill>
+                <a:schemeClr val="accent1">
+                  <a:lumMod val="20000"/>
+                  <a:lumOff val="80000"/>
+                </a:schemeClr>
+              </a:solidFill>
+              <a:tailEnd type="triangle"/>
+            </a:ln>
+          </p:spPr>
+          <p:style>
+            <a:lnRef idx="2">
+              <a:schemeClr val="accent1"/>
+            </a:lnRef>
+            <a:fillRef idx="0">
+              <a:schemeClr val="accent1"/>
+            </a:fillRef>
+            <a:effectRef idx="1">
+              <a:schemeClr val="accent1"/>
+            </a:effectRef>
+            <a:fontRef idx="minor">
+              <a:schemeClr val="tx1"/>
+            </a:fontRef>
+          </p:style>
+        </p:cxnSp>
+        <p:cxnSp>
+          <p:nvCxnSpPr>
+            <p:cNvPr id="50" name="直線單箭頭接點 49">
+              <a:extLst>
+                <a:ext uri="{FF2B5EF4-FFF2-40B4-BE49-F238E27FC236}">
+                  <a16:creationId xmlns:a16="http://schemas.microsoft.com/office/drawing/2014/main" id="{EDAAC9F9-CDFD-4958-8514-E4FADD87582A}"/>
+                </a:ext>
+              </a:extLst>
+            </p:cNvPr>
+            <p:cNvCxnSpPr/>
+            <p:nvPr/>
+          </p:nvCxnSpPr>
+          <p:spPr>
+            <a:xfrm>
+              <a:off x="7463304" y="1961670"/>
+              <a:ext cx="701642" cy="0"/>
+            </a:xfrm>
+            <a:prstGeom prst="straightConnector1">
+              <a:avLst/>
+            </a:prstGeom>
+            <a:ln>
+              <a:solidFill>
+                <a:schemeClr val="accent1">
+                  <a:lumMod val="20000"/>
+                  <a:lumOff val="80000"/>
+                </a:schemeClr>
+              </a:solidFill>
+              <a:tailEnd type="triangle"/>
+            </a:ln>
+          </p:spPr>
+          <p:style>
+            <a:lnRef idx="2">
+              <a:schemeClr val="accent1"/>
+            </a:lnRef>
+            <a:fillRef idx="0">
+              <a:schemeClr val="accent1"/>
+            </a:fillRef>
+            <a:effectRef idx="1">
+              <a:schemeClr val="accent1"/>
+            </a:effectRef>
+            <a:fontRef idx="minor">
+              <a:schemeClr val="tx1"/>
+            </a:fontRef>
+          </p:style>
+        </p:cxnSp>
+        <p:cxnSp>
+          <p:nvCxnSpPr>
+            <p:cNvPr id="52" name="直線接點 51">
+              <a:extLst>
+                <a:ext uri="{FF2B5EF4-FFF2-40B4-BE49-F238E27FC236}">
+                  <a16:creationId xmlns:a16="http://schemas.microsoft.com/office/drawing/2014/main" id="{4B50FD37-6118-46DB-809D-4310DA977521}"/>
+                </a:ext>
+              </a:extLst>
+            </p:cNvPr>
+            <p:cNvCxnSpPr/>
+            <p:nvPr/>
+          </p:nvCxnSpPr>
+          <p:spPr>
+            <a:xfrm>
+              <a:off x="8321951" y="1762351"/>
+              <a:ext cx="0" cy="323273"/>
+            </a:xfrm>
+            <a:prstGeom prst="line">
+              <a:avLst/>
+            </a:prstGeom>
+            <a:ln>
+              <a:solidFill>
+                <a:schemeClr val="bg2"/>
+              </a:solidFill>
+              <a:prstDash val="sysDash"/>
+            </a:ln>
+          </p:spPr>
+          <p:style>
+            <a:lnRef idx="2">
+              <a:schemeClr val="accent1"/>
+            </a:lnRef>
+            <a:fillRef idx="0">
+              <a:schemeClr val="accent1"/>
+            </a:fillRef>
+            <a:effectRef idx="1">
+              <a:schemeClr val="accent1"/>
+            </a:effectRef>
+            <a:fontRef idx="minor">
+              <a:schemeClr val="tx1"/>
+            </a:fontRef>
+          </p:style>
+        </p:cxnSp>
+        <p:cxnSp>
+          <p:nvCxnSpPr>
+            <p:cNvPr id="55" name="直線接點 54">
+              <a:extLst>
+                <a:ext uri="{FF2B5EF4-FFF2-40B4-BE49-F238E27FC236}">
+                  <a16:creationId xmlns:a16="http://schemas.microsoft.com/office/drawing/2014/main" id="{55125779-A9DA-4EF8-92A8-B3990C505561}"/>
+                </a:ext>
+              </a:extLst>
+            </p:cNvPr>
+            <p:cNvCxnSpPr>
+              <a:cxnSpLocks/>
+            </p:cNvCxnSpPr>
+            <p:nvPr/>
+          </p:nvCxnSpPr>
+          <p:spPr>
+            <a:xfrm flipH="1">
+              <a:off x="8631375" y="1556892"/>
+              <a:ext cx="4605" cy="697786"/>
+            </a:xfrm>
+            <a:prstGeom prst="line">
+              <a:avLst/>
+            </a:prstGeom>
+            <a:ln>
+              <a:solidFill>
+                <a:schemeClr val="accent1">
+                  <a:lumMod val="20000"/>
+                  <a:lumOff val="80000"/>
+                </a:schemeClr>
+              </a:solidFill>
+              <a:prstDash val="sysDash"/>
+            </a:ln>
+          </p:spPr>
+          <p:style>
+            <a:lnRef idx="2">
+              <a:schemeClr val="accent1"/>
+            </a:lnRef>
+            <a:fillRef idx="0">
+              <a:schemeClr val="accent1"/>
+            </a:fillRef>
+            <a:effectRef idx="1">
+              <a:schemeClr val="accent1"/>
+            </a:effectRef>
+            <a:fontRef idx="minor">
+              <a:schemeClr val="tx1"/>
+            </a:fontRef>
+          </p:style>
+        </p:cxnSp>
+        <p:cxnSp>
+          <p:nvCxnSpPr>
+            <p:cNvPr id="58" name="直線接點 57">
+              <a:extLst>
+                <a:ext uri="{FF2B5EF4-FFF2-40B4-BE49-F238E27FC236}">
+                  <a16:creationId xmlns:a16="http://schemas.microsoft.com/office/drawing/2014/main" id="{909104CF-AC02-48BA-B218-344963BFB7DA}"/>
+                </a:ext>
+              </a:extLst>
+            </p:cNvPr>
+            <p:cNvCxnSpPr>
+              <a:cxnSpLocks/>
+            </p:cNvCxnSpPr>
+            <p:nvPr/>
+          </p:nvCxnSpPr>
+          <p:spPr>
+            <a:xfrm>
+              <a:off x="9224634" y="1816391"/>
+              <a:ext cx="0" cy="223715"/>
+            </a:xfrm>
+            <a:prstGeom prst="line">
+              <a:avLst/>
+            </a:prstGeom>
+            <a:ln>
+              <a:solidFill>
+                <a:schemeClr val="accent1">
+                  <a:lumMod val="20000"/>
+                  <a:lumOff val="80000"/>
+                </a:schemeClr>
+              </a:solidFill>
+              <a:prstDash val="sysDash"/>
+            </a:ln>
+          </p:spPr>
+          <p:style>
+            <a:lnRef idx="2">
+              <a:schemeClr val="accent1"/>
+            </a:lnRef>
+            <a:fillRef idx="0">
+              <a:schemeClr val="accent1"/>
+            </a:fillRef>
+            <a:effectRef idx="1">
+              <a:schemeClr val="accent1"/>
+            </a:effectRef>
+            <a:fontRef idx="minor">
+              <a:schemeClr val="tx1"/>
+            </a:fontRef>
+          </p:style>
+        </p:cxnSp>
+        <p:sp>
+          <p:nvSpPr>
+            <p:cNvPr id="60" name="矩形 59">
+              <a:extLst>
+                <a:ext uri="{FF2B5EF4-FFF2-40B4-BE49-F238E27FC236}">
+                  <a16:creationId xmlns:a16="http://schemas.microsoft.com/office/drawing/2014/main" id="{8999171D-1D72-4928-A13A-ED1449677D37}"/>
+                </a:ext>
+              </a:extLst>
+            </p:cNvPr>
+            <p:cNvSpPr/>
+            <p:nvPr/>
+          </p:nvSpPr>
+          <p:spPr>
+            <a:xfrm>
+              <a:off x="3663292" y="1631725"/>
+              <a:ext cx="652102" cy="369332"/>
             </a:xfrm>
             <a:prstGeom prst="rect">
               <a:avLst/>
             </a:prstGeom>
           </p:spPr>
-        </p:pic>
-        <p:pic>
-          <p:nvPicPr>
-            <p:cNvPr id="20" name="圖片 19">
-              <a:extLst>
-                <a:ext uri="{FF2B5EF4-FFF2-40B4-BE49-F238E27FC236}">
-                  <a16:creationId xmlns:a16="http://schemas.microsoft.com/office/drawing/2014/main" id="{869B156A-B2EE-46C7-9329-00ABEFC237F2}"/>
-                </a:ext>
-              </a:extLst>
-            </p:cNvPr>
-            <p:cNvPicPr>
-              <a:picLocks noChangeAspect="1"/>
-            </p:cNvPicPr>
-            <p:nvPr/>
-          </p:nvPicPr>
-          <p:blipFill>
-            <a:blip r:embed="rId5"/>
-            <a:stretch>
-              <a:fillRect/>
-            </a:stretch>
-          </p:blipFill>
+          <p:txBody>
+            <a:bodyPr wrap="none">
+              <a:spAutoFit/>
+            </a:bodyPr>
+            <a:lstStyle/>
+            <a:p>
+              <a:r>
+                <a:rPr lang="en-US" altLang="zh-HK" dirty="0"/>
+                <a:t>Conv</a:t>
+              </a:r>
+              <a:endParaRPr lang="zh-HK" altLang="en-US" dirty="0"/>
+            </a:p>
+          </p:txBody>
+        </p:sp>
+        <p:sp>
+          <p:nvSpPr>
+            <p:cNvPr id="61" name="矩形 60">
+              <a:extLst>
+                <a:ext uri="{FF2B5EF4-FFF2-40B4-BE49-F238E27FC236}">
+                  <a16:creationId xmlns:a16="http://schemas.microsoft.com/office/drawing/2014/main" id="{C4177E60-FF9A-4D56-9CC1-D588C4CD3168}"/>
+                </a:ext>
+              </a:extLst>
+            </p:cNvPr>
+            <p:cNvSpPr/>
+            <p:nvPr/>
+          </p:nvSpPr>
           <p:spPr>
             <a:xfrm>
-              <a:off x="6779006" y="2543307"/>
-              <a:ext cx="670618" cy="670618"/>
+              <a:off x="5867481" y="1647427"/>
+              <a:ext cx="595228" cy="369332"/>
             </a:xfrm>
             <a:prstGeom prst="rect">
               <a:avLst/>
             </a:prstGeom>
           </p:spPr>
-        </p:pic>
-        <p:pic>
-          <p:nvPicPr>
-            <p:cNvPr id="21" name="圖片 20">
-              <a:extLst>
-                <a:ext uri="{FF2B5EF4-FFF2-40B4-BE49-F238E27FC236}">
-                  <a16:creationId xmlns:a16="http://schemas.microsoft.com/office/drawing/2014/main" id="{DF11FD97-F2B3-48A8-A0D9-A61EE5C7E507}"/>
-                </a:ext>
-              </a:extLst>
-            </p:cNvPr>
-            <p:cNvPicPr>
-              <a:picLocks noChangeAspect="1"/>
-            </p:cNvPicPr>
-            <p:nvPr/>
-          </p:nvPicPr>
-          <p:blipFill>
-            <a:blip r:embed="rId5"/>
-            <a:stretch>
-              <a:fillRect/>
-            </a:stretch>
-          </p:blipFill>
+          <p:txBody>
+            <a:bodyPr wrap="none">
+              <a:spAutoFit/>
+            </a:bodyPr>
+            <a:lstStyle/>
+            <a:p>
+              <a:r>
+                <a:rPr lang="en-US" altLang="zh-HK" dirty="0"/>
+                <a:t>Pool</a:t>
+              </a:r>
+              <a:endParaRPr lang="zh-HK" altLang="en-US" dirty="0"/>
+            </a:p>
+          </p:txBody>
+        </p:sp>
+        <p:sp>
+          <p:nvSpPr>
+            <p:cNvPr id="62" name="矩形 61">
+              <a:extLst>
+                <a:ext uri="{FF2B5EF4-FFF2-40B4-BE49-F238E27FC236}">
+                  <a16:creationId xmlns:a16="http://schemas.microsoft.com/office/drawing/2014/main" id="{B611DBAE-DFCB-43B7-8590-2C8B19B7187D}"/>
+                </a:ext>
+              </a:extLst>
+            </p:cNvPr>
+            <p:cNvSpPr/>
+            <p:nvPr/>
+          </p:nvSpPr>
           <p:spPr>
             <a:xfrm>
-              <a:off x="6852896" y="2606263"/>
-              <a:ext cx="670618" cy="670618"/>
+              <a:off x="7392664" y="1647427"/>
+              <a:ext cx="837217" cy="369332"/>
             </a:xfrm>
             <a:prstGeom prst="rect">
               <a:avLst/>
             </a:prstGeom>
           </p:spPr>
-        </p:pic>
-        <p:pic>
-          <p:nvPicPr>
-            <p:cNvPr id="22" name="圖片 21">
-              <a:extLst>
-                <a:ext uri="{FF2B5EF4-FFF2-40B4-BE49-F238E27FC236}">
-                  <a16:creationId xmlns:a16="http://schemas.microsoft.com/office/drawing/2014/main" id="{B295639C-F4F7-473F-91CD-F672D6A85391}"/>
-                </a:ext>
-              </a:extLst>
-            </p:cNvPr>
-            <p:cNvPicPr>
-              <a:picLocks noChangeAspect="1"/>
-            </p:cNvPicPr>
-            <p:nvPr/>
-          </p:nvPicPr>
-          <p:blipFill>
-            <a:blip r:embed="rId5"/>
-            <a:stretch>
-              <a:fillRect/>
-            </a:stretch>
-          </p:blipFill>
+          <p:txBody>
+            <a:bodyPr wrap="none">
+              <a:spAutoFit/>
+            </a:bodyPr>
+            <a:lstStyle/>
+            <a:p>
+              <a:r>
+                <a:rPr lang="en-US" altLang="zh-HK" dirty="0"/>
+                <a:t>Flatten</a:t>
+              </a:r>
+              <a:endParaRPr lang="zh-HK" altLang="en-US" dirty="0"/>
+            </a:p>
+          </p:txBody>
+        </p:sp>
+        <p:sp>
+          <p:nvSpPr>
+            <p:cNvPr id="63" name="矩形 62">
+              <a:extLst>
+                <a:ext uri="{FF2B5EF4-FFF2-40B4-BE49-F238E27FC236}">
+                  <a16:creationId xmlns:a16="http://schemas.microsoft.com/office/drawing/2014/main" id="{00DAABA6-A061-4621-B471-03582849849B}"/>
+                </a:ext>
+              </a:extLst>
+            </p:cNvPr>
+            <p:cNvSpPr/>
+            <p:nvPr/>
+          </p:nvSpPr>
           <p:spPr>
             <a:xfrm>
-              <a:off x="6926786" y="2669219"/>
-              <a:ext cx="670618" cy="670618"/>
+              <a:off x="8940800" y="1214728"/>
+              <a:ext cx="587020" cy="369332"/>
             </a:xfrm>
             <a:prstGeom prst="rect">
               <a:avLst/>
             </a:prstGeom>
           </p:spPr>
-        </p:pic>
+          <p:txBody>
+            <a:bodyPr wrap="none">
+              <a:spAutoFit/>
+            </a:bodyPr>
+            <a:lstStyle/>
+            <a:p>
+              <a:r>
+                <a:rPr lang="en-US" altLang="zh-HK" dirty="0"/>
+                <a:t>fully</a:t>
+              </a:r>
+              <a:endParaRPr lang="zh-HK" altLang="en-US" dirty="0"/>
+            </a:p>
+          </p:txBody>
+        </p:sp>
+        <p:sp>
+          <p:nvSpPr>
+            <p:cNvPr id="64" name="矩形 63">
+              <a:extLst>
+                <a:ext uri="{FF2B5EF4-FFF2-40B4-BE49-F238E27FC236}">
+                  <a16:creationId xmlns:a16="http://schemas.microsoft.com/office/drawing/2014/main" id="{2E8E738F-70A4-47DC-99BE-30E1C345C15E}"/>
+                </a:ext>
+              </a:extLst>
+            </p:cNvPr>
+            <p:cNvSpPr/>
+            <p:nvPr/>
+          </p:nvSpPr>
+          <p:spPr>
+            <a:xfrm>
+              <a:off x="8639185" y="2325609"/>
+              <a:ext cx="1170898" cy="369332"/>
+            </a:xfrm>
+            <a:prstGeom prst="rect">
+              <a:avLst/>
+            </a:prstGeom>
+          </p:spPr>
+          <p:txBody>
+            <a:bodyPr wrap="none">
+              <a:spAutoFit/>
+            </a:bodyPr>
+            <a:lstStyle/>
+            <a:p>
+              <a:r>
+                <a:rPr lang="en-US" altLang="zh-HK" dirty="0"/>
+                <a:t>connected</a:t>
+              </a:r>
+              <a:endParaRPr lang="zh-HK" altLang="en-US" dirty="0"/>
+            </a:p>
+          </p:txBody>
+        </p:sp>
       </p:grpSp>
-      <p:pic>
-        <p:nvPicPr>
-          <p:cNvPr id="25" name="圖片 24">
-            <a:extLst>
-              <a:ext uri="{FF2B5EF4-FFF2-40B4-BE49-F238E27FC236}">
-                <a16:creationId xmlns:a16="http://schemas.microsoft.com/office/drawing/2014/main" id="{4FF51D5A-1568-4717-9F95-759F375F2B37}"/>
-              </a:ext>
-            </a:extLst>
-          </p:cNvPr>
-          <p:cNvPicPr>
-            <a:picLocks noChangeAspect="1"/>
-          </p:cNvPicPr>
-          <p:nvPr/>
-        </p:nvPicPr>
-        <p:blipFill rotWithShape="1">
-          <a:blip r:embed="rId5"/>
-          <a:srcRect l="-1" r="75206"/>
-          <a:stretch/>
-        </p:blipFill>
-        <p:spPr>
-          <a:xfrm>
-            <a:off x="8238812" y="1038240"/>
-            <a:ext cx="166279" cy="670618"/>
-          </a:xfrm>
-          <a:prstGeom prst="rect">
-            <a:avLst/>
-          </a:prstGeom>
-        </p:spPr>
-      </p:pic>
-      <p:pic>
-        <p:nvPicPr>
-          <p:cNvPr id="26" name="圖片 25">
-            <a:extLst>
-              <a:ext uri="{FF2B5EF4-FFF2-40B4-BE49-F238E27FC236}">
-                <a16:creationId xmlns:a16="http://schemas.microsoft.com/office/drawing/2014/main" id="{0021B9F1-9128-450E-A3B8-A1DCCA3B9378}"/>
-              </a:ext>
-            </a:extLst>
-          </p:cNvPr>
-          <p:cNvPicPr>
-            <a:picLocks noChangeAspect="1"/>
-          </p:cNvPicPr>
-          <p:nvPr/>
-        </p:nvPicPr>
-        <p:blipFill>
-          <a:blip r:embed="rId6"/>
-          <a:stretch>
-            <a:fillRect/>
-          </a:stretch>
-        </p:blipFill>
-        <p:spPr>
-          <a:xfrm>
-            <a:off x="8239648" y="2174966"/>
-            <a:ext cx="164606" cy="670618"/>
-          </a:xfrm>
-          <a:prstGeom prst="rect">
-            <a:avLst/>
-          </a:prstGeom>
-        </p:spPr>
-      </p:pic>
-      <p:pic>
-        <p:nvPicPr>
-          <p:cNvPr id="27" name="圖片 26">
-            <a:extLst>
-              <a:ext uri="{FF2B5EF4-FFF2-40B4-BE49-F238E27FC236}">
-                <a16:creationId xmlns:a16="http://schemas.microsoft.com/office/drawing/2014/main" id="{5026C78D-450B-4131-9EA1-39CC3E5EF6A9}"/>
-              </a:ext>
-            </a:extLst>
-          </p:cNvPr>
-          <p:cNvPicPr>
-            <a:picLocks noChangeAspect="1"/>
-          </p:cNvPicPr>
-          <p:nvPr/>
-        </p:nvPicPr>
-        <p:blipFill>
-          <a:blip r:embed="rId6"/>
-          <a:stretch>
-            <a:fillRect/>
-          </a:stretch>
-        </p:blipFill>
-        <p:spPr>
-          <a:xfrm>
-            <a:off x="8858497" y="1584060"/>
-            <a:ext cx="164606" cy="670618"/>
-          </a:xfrm>
-          <a:prstGeom prst="rect">
-            <a:avLst/>
-          </a:prstGeom>
-        </p:spPr>
-      </p:pic>
-      <p:pic>
-        <p:nvPicPr>
-          <p:cNvPr id="28" name="圖片 27">
-            <a:extLst>
-              <a:ext uri="{FF2B5EF4-FFF2-40B4-BE49-F238E27FC236}">
-                <a16:creationId xmlns:a16="http://schemas.microsoft.com/office/drawing/2014/main" id="{B9555DB1-3FC6-4E92-911F-32126E949EDF}"/>
-              </a:ext>
-            </a:extLst>
-          </p:cNvPr>
-          <p:cNvPicPr>
-            <a:picLocks noChangeAspect="1"/>
-          </p:cNvPicPr>
-          <p:nvPr/>
-        </p:nvPicPr>
-        <p:blipFill rotWithShape="1">
-          <a:blip r:embed="rId6"/>
-          <a:srcRect b="48355"/>
-          <a:stretch/>
-        </p:blipFill>
-        <p:spPr>
-          <a:xfrm>
-            <a:off x="9426165" y="1757451"/>
-            <a:ext cx="164606" cy="346341"/>
-          </a:xfrm>
-          <a:prstGeom prst="rect">
-            <a:avLst/>
-          </a:prstGeom>
-        </p:spPr>
-      </p:pic>
-      <p:cxnSp>
-        <p:nvCxnSpPr>
-          <p:cNvPr id="30" name="直線單箭頭接點 29">
-            <a:extLst>
-              <a:ext uri="{FF2B5EF4-FFF2-40B4-BE49-F238E27FC236}">
-                <a16:creationId xmlns:a16="http://schemas.microsoft.com/office/drawing/2014/main" id="{6943ACD9-CCAB-49C0-8379-1D9F1C63BD5E}"/>
-              </a:ext>
-            </a:extLst>
-          </p:cNvPr>
-          <p:cNvCxnSpPr>
-            <a:cxnSpLocks/>
-            <a:stCxn id="9" idx="3"/>
-          </p:cNvCxnSpPr>
-          <p:nvPr/>
-        </p:nvCxnSpPr>
-        <p:spPr>
-          <a:xfrm flipV="1">
-            <a:off x="3638989" y="1961670"/>
-            <a:ext cx="779677" cy="2"/>
-          </a:xfrm>
-          <a:prstGeom prst="straightConnector1">
-            <a:avLst/>
-          </a:prstGeom>
-          <a:ln>
-            <a:solidFill>
-              <a:schemeClr val="accent1">
-                <a:lumMod val="20000"/>
-                <a:lumOff val="80000"/>
-              </a:schemeClr>
-            </a:solidFill>
-            <a:tailEnd type="triangle"/>
-          </a:ln>
-        </p:spPr>
-        <p:style>
-          <a:lnRef idx="2">
-            <a:schemeClr val="accent1"/>
-          </a:lnRef>
-          <a:fillRef idx="0">
-            <a:schemeClr val="accent1"/>
-          </a:fillRef>
-          <a:effectRef idx="1">
-            <a:schemeClr val="accent1"/>
-          </a:effectRef>
-          <a:fontRef idx="minor">
-            <a:schemeClr val="tx1"/>
-          </a:fontRef>
-        </p:style>
-      </p:cxnSp>
-      <p:cxnSp>
-        <p:nvCxnSpPr>
-          <p:cNvPr id="32" name="直線單箭頭接點 31">
-            <a:extLst>
-              <a:ext uri="{FF2B5EF4-FFF2-40B4-BE49-F238E27FC236}">
-                <a16:creationId xmlns:a16="http://schemas.microsoft.com/office/drawing/2014/main" id="{76D55E2E-2E9D-45DA-A4B5-258D1A6E663B}"/>
-              </a:ext>
-            </a:extLst>
-          </p:cNvPr>
-          <p:cNvCxnSpPr/>
-          <p:nvPr/>
-        </p:nvCxnSpPr>
-        <p:spPr>
-          <a:xfrm>
-            <a:off x="5943288" y="1961670"/>
-            <a:ext cx="565204" cy="0"/>
-          </a:xfrm>
-          <a:prstGeom prst="straightConnector1">
-            <a:avLst/>
-          </a:prstGeom>
-          <a:ln>
-            <a:solidFill>
-              <a:schemeClr val="accent1">
-                <a:lumMod val="20000"/>
-                <a:lumOff val="80000"/>
-              </a:schemeClr>
-            </a:solidFill>
-            <a:tailEnd type="triangle"/>
-          </a:ln>
-        </p:spPr>
-        <p:style>
-          <a:lnRef idx="2">
-            <a:schemeClr val="accent1"/>
-          </a:lnRef>
-          <a:fillRef idx="0">
-            <a:schemeClr val="accent1"/>
-          </a:fillRef>
-          <a:effectRef idx="1">
-            <a:schemeClr val="accent1"/>
-          </a:effectRef>
-          <a:fontRef idx="minor">
-            <a:schemeClr val="tx1"/>
-          </a:fontRef>
-        </p:style>
-      </p:cxnSp>
-      <p:cxnSp>
-        <p:nvCxnSpPr>
-          <p:cNvPr id="34" name="直線單箭頭接點 33">
-            <a:extLst>
-              <a:ext uri="{FF2B5EF4-FFF2-40B4-BE49-F238E27FC236}">
-                <a16:creationId xmlns:a16="http://schemas.microsoft.com/office/drawing/2014/main" id="{5214CB30-B388-405F-B222-19049A4D92BF}"/>
-              </a:ext>
-            </a:extLst>
-          </p:cNvPr>
-          <p:cNvCxnSpPr>
-            <a:cxnSpLocks/>
-          </p:cNvCxnSpPr>
-          <p:nvPr/>
-        </p:nvCxnSpPr>
-        <p:spPr>
-          <a:xfrm flipV="1">
-            <a:off x="7233772" y="1136073"/>
-            <a:ext cx="931174" cy="337875"/>
-          </a:xfrm>
-          <a:prstGeom prst="straightConnector1">
-            <a:avLst/>
-          </a:prstGeom>
-          <a:ln>
-            <a:solidFill>
-              <a:schemeClr val="accent1">
-                <a:lumMod val="20000"/>
-                <a:lumOff val="80000"/>
-              </a:schemeClr>
-            </a:solidFill>
-            <a:tailEnd type="triangle"/>
-          </a:ln>
-        </p:spPr>
-        <p:style>
-          <a:lnRef idx="2">
-            <a:schemeClr val="accent1"/>
-          </a:lnRef>
-          <a:fillRef idx="0">
-            <a:schemeClr val="accent1"/>
-          </a:fillRef>
-          <a:effectRef idx="1">
-            <a:schemeClr val="accent1"/>
-          </a:effectRef>
-          <a:fontRef idx="minor">
-            <a:schemeClr val="tx1"/>
-          </a:fontRef>
-        </p:style>
-      </p:cxnSp>
-      <p:cxnSp>
-        <p:nvCxnSpPr>
-          <p:cNvPr id="36" name="直線單箭頭接點 35">
-            <a:extLst>
-              <a:ext uri="{FF2B5EF4-FFF2-40B4-BE49-F238E27FC236}">
-                <a16:creationId xmlns:a16="http://schemas.microsoft.com/office/drawing/2014/main" id="{92DF8390-AC72-402B-A0FA-3FBD10D770CD}"/>
-              </a:ext>
-            </a:extLst>
-          </p:cNvPr>
-          <p:cNvCxnSpPr>
-            <a:cxnSpLocks/>
-          </p:cNvCxnSpPr>
-          <p:nvPr/>
-        </p:nvCxnSpPr>
-        <p:spPr>
-          <a:xfrm>
-            <a:off x="6845619" y="2493199"/>
-            <a:ext cx="1393193" cy="286947"/>
-          </a:xfrm>
-          <a:prstGeom prst="straightConnector1">
-            <a:avLst/>
-          </a:prstGeom>
-          <a:ln>
-            <a:solidFill>
-              <a:schemeClr val="accent1">
-                <a:lumMod val="20000"/>
-                <a:lumOff val="80000"/>
-              </a:schemeClr>
-            </a:solidFill>
-            <a:tailEnd type="triangle"/>
-          </a:ln>
-        </p:spPr>
-        <p:style>
-          <a:lnRef idx="2">
-            <a:schemeClr val="accent1"/>
-          </a:lnRef>
-          <a:fillRef idx="0">
-            <a:schemeClr val="accent1"/>
-          </a:fillRef>
-          <a:effectRef idx="1">
-            <a:schemeClr val="accent1"/>
-          </a:effectRef>
-          <a:fontRef idx="minor">
-            <a:schemeClr val="tx1"/>
-          </a:fontRef>
-        </p:style>
-      </p:cxnSp>
-      <p:cxnSp>
-        <p:nvCxnSpPr>
-          <p:cNvPr id="38" name="直線單箭頭接點 37">
-            <a:extLst>
-              <a:ext uri="{FF2B5EF4-FFF2-40B4-BE49-F238E27FC236}">
-                <a16:creationId xmlns:a16="http://schemas.microsoft.com/office/drawing/2014/main" id="{A692F329-BDD2-4739-8249-BCB5BB407D8A}"/>
-              </a:ext>
-            </a:extLst>
-          </p:cNvPr>
-          <p:cNvCxnSpPr/>
-          <p:nvPr/>
-        </p:nvCxnSpPr>
-        <p:spPr>
-          <a:xfrm>
-            <a:off x="8404254" y="1136073"/>
-            <a:ext cx="454243" cy="519500"/>
-          </a:xfrm>
-          <a:prstGeom prst="straightConnector1">
-            <a:avLst/>
-          </a:prstGeom>
-          <a:ln>
-            <a:solidFill>
-              <a:schemeClr val="accent1">
-                <a:lumMod val="20000"/>
-                <a:lumOff val="80000"/>
-              </a:schemeClr>
-            </a:solidFill>
-            <a:tailEnd type="triangle"/>
-          </a:ln>
-        </p:spPr>
-        <p:style>
-          <a:lnRef idx="2">
-            <a:schemeClr val="accent1"/>
-          </a:lnRef>
-          <a:fillRef idx="0">
-            <a:schemeClr val="accent1"/>
-          </a:fillRef>
-          <a:effectRef idx="1">
-            <a:schemeClr val="accent1"/>
-          </a:effectRef>
-          <a:fontRef idx="minor">
-            <a:schemeClr val="tx1"/>
-          </a:fontRef>
-        </p:style>
-      </p:cxnSp>
-      <p:cxnSp>
-        <p:nvCxnSpPr>
-          <p:cNvPr id="40" name="直線單箭頭接點 39">
-            <a:extLst>
-              <a:ext uri="{FF2B5EF4-FFF2-40B4-BE49-F238E27FC236}">
-                <a16:creationId xmlns:a16="http://schemas.microsoft.com/office/drawing/2014/main" id="{BA8DB398-918F-490A-AC29-8D0C01A0DED8}"/>
-              </a:ext>
-            </a:extLst>
-          </p:cNvPr>
-          <p:cNvCxnSpPr>
-            <a:cxnSpLocks/>
-          </p:cNvCxnSpPr>
-          <p:nvPr/>
-        </p:nvCxnSpPr>
-        <p:spPr>
-          <a:xfrm flipV="1">
-            <a:off x="8404254" y="2206252"/>
-            <a:ext cx="454243" cy="573894"/>
-          </a:xfrm>
-          <a:prstGeom prst="straightConnector1">
-            <a:avLst/>
-          </a:prstGeom>
-          <a:ln>
-            <a:solidFill>
-              <a:schemeClr val="accent1">
-                <a:lumMod val="20000"/>
-                <a:lumOff val="80000"/>
-              </a:schemeClr>
-            </a:solidFill>
-            <a:tailEnd type="triangle"/>
-          </a:ln>
-        </p:spPr>
-        <p:style>
-          <a:lnRef idx="2">
-            <a:schemeClr val="accent1"/>
-          </a:lnRef>
-          <a:fillRef idx="0">
-            <a:schemeClr val="accent1"/>
-          </a:fillRef>
-          <a:effectRef idx="1">
-            <a:schemeClr val="accent1"/>
-          </a:effectRef>
-          <a:fontRef idx="minor">
-            <a:schemeClr val="tx1"/>
-          </a:fontRef>
-        </p:style>
-      </p:cxnSp>
-      <p:cxnSp>
-        <p:nvCxnSpPr>
-          <p:cNvPr id="43" name="直線單箭頭接點 42">
-            <a:extLst>
-              <a:ext uri="{FF2B5EF4-FFF2-40B4-BE49-F238E27FC236}">
-                <a16:creationId xmlns:a16="http://schemas.microsoft.com/office/drawing/2014/main" id="{7BBA1143-BD4E-4143-A71C-F2C0E5F7F4DC}"/>
-              </a:ext>
-            </a:extLst>
-          </p:cNvPr>
-          <p:cNvCxnSpPr/>
-          <p:nvPr/>
-        </p:nvCxnSpPr>
-        <p:spPr>
-          <a:xfrm>
-            <a:off x="9023103" y="1708858"/>
-            <a:ext cx="403062" cy="85306"/>
-          </a:xfrm>
-          <a:prstGeom prst="straightConnector1">
-            <a:avLst/>
-          </a:prstGeom>
-          <a:ln>
-            <a:solidFill>
-              <a:schemeClr val="accent1">
-                <a:lumMod val="20000"/>
-                <a:lumOff val="80000"/>
-              </a:schemeClr>
-            </a:solidFill>
-            <a:tailEnd type="triangle"/>
-          </a:ln>
-        </p:spPr>
-        <p:style>
-          <a:lnRef idx="2">
-            <a:schemeClr val="accent1"/>
-          </a:lnRef>
-          <a:fillRef idx="0">
-            <a:schemeClr val="accent1"/>
-          </a:fillRef>
-          <a:effectRef idx="1">
-            <a:schemeClr val="accent1"/>
-          </a:effectRef>
-          <a:fontRef idx="minor">
-            <a:schemeClr val="tx1"/>
-          </a:fontRef>
-        </p:style>
-      </p:cxnSp>
-      <p:cxnSp>
-        <p:nvCxnSpPr>
-          <p:cNvPr id="45" name="直線單箭頭接點 44">
-            <a:extLst>
-              <a:ext uri="{FF2B5EF4-FFF2-40B4-BE49-F238E27FC236}">
-                <a16:creationId xmlns:a16="http://schemas.microsoft.com/office/drawing/2014/main" id="{A2627054-7607-469E-BD6E-3199A1697217}"/>
-              </a:ext>
-            </a:extLst>
-          </p:cNvPr>
-          <p:cNvCxnSpPr>
-            <a:cxnSpLocks/>
-          </p:cNvCxnSpPr>
-          <p:nvPr/>
-        </p:nvCxnSpPr>
-        <p:spPr>
-          <a:xfrm flipV="1">
-            <a:off x="9049842" y="2053838"/>
-            <a:ext cx="376323" cy="121129"/>
-          </a:xfrm>
-          <a:prstGeom prst="straightConnector1">
-            <a:avLst/>
-          </a:prstGeom>
-          <a:ln>
-            <a:solidFill>
-              <a:schemeClr val="accent1">
-                <a:lumMod val="20000"/>
-                <a:lumOff val="80000"/>
-              </a:schemeClr>
-            </a:solidFill>
-            <a:tailEnd type="triangle"/>
-          </a:ln>
-        </p:spPr>
-        <p:style>
-          <a:lnRef idx="2">
-            <a:schemeClr val="accent1"/>
-          </a:lnRef>
-          <a:fillRef idx="0">
-            <a:schemeClr val="accent1"/>
-          </a:fillRef>
-          <a:effectRef idx="1">
-            <a:schemeClr val="accent1"/>
-          </a:effectRef>
-          <a:fontRef idx="minor">
-            <a:schemeClr val="tx1"/>
-          </a:fontRef>
-        </p:style>
-      </p:cxnSp>
-      <p:cxnSp>
-        <p:nvCxnSpPr>
-          <p:cNvPr id="50" name="直線單箭頭接點 49">
-            <a:extLst>
-              <a:ext uri="{FF2B5EF4-FFF2-40B4-BE49-F238E27FC236}">
-                <a16:creationId xmlns:a16="http://schemas.microsoft.com/office/drawing/2014/main" id="{EDAAC9F9-CDFD-4958-8514-E4FADD87582A}"/>
-              </a:ext>
-            </a:extLst>
-          </p:cNvPr>
-          <p:cNvCxnSpPr/>
-          <p:nvPr/>
-        </p:nvCxnSpPr>
-        <p:spPr>
-          <a:xfrm>
-            <a:off x="7463304" y="1961670"/>
-            <a:ext cx="701642" cy="0"/>
-          </a:xfrm>
-          <a:prstGeom prst="straightConnector1">
-            <a:avLst/>
-          </a:prstGeom>
-          <a:ln>
-            <a:solidFill>
-              <a:schemeClr val="accent1">
-                <a:lumMod val="20000"/>
-                <a:lumOff val="80000"/>
-              </a:schemeClr>
-            </a:solidFill>
-            <a:tailEnd type="triangle"/>
-          </a:ln>
-        </p:spPr>
-        <p:style>
-          <a:lnRef idx="2">
-            <a:schemeClr val="accent1"/>
-          </a:lnRef>
-          <a:fillRef idx="0">
-            <a:schemeClr val="accent1"/>
-          </a:fillRef>
-          <a:effectRef idx="1">
-            <a:schemeClr val="accent1"/>
-          </a:effectRef>
-          <a:fontRef idx="minor">
-            <a:schemeClr val="tx1"/>
-          </a:fontRef>
-        </p:style>
-      </p:cxnSp>
-      <p:cxnSp>
-        <p:nvCxnSpPr>
-          <p:cNvPr id="52" name="直線接點 51">
-            <a:extLst>
-              <a:ext uri="{FF2B5EF4-FFF2-40B4-BE49-F238E27FC236}">
-                <a16:creationId xmlns:a16="http://schemas.microsoft.com/office/drawing/2014/main" id="{4B50FD37-6118-46DB-809D-4310DA977521}"/>
-              </a:ext>
-            </a:extLst>
-          </p:cNvPr>
-          <p:cNvCxnSpPr/>
-          <p:nvPr/>
-        </p:nvCxnSpPr>
-        <p:spPr>
-          <a:xfrm>
-            <a:off x="8321951" y="1762351"/>
-            <a:ext cx="0" cy="323273"/>
-          </a:xfrm>
-          <a:prstGeom prst="line">
-            <a:avLst/>
-          </a:prstGeom>
-          <a:ln>
-            <a:solidFill>
-              <a:schemeClr val="bg2"/>
-            </a:solidFill>
-            <a:prstDash val="sysDash"/>
-          </a:ln>
-        </p:spPr>
-        <p:style>
-          <a:lnRef idx="2">
-            <a:schemeClr val="accent1"/>
-          </a:lnRef>
-          <a:fillRef idx="0">
-            <a:schemeClr val="accent1"/>
-          </a:fillRef>
-          <a:effectRef idx="1">
-            <a:schemeClr val="accent1"/>
-          </a:effectRef>
-          <a:fontRef idx="minor">
-            <a:schemeClr val="tx1"/>
-          </a:fontRef>
-        </p:style>
-      </p:cxnSp>
-      <p:cxnSp>
-        <p:nvCxnSpPr>
-          <p:cNvPr id="55" name="直線接點 54">
-            <a:extLst>
-              <a:ext uri="{FF2B5EF4-FFF2-40B4-BE49-F238E27FC236}">
-                <a16:creationId xmlns:a16="http://schemas.microsoft.com/office/drawing/2014/main" id="{55125779-A9DA-4EF8-92A8-B3990C505561}"/>
-              </a:ext>
-            </a:extLst>
-          </p:cNvPr>
-          <p:cNvCxnSpPr>
-            <a:cxnSpLocks/>
-          </p:cNvCxnSpPr>
-          <p:nvPr/>
-        </p:nvCxnSpPr>
-        <p:spPr>
-          <a:xfrm flipH="1">
-            <a:off x="8631375" y="1556892"/>
-            <a:ext cx="4605" cy="697786"/>
-          </a:xfrm>
-          <a:prstGeom prst="line">
-            <a:avLst/>
-          </a:prstGeom>
-          <a:ln>
-            <a:solidFill>
-              <a:schemeClr val="accent1">
-                <a:lumMod val="20000"/>
-                <a:lumOff val="80000"/>
-              </a:schemeClr>
-            </a:solidFill>
-            <a:prstDash val="sysDash"/>
-          </a:ln>
-        </p:spPr>
-        <p:style>
-          <a:lnRef idx="2">
-            <a:schemeClr val="accent1"/>
-          </a:lnRef>
-          <a:fillRef idx="0">
-            <a:schemeClr val="accent1"/>
-          </a:fillRef>
-          <a:effectRef idx="1">
-            <a:schemeClr val="accent1"/>
-          </a:effectRef>
-          <a:fontRef idx="minor">
-            <a:schemeClr val="tx1"/>
-          </a:fontRef>
-        </p:style>
-      </p:cxnSp>
-      <p:cxnSp>
-        <p:nvCxnSpPr>
-          <p:cNvPr id="58" name="直線接點 57">
-            <a:extLst>
-              <a:ext uri="{FF2B5EF4-FFF2-40B4-BE49-F238E27FC236}">
-                <a16:creationId xmlns:a16="http://schemas.microsoft.com/office/drawing/2014/main" id="{909104CF-AC02-48BA-B218-344963BFB7DA}"/>
-              </a:ext>
-            </a:extLst>
-          </p:cNvPr>
-          <p:cNvCxnSpPr>
-            <a:cxnSpLocks/>
-          </p:cNvCxnSpPr>
-          <p:nvPr/>
-        </p:nvCxnSpPr>
-        <p:spPr>
-          <a:xfrm>
-            <a:off x="9224634" y="1816391"/>
-            <a:ext cx="0" cy="223715"/>
-          </a:xfrm>
-          <a:prstGeom prst="line">
-            <a:avLst/>
-          </a:prstGeom>
-          <a:ln>
-            <a:solidFill>
-              <a:schemeClr val="accent1">
-                <a:lumMod val="20000"/>
-                <a:lumOff val="80000"/>
-              </a:schemeClr>
-            </a:solidFill>
-            <a:prstDash val="sysDash"/>
-          </a:ln>
-        </p:spPr>
-        <p:style>
-          <a:lnRef idx="2">
-            <a:schemeClr val="accent1"/>
-          </a:lnRef>
-          <a:fillRef idx="0">
-            <a:schemeClr val="accent1"/>
-          </a:fillRef>
-          <a:effectRef idx="1">
-            <a:schemeClr val="accent1"/>
-          </a:effectRef>
-          <a:fontRef idx="minor">
-            <a:schemeClr val="tx1"/>
-          </a:fontRef>
-        </p:style>
-      </p:cxnSp>
-      <p:sp>
-        <p:nvSpPr>
-          <p:cNvPr id="60" name="矩形 59">
-            <a:extLst>
-              <a:ext uri="{FF2B5EF4-FFF2-40B4-BE49-F238E27FC236}">
-                <a16:creationId xmlns:a16="http://schemas.microsoft.com/office/drawing/2014/main" id="{8999171D-1D72-4928-A13A-ED1449677D37}"/>
-              </a:ext>
-            </a:extLst>
-          </p:cNvPr>
-          <p:cNvSpPr/>
-          <p:nvPr/>
-        </p:nvSpPr>
-        <p:spPr>
-          <a:xfrm>
-            <a:off x="3663292" y="1631725"/>
-            <a:ext cx="652102" cy="369332"/>
-          </a:xfrm>
-          <a:prstGeom prst="rect">
-            <a:avLst/>
-          </a:prstGeom>
-        </p:spPr>
-        <p:txBody>
-          <a:bodyPr wrap="none">
-            <a:spAutoFit/>
-          </a:bodyPr>
-          <a:lstStyle/>
-          <a:p>
-            <a:r>
-              <a:rPr lang="en-US" altLang="zh-HK" dirty="0"/>
-              <a:t>Conv</a:t>
-            </a:r>
-            <a:endParaRPr lang="zh-HK" altLang="en-US" dirty="0"/>
-          </a:p>
-        </p:txBody>
-      </p:sp>
-      <p:sp>
-        <p:nvSpPr>
-          <p:cNvPr id="61" name="矩形 60">
-            <a:extLst>
-              <a:ext uri="{FF2B5EF4-FFF2-40B4-BE49-F238E27FC236}">
-                <a16:creationId xmlns:a16="http://schemas.microsoft.com/office/drawing/2014/main" id="{C4177E60-FF9A-4D56-9CC1-D588C4CD3168}"/>
-              </a:ext>
-            </a:extLst>
-          </p:cNvPr>
-          <p:cNvSpPr/>
-          <p:nvPr/>
-        </p:nvSpPr>
-        <p:spPr>
-          <a:xfrm>
-            <a:off x="5867481" y="1647427"/>
-            <a:ext cx="595228" cy="369332"/>
-          </a:xfrm>
-          <a:prstGeom prst="rect">
-            <a:avLst/>
-          </a:prstGeom>
-        </p:spPr>
-        <p:txBody>
-          <a:bodyPr wrap="none">
-            <a:spAutoFit/>
-          </a:bodyPr>
-          <a:lstStyle/>
-          <a:p>
-            <a:r>
-              <a:rPr lang="en-US" altLang="zh-HK" dirty="0"/>
-              <a:t>Pool</a:t>
-            </a:r>
-            <a:endParaRPr lang="zh-HK" altLang="en-US" dirty="0"/>
-          </a:p>
-        </p:txBody>
-      </p:sp>
-      <p:sp>
-        <p:nvSpPr>
-          <p:cNvPr id="62" name="矩形 61">
-            <a:extLst>
-              <a:ext uri="{FF2B5EF4-FFF2-40B4-BE49-F238E27FC236}">
-                <a16:creationId xmlns:a16="http://schemas.microsoft.com/office/drawing/2014/main" id="{B611DBAE-DFCB-43B7-8590-2C8B19B7187D}"/>
-              </a:ext>
-            </a:extLst>
-          </p:cNvPr>
-          <p:cNvSpPr/>
-          <p:nvPr/>
-        </p:nvSpPr>
-        <p:spPr>
-          <a:xfrm>
-            <a:off x="7392664" y="1647427"/>
-            <a:ext cx="837217" cy="369332"/>
-          </a:xfrm>
-          <a:prstGeom prst="rect">
-            <a:avLst/>
-          </a:prstGeom>
-        </p:spPr>
-        <p:txBody>
-          <a:bodyPr wrap="none">
-            <a:spAutoFit/>
-          </a:bodyPr>
-          <a:lstStyle/>
-          <a:p>
-            <a:r>
-              <a:rPr lang="en-US" altLang="zh-HK" dirty="0"/>
-              <a:t>Flatten</a:t>
-            </a:r>
-            <a:endParaRPr lang="zh-HK" altLang="en-US" dirty="0"/>
-          </a:p>
-        </p:txBody>
-      </p:sp>
-      <p:sp>
-        <p:nvSpPr>
-          <p:cNvPr id="63" name="矩形 62">
-            <a:extLst>
-              <a:ext uri="{FF2B5EF4-FFF2-40B4-BE49-F238E27FC236}">
-                <a16:creationId xmlns:a16="http://schemas.microsoft.com/office/drawing/2014/main" id="{00DAABA6-A061-4621-B471-03582849849B}"/>
-              </a:ext>
-            </a:extLst>
-          </p:cNvPr>
-          <p:cNvSpPr/>
-          <p:nvPr/>
-        </p:nvSpPr>
-        <p:spPr>
-          <a:xfrm>
-            <a:off x="8940800" y="1214728"/>
-            <a:ext cx="587020" cy="369332"/>
-          </a:xfrm>
-          <a:prstGeom prst="rect">
-            <a:avLst/>
-          </a:prstGeom>
-        </p:spPr>
-        <p:txBody>
-          <a:bodyPr wrap="none">
-            <a:spAutoFit/>
-          </a:bodyPr>
-          <a:lstStyle/>
-          <a:p>
-            <a:r>
-              <a:rPr lang="en-US" altLang="zh-HK" dirty="0"/>
-              <a:t>fully</a:t>
-            </a:r>
-            <a:endParaRPr lang="zh-HK" altLang="en-US" dirty="0"/>
-          </a:p>
-        </p:txBody>
-      </p:sp>
-      <p:sp>
-        <p:nvSpPr>
-          <p:cNvPr id="64" name="矩形 63">
-            <a:extLst>
-              <a:ext uri="{FF2B5EF4-FFF2-40B4-BE49-F238E27FC236}">
-                <a16:creationId xmlns:a16="http://schemas.microsoft.com/office/drawing/2014/main" id="{2E8E738F-70A4-47DC-99BE-30E1C345C15E}"/>
-              </a:ext>
-            </a:extLst>
-          </p:cNvPr>
-          <p:cNvSpPr/>
-          <p:nvPr/>
-        </p:nvSpPr>
-        <p:spPr>
-          <a:xfrm>
-            <a:off x="8639185" y="2325609"/>
-            <a:ext cx="1170898" cy="369332"/>
-          </a:xfrm>
-          <a:prstGeom prst="rect">
-            <a:avLst/>
-          </a:prstGeom>
-        </p:spPr>
-        <p:txBody>
-          <a:bodyPr wrap="none">
-            <a:spAutoFit/>
-          </a:bodyPr>
-          <a:lstStyle/>
-          <a:p>
-            <a:r>
-              <a:rPr lang="en-US" altLang="zh-HK" dirty="0"/>
-              <a:t>connected</a:t>
-            </a:r>
-            <a:endParaRPr lang="zh-HK" altLang="en-US" dirty="0"/>
-          </a:p>
-        </p:txBody>
-      </p:sp>
       <p:grpSp>
         <p:nvGrpSpPr>
           <p:cNvPr id="96" name="群組 95">
@@ -5108,7 +5129,7 @@
         </p:nvGrpSpPr>
         <p:grpSpPr>
           <a:xfrm>
-            <a:off x="2119568" y="3198587"/>
+            <a:off x="771593" y="2171382"/>
             <a:ext cx="5312604" cy="1807344"/>
             <a:chOff x="2119568" y="3198587"/>
             <a:chExt cx="5312604" cy="1807344"/>
@@ -6133,6 +6154,976 @@
             </a:fontRef>
           </p:style>
         </p:cxnSp>
+      </p:grpSp>
+      <p:grpSp>
+        <p:nvGrpSpPr>
+          <p:cNvPr id="54" name="群組 53">
+            <a:extLst>
+              <a:ext uri="{FF2B5EF4-FFF2-40B4-BE49-F238E27FC236}">
+                <a16:creationId xmlns:a16="http://schemas.microsoft.com/office/drawing/2014/main" id="{8409D2FB-5C9F-45CF-8656-A00DAA003C07}"/>
+              </a:ext>
+            </a:extLst>
+          </p:cNvPr>
+          <p:cNvGrpSpPr/>
+          <p:nvPr/>
+        </p:nvGrpSpPr>
+        <p:grpSpPr>
+          <a:xfrm>
+            <a:off x="3402845" y="4167402"/>
+            <a:ext cx="6682768" cy="2256501"/>
+            <a:chOff x="3402845" y="4167402"/>
+            <a:chExt cx="6682768" cy="2256501"/>
+          </a:xfrm>
+        </p:grpSpPr>
+        <p:sp>
+          <p:nvSpPr>
+            <p:cNvPr id="3" name="矩形 2">
+              <a:extLst>
+                <a:ext uri="{FF2B5EF4-FFF2-40B4-BE49-F238E27FC236}">
+                  <a16:creationId xmlns:a16="http://schemas.microsoft.com/office/drawing/2014/main" id="{D846CACC-4AF0-4AAE-B4D5-E6DCF62332B6}"/>
+                </a:ext>
+              </a:extLst>
+            </p:cNvPr>
+            <p:cNvSpPr/>
+            <p:nvPr/>
+          </p:nvSpPr>
+          <p:spPr>
+            <a:xfrm>
+              <a:off x="3402845" y="4509856"/>
+              <a:ext cx="1502644" cy="1265364"/>
+            </a:xfrm>
+            <a:prstGeom prst="rect">
+              <a:avLst/>
+            </a:prstGeom>
+          </p:spPr>
+          <p:style>
+            <a:lnRef idx="2">
+              <a:schemeClr val="accent1">
+                <a:shade val="50000"/>
+              </a:schemeClr>
+            </a:lnRef>
+            <a:fillRef idx="1">
+              <a:schemeClr val="accent1"/>
+            </a:fillRef>
+            <a:effectRef idx="0">
+              <a:schemeClr val="accent1"/>
+            </a:effectRef>
+            <a:fontRef idx="minor">
+              <a:schemeClr val="lt1"/>
+            </a:fontRef>
+          </p:style>
+          <p:txBody>
+            <a:bodyPr rtlCol="0" anchor="ctr"/>
+            <a:lstStyle/>
+            <a:p>
+              <a:pPr algn="ctr"/>
+              <a:endParaRPr lang="zh-HK" altLang="en-US"/>
+            </a:p>
+          </p:txBody>
+        </p:sp>
+        <p:pic>
+          <p:nvPicPr>
+            <p:cNvPr id="4" name="圖片 3">
+              <a:extLst>
+                <a:ext uri="{FF2B5EF4-FFF2-40B4-BE49-F238E27FC236}">
+                  <a16:creationId xmlns:a16="http://schemas.microsoft.com/office/drawing/2014/main" id="{DD86D3E5-F3F2-4108-A7D9-7D6273EF88B8}"/>
+                </a:ext>
+              </a:extLst>
+            </p:cNvPr>
+            <p:cNvPicPr>
+              <a:picLocks noChangeAspect="1"/>
+            </p:cNvPicPr>
+            <p:nvPr/>
+          </p:nvPicPr>
+          <p:blipFill>
+            <a:blip r:embed="rId5"/>
+            <a:stretch>
+              <a:fillRect/>
+            </a:stretch>
+          </p:blipFill>
+          <p:spPr>
+            <a:xfrm>
+              <a:off x="5804049" y="4621436"/>
+              <a:ext cx="670618" cy="670618"/>
+            </a:xfrm>
+            <a:prstGeom prst="rect">
+              <a:avLst/>
+            </a:prstGeom>
+          </p:spPr>
+        </p:pic>
+        <p:pic>
+          <p:nvPicPr>
+            <p:cNvPr id="5" name="圖片 4">
+              <a:extLst>
+                <a:ext uri="{FF2B5EF4-FFF2-40B4-BE49-F238E27FC236}">
+                  <a16:creationId xmlns:a16="http://schemas.microsoft.com/office/drawing/2014/main" id="{B455486C-A956-432E-AE71-BCAD4CA7D88D}"/>
+                </a:ext>
+              </a:extLst>
+            </p:cNvPr>
+            <p:cNvPicPr>
+              <a:picLocks noChangeAspect="1"/>
+            </p:cNvPicPr>
+            <p:nvPr/>
+          </p:nvPicPr>
+          <p:blipFill>
+            <a:blip r:embed="rId5"/>
+            <a:stretch>
+              <a:fillRect/>
+            </a:stretch>
+          </p:blipFill>
+          <p:spPr>
+            <a:xfrm>
+              <a:off x="5903194" y="4725902"/>
+              <a:ext cx="670618" cy="670618"/>
+            </a:xfrm>
+            <a:prstGeom prst="rect">
+              <a:avLst/>
+            </a:prstGeom>
+          </p:spPr>
+        </p:pic>
+        <p:pic>
+          <p:nvPicPr>
+            <p:cNvPr id="6" name="圖片 5">
+              <a:extLst>
+                <a:ext uri="{FF2B5EF4-FFF2-40B4-BE49-F238E27FC236}">
+                  <a16:creationId xmlns:a16="http://schemas.microsoft.com/office/drawing/2014/main" id="{BDBCD6B8-4108-44C2-AED7-5CF37DA09EAF}"/>
+                </a:ext>
+              </a:extLst>
+            </p:cNvPr>
+            <p:cNvPicPr>
+              <a:picLocks noChangeAspect="1"/>
+            </p:cNvPicPr>
+            <p:nvPr/>
+          </p:nvPicPr>
+          <p:blipFill>
+            <a:blip r:embed="rId5"/>
+            <a:stretch>
+              <a:fillRect/>
+            </a:stretch>
+          </p:blipFill>
+          <p:spPr>
+            <a:xfrm>
+              <a:off x="6002339" y="4830368"/>
+              <a:ext cx="670618" cy="670618"/>
+            </a:xfrm>
+            <a:prstGeom prst="rect">
+              <a:avLst/>
+            </a:prstGeom>
+          </p:spPr>
+        </p:pic>
+        <p:pic>
+          <p:nvPicPr>
+            <p:cNvPr id="7" name="圖片 6">
+              <a:extLst>
+                <a:ext uri="{FF2B5EF4-FFF2-40B4-BE49-F238E27FC236}">
+                  <a16:creationId xmlns:a16="http://schemas.microsoft.com/office/drawing/2014/main" id="{BA832F17-0450-4F26-8211-070503D23059}"/>
+                </a:ext>
+              </a:extLst>
+            </p:cNvPr>
+            <p:cNvPicPr>
+              <a:picLocks noChangeAspect="1"/>
+            </p:cNvPicPr>
+            <p:nvPr/>
+          </p:nvPicPr>
+          <p:blipFill>
+            <a:blip r:embed="rId5"/>
+            <a:stretch>
+              <a:fillRect/>
+            </a:stretch>
+          </p:blipFill>
+          <p:spPr>
+            <a:xfrm>
+              <a:off x="6108225" y="4936635"/>
+              <a:ext cx="670618" cy="670618"/>
+            </a:xfrm>
+            <a:prstGeom prst="rect">
+              <a:avLst/>
+            </a:prstGeom>
+          </p:spPr>
+        </p:pic>
+        <p:pic>
+          <p:nvPicPr>
+            <p:cNvPr id="8" name="圖片 7">
+              <a:extLst>
+                <a:ext uri="{FF2B5EF4-FFF2-40B4-BE49-F238E27FC236}">
+                  <a16:creationId xmlns:a16="http://schemas.microsoft.com/office/drawing/2014/main" id="{B0CED8F6-732E-4BD2-9AF0-3C57DE38691E}"/>
+                </a:ext>
+              </a:extLst>
+            </p:cNvPr>
+            <p:cNvPicPr>
+              <a:picLocks noChangeAspect="1"/>
+            </p:cNvPicPr>
+            <p:nvPr/>
+          </p:nvPicPr>
+          <p:blipFill>
+            <a:blip r:embed="rId5"/>
+            <a:stretch>
+              <a:fillRect/>
+            </a:stretch>
+          </p:blipFill>
+          <p:spPr>
+            <a:xfrm>
+              <a:off x="6223301" y="5042902"/>
+              <a:ext cx="670618" cy="670618"/>
+            </a:xfrm>
+            <a:prstGeom prst="rect">
+              <a:avLst/>
+            </a:prstGeom>
+          </p:spPr>
+        </p:pic>
+        <p:pic>
+          <p:nvPicPr>
+            <p:cNvPr id="10" name="圖片 9">
+              <a:extLst>
+                <a:ext uri="{FF2B5EF4-FFF2-40B4-BE49-F238E27FC236}">
+                  <a16:creationId xmlns:a16="http://schemas.microsoft.com/office/drawing/2014/main" id="{2DA74B12-61E6-4400-9098-8A710721265A}"/>
+                </a:ext>
+              </a:extLst>
+            </p:cNvPr>
+            <p:cNvPicPr>
+              <a:picLocks noChangeAspect="1"/>
+            </p:cNvPicPr>
+            <p:nvPr/>
+          </p:nvPicPr>
+          <p:blipFill>
+            <a:blip r:embed="rId5"/>
+            <a:stretch>
+              <a:fillRect/>
+            </a:stretch>
+          </p:blipFill>
+          <p:spPr>
+            <a:xfrm>
+              <a:off x="6337648" y="5138269"/>
+              <a:ext cx="670618" cy="670618"/>
+            </a:xfrm>
+            <a:prstGeom prst="rect">
+              <a:avLst/>
+            </a:prstGeom>
+          </p:spPr>
+        </p:pic>
+        <p:pic>
+          <p:nvPicPr>
+            <p:cNvPr id="18" name="圖片 17">
+              <a:extLst>
+                <a:ext uri="{FF2B5EF4-FFF2-40B4-BE49-F238E27FC236}">
+                  <a16:creationId xmlns:a16="http://schemas.microsoft.com/office/drawing/2014/main" id="{8708D514-2D75-4B6B-83CA-135FE8A1436F}"/>
+                </a:ext>
+              </a:extLst>
+            </p:cNvPr>
+            <p:cNvPicPr>
+              <a:picLocks noChangeAspect="1"/>
+            </p:cNvPicPr>
+            <p:nvPr/>
+          </p:nvPicPr>
+          <p:blipFill>
+            <a:blip r:embed="rId11"/>
+            <a:stretch>
+              <a:fillRect/>
+            </a:stretch>
+          </p:blipFill>
+          <p:spPr>
+            <a:xfrm>
+              <a:off x="8096655" y="4555751"/>
+              <a:ext cx="1019263" cy="856181"/>
+            </a:xfrm>
+            <a:prstGeom prst="rect">
+              <a:avLst/>
+            </a:prstGeom>
+          </p:spPr>
+        </p:pic>
+        <p:pic>
+          <p:nvPicPr>
+            <p:cNvPr id="35" name="圖片 34">
+              <a:extLst>
+                <a:ext uri="{FF2B5EF4-FFF2-40B4-BE49-F238E27FC236}">
+                  <a16:creationId xmlns:a16="http://schemas.microsoft.com/office/drawing/2014/main" id="{561EE4E3-C437-4747-91DE-D4F37536315E}"/>
+                </a:ext>
+              </a:extLst>
+            </p:cNvPr>
+            <p:cNvPicPr>
+              <a:picLocks noChangeAspect="1"/>
+            </p:cNvPicPr>
+            <p:nvPr/>
+          </p:nvPicPr>
+          <p:blipFill>
+            <a:blip r:embed="rId12"/>
+            <a:stretch>
+              <a:fillRect/>
+            </a:stretch>
+          </p:blipFill>
+          <p:spPr>
+            <a:xfrm>
+              <a:off x="8195800" y="4645250"/>
+              <a:ext cx="1018120" cy="859611"/>
+            </a:xfrm>
+            <a:prstGeom prst="rect">
+              <a:avLst/>
+            </a:prstGeom>
+          </p:spPr>
+        </p:pic>
+        <p:pic>
+          <p:nvPicPr>
+            <p:cNvPr id="37" name="圖片 36">
+              <a:extLst>
+                <a:ext uri="{FF2B5EF4-FFF2-40B4-BE49-F238E27FC236}">
+                  <a16:creationId xmlns:a16="http://schemas.microsoft.com/office/drawing/2014/main" id="{5BF33A54-7707-4A5F-AB43-AEBCA579E1C6}"/>
+                </a:ext>
+              </a:extLst>
+            </p:cNvPr>
+            <p:cNvPicPr>
+              <a:picLocks noChangeAspect="1"/>
+            </p:cNvPicPr>
+            <p:nvPr/>
+          </p:nvPicPr>
+          <p:blipFill>
+            <a:blip r:embed="rId12"/>
+            <a:stretch>
+              <a:fillRect/>
+            </a:stretch>
+          </p:blipFill>
+          <p:spPr>
+            <a:xfrm>
+              <a:off x="8294945" y="4740211"/>
+              <a:ext cx="1018120" cy="859611"/>
+            </a:xfrm>
+            <a:prstGeom prst="rect">
+              <a:avLst/>
+            </a:prstGeom>
+          </p:spPr>
+        </p:pic>
+        <p:pic>
+          <p:nvPicPr>
+            <p:cNvPr id="39" name="圖片 38">
+              <a:extLst>
+                <a:ext uri="{FF2B5EF4-FFF2-40B4-BE49-F238E27FC236}">
+                  <a16:creationId xmlns:a16="http://schemas.microsoft.com/office/drawing/2014/main" id="{4242788A-16E6-41A1-9A9A-04B3CCC35E38}"/>
+                </a:ext>
+              </a:extLst>
+            </p:cNvPr>
+            <p:cNvPicPr>
+              <a:picLocks noChangeAspect="1"/>
+            </p:cNvPicPr>
+            <p:nvPr/>
+          </p:nvPicPr>
+          <p:blipFill>
+            <a:blip r:embed="rId12"/>
+            <a:stretch>
+              <a:fillRect/>
+            </a:stretch>
+          </p:blipFill>
+          <p:spPr>
+            <a:xfrm>
+              <a:off x="8390981" y="4842138"/>
+              <a:ext cx="1018120" cy="859611"/>
+            </a:xfrm>
+            <a:prstGeom prst="rect">
+              <a:avLst/>
+            </a:prstGeom>
+          </p:spPr>
+        </p:pic>
+        <p:pic>
+          <p:nvPicPr>
+            <p:cNvPr id="41" name="圖片 40">
+              <a:extLst>
+                <a:ext uri="{FF2B5EF4-FFF2-40B4-BE49-F238E27FC236}">
+                  <a16:creationId xmlns:a16="http://schemas.microsoft.com/office/drawing/2014/main" id="{A8B060AE-9691-4B29-8E4C-0FB63878A29C}"/>
+                </a:ext>
+              </a:extLst>
+            </p:cNvPr>
+            <p:cNvPicPr>
+              <a:picLocks noChangeAspect="1"/>
+            </p:cNvPicPr>
+            <p:nvPr/>
+          </p:nvPicPr>
+          <p:blipFill>
+            <a:blip r:embed="rId12"/>
+            <a:stretch>
+              <a:fillRect/>
+            </a:stretch>
+          </p:blipFill>
+          <p:spPr>
+            <a:xfrm>
+              <a:off x="8508063" y="4944065"/>
+              <a:ext cx="1018120" cy="859611"/>
+            </a:xfrm>
+            <a:prstGeom prst="rect">
+              <a:avLst/>
+            </a:prstGeom>
+          </p:spPr>
+        </p:pic>
+        <p:pic>
+          <p:nvPicPr>
+            <p:cNvPr id="42" name="圖片 41">
+              <a:extLst>
+                <a:ext uri="{FF2B5EF4-FFF2-40B4-BE49-F238E27FC236}">
+                  <a16:creationId xmlns:a16="http://schemas.microsoft.com/office/drawing/2014/main" id="{ED28C492-6CC5-4D96-96B4-C80166F447F2}"/>
+                </a:ext>
+              </a:extLst>
+            </p:cNvPr>
+            <p:cNvPicPr>
+              <a:picLocks noChangeAspect="1"/>
+            </p:cNvPicPr>
+            <p:nvPr/>
+          </p:nvPicPr>
+          <p:blipFill>
+            <a:blip r:embed="rId12"/>
+            <a:stretch>
+              <a:fillRect/>
+            </a:stretch>
+          </p:blipFill>
+          <p:spPr>
+            <a:xfrm>
+              <a:off x="8630254" y="5042902"/>
+              <a:ext cx="1018120" cy="859611"/>
+            </a:xfrm>
+            <a:prstGeom prst="rect">
+              <a:avLst/>
+            </a:prstGeom>
+          </p:spPr>
+        </p:pic>
+        <p:sp>
+          <p:nvSpPr>
+            <p:cNvPr id="44" name="文字方塊 43">
+              <a:extLst>
+                <a:ext uri="{FF2B5EF4-FFF2-40B4-BE49-F238E27FC236}">
+                  <a16:creationId xmlns:a16="http://schemas.microsoft.com/office/drawing/2014/main" id="{F7FB2828-1970-4285-A288-1F8E61FF8F69}"/>
+                </a:ext>
+              </a:extLst>
+            </p:cNvPr>
+            <p:cNvSpPr txBox="1"/>
+            <p:nvPr/>
+          </p:nvSpPr>
+          <p:spPr>
+            <a:xfrm>
+              <a:off x="3719816" y="6054571"/>
+              <a:ext cx="793109" cy="369332"/>
+            </a:xfrm>
+            <a:prstGeom prst="rect">
+              <a:avLst/>
+            </a:prstGeom>
+            <a:noFill/>
+          </p:spPr>
+          <p:txBody>
+            <a:bodyPr wrap="square" rtlCol="0">
+              <a:spAutoFit/>
+            </a:bodyPr>
+            <a:lstStyle/>
+            <a:p>
+              <a:r>
+                <a:rPr lang="en-US" altLang="zh-HK" dirty="0"/>
+                <a:t>n, n, 1</a:t>
+              </a:r>
+              <a:endParaRPr lang="zh-HK" altLang="en-US" dirty="0"/>
+            </a:p>
+          </p:txBody>
+        </p:sp>
+        <p:sp>
+          <p:nvSpPr>
+            <p:cNvPr id="97" name="文字方塊 96">
+              <a:extLst>
+                <a:ext uri="{FF2B5EF4-FFF2-40B4-BE49-F238E27FC236}">
+                  <a16:creationId xmlns:a16="http://schemas.microsoft.com/office/drawing/2014/main" id="{A8B7461B-4B86-4C26-A8D8-5013D72454ED}"/>
+                </a:ext>
+              </a:extLst>
+            </p:cNvPr>
+            <p:cNvSpPr txBox="1"/>
+            <p:nvPr/>
+          </p:nvSpPr>
+          <p:spPr>
+            <a:xfrm>
+              <a:off x="6100810" y="6054571"/>
+              <a:ext cx="793109" cy="369332"/>
+            </a:xfrm>
+            <a:prstGeom prst="rect">
+              <a:avLst/>
+            </a:prstGeom>
+            <a:noFill/>
+          </p:spPr>
+          <p:txBody>
+            <a:bodyPr wrap="square" rtlCol="0">
+              <a:spAutoFit/>
+            </a:bodyPr>
+            <a:lstStyle/>
+            <a:p>
+              <a:r>
+                <a:rPr lang="en-US" altLang="zh-HK" dirty="0"/>
+                <a:t>k, k, f</a:t>
+              </a:r>
+              <a:endParaRPr lang="zh-HK" altLang="en-US" dirty="0"/>
+            </a:p>
+          </p:txBody>
+        </p:sp>
+        <p:sp>
+          <p:nvSpPr>
+            <p:cNvPr id="98" name="文字方塊 97">
+              <a:extLst>
+                <a:ext uri="{FF2B5EF4-FFF2-40B4-BE49-F238E27FC236}">
+                  <a16:creationId xmlns:a16="http://schemas.microsoft.com/office/drawing/2014/main" id="{9B5A0096-3668-4A1E-A7EA-369669293D48}"/>
+                </a:ext>
+              </a:extLst>
+            </p:cNvPr>
+            <p:cNvSpPr txBox="1"/>
+            <p:nvPr/>
+          </p:nvSpPr>
+          <p:spPr>
+            <a:xfrm>
+              <a:off x="8193220" y="6054571"/>
+              <a:ext cx="1845396" cy="369332"/>
+            </a:xfrm>
+            <a:prstGeom prst="rect">
+              <a:avLst/>
+            </a:prstGeom>
+            <a:noFill/>
+          </p:spPr>
+          <p:txBody>
+            <a:bodyPr wrap="square" rtlCol="0">
+              <a:spAutoFit/>
+            </a:bodyPr>
+            <a:lstStyle/>
+            <a:p>
+              <a:r>
+                <a:rPr lang="en-US" altLang="zh-HK" dirty="0"/>
+                <a:t>(n-k+1), (n-k+1), f</a:t>
+              </a:r>
+              <a:endParaRPr lang="zh-HK" altLang="en-US" dirty="0"/>
+            </a:p>
+          </p:txBody>
+        </p:sp>
+        <p:sp>
+          <p:nvSpPr>
+            <p:cNvPr id="46" name="文字方塊 45">
+              <a:extLst>
+                <a:ext uri="{FF2B5EF4-FFF2-40B4-BE49-F238E27FC236}">
+                  <a16:creationId xmlns:a16="http://schemas.microsoft.com/office/drawing/2014/main" id="{E78531B9-F8C5-4F3B-83CF-65BB08BB768D}"/>
+                </a:ext>
+              </a:extLst>
+            </p:cNvPr>
+            <p:cNvSpPr txBox="1"/>
+            <p:nvPr/>
+          </p:nvSpPr>
+          <p:spPr>
+            <a:xfrm>
+              <a:off x="5127662" y="5042902"/>
+              <a:ext cx="371086" cy="584775"/>
+            </a:xfrm>
+            <a:prstGeom prst="rect">
+              <a:avLst/>
+            </a:prstGeom>
+            <a:noFill/>
+          </p:spPr>
+          <p:txBody>
+            <a:bodyPr wrap="square" rtlCol="0">
+              <a:spAutoFit/>
+            </a:bodyPr>
+            <a:lstStyle/>
+            <a:p>
+              <a:r>
+                <a:rPr lang="en-US" altLang="zh-HK" sz="3200" dirty="0"/>
+                <a:t>*</a:t>
+              </a:r>
+              <a:endParaRPr lang="zh-HK" altLang="en-US" sz="3200" dirty="0"/>
+            </a:p>
+          </p:txBody>
+        </p:sp>
+        <p:sp>
+          <p:nvSpPr>
+            <p:cNvPr id="99" name="文字方塊 98">
+              <a:extLst>
+                <a:ext uri="{FF2B5EF4-FFF2-40B4-BE49-F238E27FC236}">
+                  <a16:creationId xmlns:a16="http://schemas.microsoft.com/office/drawing/2014/main" id="{757F40FB-EAF6-4663-9949-65B6A5C76C4C}"/>
+                </a:ext>
+              </a:extLst>
+            </p:cNvPr>
+            <p:cNvSpPr txBox="1"/>
+            <p:nvPr/>
+          </p:nvSpPr>
+          <p:spPr>
+            <a:xfrm>
+              <a:off x="7392735" y="4983841"/>
+              <a:ext cx="371086" cy="584775"/>
+            </a:xfrm>
+            <a:prstGeom prst="rect">
+              <a:avLst/>
+            </a:prstGeom>
+            <a:noFill/>
+          </p:spPr>
+          <p:txBody>
+            <a:bodyPr wrap="square" rtlCol="0">
+              <a:spAutoFit/>
+            </a:bodyPr>
+            <a:lstStyle/>
+            <a:p>
+              <a:r>
+                <a:rPr lang="en-US" altLang="zh-HK" sz="3200" dirty="0"/>
+                <a:t>=</a:t>
+              </a:r>
+              <a:endParaRPr lang="zh-HK" altLang="en-US" sz="3200" dirty="0"/>
+            </a:p>
+          </p:txBody>
+        </p:sp>
+        <p:cxnSp>
+          <p:nvCxnSpPr>
+            <p:cNvPr id="100" name="直線單箭頭接點 99">
+              <a:extLst>
+                <a:ext uri="{FF2B5EF4-FFF2-40B4-BE49-F238E27FC236}">
+                  <a16:creationId xmlns:a16="http://schemas.microsoft.com/office/drawing/2014/main" id="{29BD2765-6721-4F6A-94E8-B8FDEADAE25E}"/>
+                </a:ext>
+              </a:extLst>
+            </p:cNvPr>
+            <p:cNvCxnSpPr/>
+            <p:nvPr/>
+          </p:nvCxnSpPr>
+          <p:spPr>
+            <a:xfrm flipH="1">
+              <a:off x="7002007" y="4965471"/>
+              <a:ext cx="315756" cy="191479"/>
+            </a:xfrm>
+            <a:prstGeom prst="straightConnector1">
+              <a:avLst/>
+            </a:prstGeom>
+            <a:ln>
+              <a:tailEnd type="triangle"/>
+            </a:ln>
+          </p:spPr>
+          <p:style>
+            <a:lnRef idx="2">
+              <a:schemeClr val="accent1"/>
+            </a:lnRef>
+            <a:fillRef idx="0">
+              <a:schemeClr val="accent1"/>
+            </a:fillRef>
+            <a:effectRef idx="1">
+              <a:schemeClr val="accent1"/>
+            </a:effectRef>
+            <a:fontRef idx="minor">
+              <a:schemeClr val="tx1"/>
+            </a:fontRef>
+          </p:style>
+        </p:cxnSp>
+        <p:grpSp>
+          <p:nvGrpSpPr>
+            <p:cNvPr id="53" name="群組 52">
+              <a:extLst>
+                <a:ext uri="{FF2B5EF4-FFF2-40B4-BE49-F238E27FC236}">
+                  <a16:creationId xmlns:a16="http://schemas.microsoft.com/office/drawing/2014/main" id="{647C5896-09A4-4888-A878-BF9158B8285E}"/>
+                </a:ext>
+              </a:extLst>
+            </p:cNvPr>
+            <p:cNvGrpSpPr/>
+            <p:nvPr/>
+          </p:nvGrpSpPr>
+          <p:grpSpPr>
+            <a:xfrm>
+              <a:off x="6497364" y="4225038"/>
+              <a:ext cx="433222" cy="396398"/>
+              <a:chOff x="6497364" y="4225038"/>
+              <a:chExt cx="433222" cy="396398"/>
+            </a:xfrm>
+          </p:grpSpPr>
+          <p:cxnSp>
+            <p:nvCxnSpPr>
+              <p:cNvPr id="48" name="直線單箭頭接點 47">
+                <a:extLst>
+                  <a:ext uri="{FF2B5EF4-FFF2-40B4-BE49-F238E27FC236}">
+                    <a16:creationId xmlns:a16="http://schemas.microsoft.com/office/drawing/2014/main" id="{A7A38FB2-FD2E-4166-BB5E-E380EE9042CC}"/>
+                  </a:ext>
+                </a:extLst>
+              </p:cNvPr>
+              <p:cNvCxnSpPr/>
+              <p:nvPr/>
+            </p:nvCxnSpPr>
+            <p:spPr>
+              <a:xfrm flipH="1">
+                <a:off x="6497364" y="4429957"/>
+                <a:ext cx="315756" cy="191479"/>
+              </a:xfrm>
+              <a:prstGeom prst="straightConnector1">
+                <a:avLst/>
+              </a:prstGeom>
+              <a:ln>
+                <a:tailEnd type="triangle"/>
+              </a:ln>
+            </p:spPr>
+            <p:style>
+              <a:lnRef idx="2">
+                <a:schemeClr val="accent1"/>
+              </a:lnRef>
+              <a:fillRef idx="0">
+                <a:schemeClr val="accent1"/>
+              </a:fillRef>
+              <a:effectRef idx="1">
+                <a:schemeClr val="accent1"/>
+              </a:effectRef>
+              <a:fontRef idx="minor">
+                <a:schemeClr val="tx1"/>
+              </a:fontRef>
+            </p:style>
+          </p:cxnSp>
+          <p:sp>
+            <p:nvSpPr>
+              <p:cNvPr id="49" name="文字方塊 48">
+                <a:extLst>
+                  <a:ext uri="{FF2B5EF4-FFF2-40B4-BE49-F238E27FC236}">
+                    <a16:creationId xmlns:a16="http://schemas.microsoft.com/office/drawing/2014/main" id="{F965265F-29B6-4147-8CD0-0F64BEC9667B}"/>
+                  </a:ext>
+                </a:extLst>
+              </p:cNvPr>
+              <p:cNvSpPr txBox="1"/>
+              <p:nvPr/>
+            </p:nvSpPr>
+            <p:spPr>
+              <a:xfrm>
+                <a:off x="6776454" y="4225038"/>
+                <a:ext cx="154132" cy="369332"/>
+              </a:xfrm>
+              <a:prstGeom prst="rect">
+                <a:avLst/>
+              </a:prstGeom>
+              <a:noFill/>
+            </p:spPr>
+            <p:txBody>
+              <a:bodyPr wrap="square" rtlCol="0">
+                <a:spAutoFit/>
+              </a:bodyPr>
+              <a:lstStyle/>
+              <a:p>
+                <a:r>
+                  <a:rPr lang="en-US" altLang="zh-HK" dirty="0"/>
+                  <a:t>1</a:t>
+                </a:r>
+                <a:endParaRPr lang="zh-HK" altLang="en-US" dirty="0"/>
+              </a:p>
+            </p:txBody>
+          </p:sp>
+        </p:grpSp>
+        <p:sp>
+          <p:nvSpPr>
+            <p:cNvPr id="51" name="文字方塊 50">
+              <a:extLst>
+                <a:ext uri="{FF2B5EF4-FFF2-40B4-BE49-F238E27FC236}">
+                  <a16:creationId xmlns:a16="http://schemas.microsoft.com/office/drawing/2014/main" id="{BF35C227-A57A-4B17-9409-B9AAAC6DE85C}"/>
+                </a:ext>
+              </a:extLst>
+            </p:cNvPr>
+            <p:cNvSpPr txBox="1"/>
+            <p:nvPr/>
+          </p:nvSpPr>
+          <p:spPr>
+            <a:xfrm>
+              <a:off x="7275653" y="4751969"/>
+              <a:ext cx="164606" cy="369332"/>
+            </a:xfrm>
+            <a:prstGeom prst="rect">
+              <a:avLst/>
+            </a:prstGeom>
+            <a:noFill/>
+          </p:spPr>
+          <p:txBody>
+            <a:bodyPr wrap="square" rtlCol="0">
+              <a:spAutoFit/>
+            </a:bodyPr>
+            <a:lstStyle/>
+            <a:p>
+              <a:r>
+                <a:rPr lang="en-US" altLang="zh-HK" dirty="0"/>
+                <a:t>f</a:t>
+              </a:r>
+              <a:endParaRPr lang="zh-HK" altLang="en-US" dirty="0"/>
+            </a:p>
+          </p:txBody>
+        </p:sp>
+        <p:grpSp>
+          <p:nvGrpSpPr>
+            <p:cNvPr id="102" name="群組 101">
+              <a:extLst>
+                <a:ext uri="{FF2B5EF4-FFF2-40B4-BE49-F238E27FC236}">
+                  <a16:creationId xmlns:a16="http://schemas.microsoft.com/office/drawing/2014/main" id="{A6D08280-9385-4A2D-964A-B44B105C843B}"/>
+                </a:ext>
+              </a:extLst>
+            </p:cNvPr>
+            <p:cNvGrpSpPr/>
+            <p:nvPr/>
+          </p:nvGrpSpPr>
+          <p:grpSpPr>
+            <a:xfrm>
+              <a:off x="9115918" y="4167402"/>
+              <a:ext cx="433222" cy="396398"/>
+              <a:chOff x="6497364" y="4225038"/>
+              <a:chExt cx="433222" cy="396398"/>
+            </a:xfrm>
+          </p:grpSpPr>
+          <p:cxnSp>
+            <p:nvCxnSpPr>
+              <p:cNvPr id="103" name="直線單箭頭接點 102">
+                <a:extLst>
+                  <a:ext uri="{FF2B5EF4-FFF2-40B4-BE49-F238E27FC236}">
+                    <a16:creationId xmlns:a16="http://schemas.microsoft.com/office/drawing/2014/main" id="{DDC4EC55-B425-4C6C-B43B-B44285488F1C}"/>
+                  </a:ext>
+                </a:extLst>
+              </p:cNvPr>
+              <p:cNvCxnSpPr/>
+              <p:nvPr/>
+            </p:nvCxnSpPr>
+            <p:spPr>
+              <a:xfrm flipH="1">
+                <a:off x="6497364" y="4429957"/>
+                <a:ext cx="315756" cy="191479"/>
+              </a:xfrm>
+              <a:prstGeom prst="straightConnector1">
+                <a:avLst/>
+              </a:prstGeom>
+              <a:ln>
+                <a:tailEnd type="triangle"/>
+              </a:ln>
+            </p:spPr>
+            <p:style>
+              <a:lnRef idx="2">
+                <a:schemeClr val="accent1"/>
+              </a:lnRef>
+              <a:fillRef idx="0">
+                <a:schemeClr val="accent1"/>
+              </a:fillRef>
+              <a:effectRef idx="1">
+                <a:schemeClr val="accent1"/>
+              </a:effectRef>
+              <a:fontRef idx="minor">
+                <a:schemeClr val="tx1"/>
+              </a:fontRef>
+            </p:style>
+          </p:cxnSp>
+          <p:sp>
+            <p:nvSpPr>
+              <p:cNvPr id="104" name="文字方塊 103">
+                <a:extLst>
+                  <a:ext uri="{FF2B5EF4-FFF2-40B4-BE49-F238E27FC236}">
+                    <a16:creationId xmlns:a16="http://schemas.microsoft.com/office/drawing/2014/main" id="{99F3A210-B843-4292-86A7-86E968B1A077}"/>
+                  </a:ext>
+                </a:extLst>
+              </p:cNvPr>
+              <p:cNvSpPr txBox="1"/>
+              <p:nvPr/>
+            </p:nvSpPr>
+            <p:spPr>
+              <a:xfrm>
+                <a:off x="6776454" y="4225038"/>
+                <a:ext cx="154132" cy="369332"/>
+              </a:xfrm>
+              <a:prstGeom prst="rect">
+                <a:avLst/>
+              </a:prstGeom>
+              <a:noFill/>
+            </p:spPr>
+            <p:txBody>
+              <a:bodyPr wrap="square" rtlCol="0">
+                <a:spAutoFit/>
+              </a:bodyPr>
+              <a:lstStyle/>
+              <a:p>
+                <a:r>
+                  <a:rPr lang="en-US" altLang="zh-HK" dirty="0"/>
+                  <a:t>1</a:t>
+                </a:r>
+                <a:endParaRPr lang="zh-HK" altLang="en-US" dirty="0"/>
+              </a:p>
+            </p:txBody>
+          </p:sp>
+        </p:grpSp>
+        <p:grpSp>
+          <p:nvGrpSpPr>
+            <p:cNvPr id="105" name="群組 104">
+              <a:extLst>
+                <a:ext uri="{FF2B5EF4-FFF2-40B4-BE49-F238E27FC236}">
+                  <a16:creationId xmlns:a16="http://schemas.microsoft.com/office/drawing/2014/main" id="{88F3AF23-C369-4F33-950C-EA9A34918983}"/>
+                </a:ext>
+              </a:extLst>
+            </p:cNvPr>
+            <p:cNvGrpSpPr/>
+            <p:nvPr/>
+          </p:nvGrpSpPr>
+          <p:grpSpPr>
+            <a:xfrm>
+              <a:off x="9652391" y="4658401"/>
+              <a:ext cx="433222" cy="396398"/>
+              <a:chOff x="6497364" y="4225038"/>
+              <a:chExt cx="433222" cy="396398"/>
+            </a:xfrm>
+          </p:grpSpPr>
+          <p:cxnSp>
+            <p:nvCxnSpPr>
+              <p:cNvPr id="106" name="直線單箭頭接點 105">
+                <a:extLst>
+                  <a:ext uri="{FF2B5EF4-FFF2-40B4-BE49-F238E27FC236}">
+                    <a16:creationId xmlns:a16="http://schemas.microsoft.com/office/drawing/2014/main" id="{371CF24B-4282-4590-9241-E458C58BC1FD}"/>
+                  </a:ext>
+                </a:extLst>
+              </p:cNvPr>
+              <p:cNvCxnSpPr/>
+              <p:nvPr/>
+            </p:nvCxnSpPr>
+            <p:spPr>
+              <a:xfrm flipH="1">
+                <a:off x="6497364" y="4429957"/>
+                <a:ext cx="315756" cy="191479"/>
+              </a:xfrm>
+              <a:prstGeom prst="straightConnector1">
+                <a:avLst/>
+              </a:prstGeom>
+              <a:ln>
+                <a:tailEnd type="triangle"/>
+              </a:ln>
+            </p:spPr>
+            <p:style>
+              <a:lnRef idx="2">
+                <a:schemeClr val="accent1"/>
+              </a:lnRef>
+              <a:fillRef idx="0">
+                <a:schemeClr val="accent1"/>
+              </a:fillRef>
+              <a:effectRef idx="1">
+                <a:schemeClr val="accent1"/>
+              </a:effectRef>
+              <a:fontRef idx="minor">
+                <a:schemeClr val="tx1"/>
+              </a:fontRef>
+            </p:style>
+          </p:cxnSp>
+          <p:sp>
+            <p:nvSpPr>
+              <p:cNvPr id="107" name="文字方塊 106">
+                <a:extLst>
+                  <a:ext uri="{FF2B5EF4-FFF2-40B4-BE49-F238E27FC236}">
+                    <a16:creationId xmlns:a16="http://schemas.microsoft.com/office/drawing/2014/main" id="{E74F5F0B-D069-4328-B322-001A2DF7639C}"/>
+                  </a:ext>
+                </a:extLst>
+              </p:cNvPr>
+              <p:cNvSpPr txBox="1"/>
+              <p:nvPr/>
+            </p:nvSpPr>
+            <p:spPr>
+              <a:xfrm>
+                <a:off x="6776454" y="4225038"/>
+                <a:ext cx="154132" cy="369332"/>
+              </a:xfrm>
+              <a:prstGeom prst="rect">
+                <a:avLst/>
+              </a:prstGeom>
+              <a:noFill/>
+            </p:spPr>
+            <p:txBody>
+              <a:bodyPr wrap="square" rtlCol="0">
+                <a:spAutoFit/>
+              </a:bodyPr>
+              <a:lstStyle/>
+              <a:p>
+                <a:r>
+                  <a:rPr lang="en-US" altLang="zh-HK" dirty="0"/>
+                  <a:t>f</a:t>
+                </a:r>
+                <a:endParaRPr lang="zh-HK" altLang="en-US" dirty="0"/>
+              </a:p>
+            </p:txBody>
+          </p:sp>
+        </p:grpSp>
       </p:grpSp>
     </p:spTree>
     <p:extLst>

</xml_diff>

<commit_message>
start working on result
</commit_message>
<xml_diff>
--- a/Presentation1.pptx
+++ b/Presentation1.pptx
@@ -8,6 +8,7 @@
     <p:sldId id="256" r:id="rId2"/>
     <p:sldId id="257" r:id="rId3"/>
     <p:sldId id="258" r:id="rId4"/>
+    <p:sldId id="259" r:id="rId5"/>
   </p:sldIdLst>
   <p:sldSz cx="12192000" cy="6858000"/>
   <p:notesSz cx="6858000" cy="9144000"/>
@@ -263,7 +264,7 @@
           <a:p>
             <a:fld id="{ED0FC01E-52E7-E248-9225-B6E184C589D0}" type="datetimeFigureOut">
               <a:rPr lang="en-US" smtClean="0"/>
-              <a:t>11/19/2024</a:t>
+              <a:t>11/21/2024</a:t>
             </a:fld>
             <a:endParaRPr lang="en-US"/>
           </a:p>
@@ -463,7 +464,7 @@
           <a:p>
             <a:fld id="{ED0FC01E-52E7-E248-9225-B6E184C589D0}" type="datetimeFigureOut">
               <a:rPr lang="en-US" smtClean="0"/>
-              <a:t>11/19/2024</a:t>
+              <a:t>11/21/2024</a:t>
             </a:fld>
             <a:endParaRPr lang="en-US"/>
           </a:p>
@@ -673,7 +674,7 @@
           <a:p>
             <a:fld id="{ED0FC01E-52E7-E248-9225-B6E184C589D0}" type="datetimeFigureOut">
               <a:rPr lang="en-US" smtClean="0"/>
-              <a:t>11/19/2024</a:t>
+              <a:t>11/21/2024</a:t>
             </a:fld>
             <a:endParaRPr lang="en-US"/>
           </a:p>
@@ -873,7 +874,7 @@
           <a:p>
             <a:fld id="{ED0FC01E-52E7-E248-9225-B6E184C589D0}" type="datetimeFigureOut">
               <a:rPr lang="en-US" smtClean="0"/>
-              <a:t>11/19/2024</a:t>
+              <a:t>11/21/2024</a:t>
             </a:fld>
             <a:endParaRPr lang="en-US"/>
           </a:p>
@@ -1149,7 +1150,7 @@
           <a:p>
             <a:fld id="{ED0FC01E-52E7-E248-9225-B6E184C589D0}" type="datetimeFigureOut">
               <a:rPr lang="en-US" smtClean="0"/>
-              <a:t>11/19/2024</a:t>
+              <a:t>11/21/2024</a:t>
             </a:fld>
             <a:endParaRPr lang="en-US"/>
           </a:p>
@@ -1417,7 +1418,7 @@
           <a:p>
             <a:fld id="{ED0FC01E-52E7-E248-9225-B6E184C589D0}" type="datetimeFigureOut">
               <a:rPr lang="en-US" smtClean="0"/>
-              <a:t>11/19/2024</a:t>
+              <a:t>11/21/2024</a:t>
             </a:fld>
             <a:endParaRPr lang="en-US"/>
           </a:p>
@@ -1832,7 +1833,7 @@
           <a:p>
             <a:fld id="{ED0FC01E-52E7-E248-9225-B6E184C589D0}" type="datetimeFigureOut">
               <a:rPr lang="en-US" smtClean="0"/>
-              <a:t>11/19/2024</a:t>
+              <a:t>11/21/2024</a:t>
             </a:fld>
             <a:endParaRPr lang="en-US"/>
           </a:p>
@@ -1974,7 +1975,7 @@
           <a:p>
             <a:fld id="{ED0FC01E-52E7-E248-9225-B6E184C589D0}" type="datetimeFigureOut">
               <a:rPr lang="en-US" smtClean="0"/>
-              <a:t>11/19/2024</a:t>
+              <a:t>11/21/2024</a:t>
             </a:fld>
             <a:endParaRPr lang="en-US"/>
           </a:p>
@@ -2087,7 +2088,7 @@
           <a:p>
             <a:fld id="{ED0FC01E-52E7-E248-9225-B6E184C589D0}" type="datetimeFigureOut">
               <a:rPr lang="en-US" smtClean="0"/>
-              <a:t>11/19/2024</a:t>
+              <a:t>11/21/2024</a:t>
             </a:fld>
             <a:endParaRPr lang="en-US"/>
           </a:p>
@@ -2400,7 +2401,7 @@
           <a:p>
             <a:fld id="{ED0FC01E-52E7-E248-9225-B6E184C589D0}" type="datetimeFigureOut">
               <a:rPr lang="en-US" smtClean="0"/>
-              <a:t>11/19/2024</a:t>
+              <a:t>11/21/2024</a:t>
             </a:fld>
             <a:endParaRPr lang="en-US"/>
           </a:p>
@@ -2689,7 +2690,7 @@
           <a:p>
             <a:fld id="{ED0FC01E-52E7-E248-9225-B6E184C589D0}" type="datetimeFigureOut">
               <a:rPr lang="en-US" smtClean="0"/>
-              <a:t>11/19/2024</a:t>
+              <a:t>11/21/2024</a:t>
             </a:fld>
             <a:endParaRPr lang="en-US"/>
           </a:p>
@@ -2932,7 +2933,7 @@
           <a:p>
             <a:fld id="{ED0FC01E-52E7-E248-9225-B6E184C589D0}" type="datetimeFigureOut">
               <a:rPr lang="en-US" smtClean="0"/>
-              <a:t>11/19/2024</a:t>
+              <a:t>11/21/2024</a:t>
             </a:fld>
             <a:endParaRPr lang="en-US"/>
           </a:p>
@@ -6157,10 +6158,10 @@
       </p:grpSp>
       <p:grpSp>
         <p:nvGrpSpPr>
-          <p:cNvPr id="54" name="群組 53">
+          <p:cNvPr id="56" name="群組 55">
             <a:extLst>
               <a:ext uri="{FF2B5EF4-FFF2-40B4-BE49-F238E27FC236}">
-                <a16:creationId xmlns:a16="http://schemas.microsoft.com/office/drawing/2014/main" id="{8409D2FB-5C9F-45CF-8656-A00DAA003C07}"/>
+                <a16:creationId xmlns:a16="http://schemas.microsoft.com/office/drawing/2014/main" id="{3E805B3C-EB09-4D22-810F-D8C6682CC0D4}"/>
               </a:ext>
             </a:extLst>
           </p:cNvPr>
@@ -6175,637 +6176,12 @@
             <a:chExt cx="6682768" cy="2256501"/>
           </a:xfrm>
         </p:grpSpPr>
-        <p:sp>
-          <p:nvSpPr>
-            <p:cNvPr id="3" name="矩形 2">
+        <p:grpSp>
+          <p:nvGrpSpPr>
+            <p:cNvPr id="54" name="群組 53">
               <a:extLst>
                 <a:ext uri="{FF2B5EF4-FFF2-40B4-BE49-F238E27FC236}">
-                  <a16:creationId xmlns:a16="http://schemas.microsoft.com/office/drawing/2014/main" id="{D846CACC-4AF0-4AAE-B4D5-E6DCF62332B6}"/>
-                </a:ext>
-              </a:extLst>
-            </p:cNvPr>
-            <p:cNvSpPr/>
-            <p:nvPr/>
-          </p:nvSpPr>
-          <p:spPr>
-            <a:xfrm>
-              <a:off x="3402845" y="4509856"/>
-              <a:ext cx="1502644" cy="1265364"/>
-            </a:xfrm>
-            <a:prstGeom prst="rect">
-              <a:avLst/>
-            </a:prstGeom>
-          </p:spPr>
-          <p:style>
-            <a:lnRef idx="2">
-              <a:schemeClr val="accent1">
-                <a:shade val="50000"/>
-              </a:schemeClr>
-            </a:lnRef>
-            <a:fillRef idx="1">
-              <a:schemeClr val="accent1"/>
-            </a:fillRef>
-            <a:effectRef idx="0">
-              <a:schemeClr val="accent1"/>
-            </a:effectRef>
-            <a:fontRef idx="minor">
-              <a:schemeClr val="lt1"/>
-            </a:fontRef>
-          </p:style>
-          <p:txBody>
-            <a:bodyPr rtlCol="0" anchor="ctr"/>
-            <a:lstStyle/>
-            <a:p>
-              <a:pPr algn="ctr"/>
-              <a:endParaRPr lang="zh-HK" altLang="en-US"/>
-            </a:p>
-          </p:txBody>
-        </p:sp>
-        <p:pic>
-          <p:nvPicPr>
-            <p:cNvPr id="4" name="圖片 3">
-              <a:extLst>
-                <a:ext uri="{FF2B5EF4-FFF2-40B4-BE49-F238E27FC236}">
-                  <a16:creationId xmlns:a16="http://schemas.microsoft.com/office/drawing/2014/main" id="{DD86D3E5-F3F2-4108-A7D9-7D6273EF88B8}"/>
-                </a:ext>
-              </a:extLst>
-            </p:cNvPr>
-            <p:cNvPicPr>
-              <a:picLocks noChangeAspect="1"/>
-            </p:cNvPicPr>
-            <p:nvPr/>
-          </p:nvPicPr>
-          <p:blipFill>
-            <a:blip r:embed="rId5"/>
-            <a:stretch>
-              <a:fillRect/>
-            </a:stretch>
-          </p:blipFill>
-          <p:spPr>
-            <a:xfrm>
-              <a:off x="5804049" y="4621436"/>
-              <a:ext cx="670618" cy="670618"/>
-            </a:xfrm>
-            <a:prstGeom prst="rect">
-              <a:avLst/>
-            </a:prstGeom>
-          </p:spPr>
-        </p:pic>
-        <p:pic>
-          <p:nvPicPr>
-            <p:cNvPr id="5" name="圖片 4">
-              <a:extLst>
-                <a:ext uri="{FF2B5EF4-FFF2-40B4-BE49-F238E27FC236}">
-                  <a16:creationId xmlns:a16="http://schemas.microsoft.com/office/drawing/2014/main" id="{B455486C-A956-432E-AE71-BCAD4CA7D88D}"/>
-                </a:ext>
-              </a:extLst>
-            </p:cNvPr>
-            <p:cNvPicPr>
-              <a:picLocks noChangeAspect="1"/>
-            </p:cNvPicPr>
-            <p:nvPr/>
-          </p:nvPicPr>
-          <p:blipFill>
-            <a:blip r:embed="rId5"/>
-            <a:stretch>
-              <a:fillRect/>
-            </a:stretch>
-          </p:blipFill>
-          <p:spPr>
-            <a:xfrm>
-              <a:off x="5903194" y="4725902"/>
-              <a:ext cx="670618" cy="670618"/>
-            </a:xfrm>
-            <a:prstGeom prst="rect">
-              <a:avLst/>
-            </a:prstGeom>
-          </p:spPr>
-        </p:pic>
-        <p:pic>
-          <p:nvPicPr>
-            <p:cNvPr id="6" name="圖片 5">
-              <a:extLst>
-                <a:ext uri="{FF2B5EF4-FFF2-40B4-BE49-F238E27FC236}">
-                  <a16:creationId xmlns:a16="http://schemas.microsoft.com/office/drawing/2014/main" id="{BDBCD6B8-4108-44C2-AED7-5CF37DA09EAF}"/>
-                </a:ext>
-              </a:extLst>
-            </p:cNvPr>
-            <p:cNvPicPr>
-              <a:picLocks noChangeAspect="1"/>
-            </p:cNvPicPr>
-            <p:nvPr/>
-          </p:nvPicPr>
-          <p:blipFill>
-            <a:blip r:embed="rId5"/>
-            <a:stretch>
-              <a:fillRect/>
-            </a:stretch>
-          </p:blipFill>
-          <p:spPr>
-            <a:xfrm>
-              <a:off x="6002339" y="4830368"/>
-              <a:ext cx="670618" cy="670618"/>
-            </a:xfrm>
-            <a:prstGeom prst="rect">
-              <a:avLst/>
-            </a:prstGeom>
-          </p:spPr>
-        </p:pic>
-        <p:pic>
-          <p:nvPicPr>
-            <p:cNvPr id="7" name="圖片 6">
-              <a:extLst>
-                <a:ext uri="{FF2B5EF4-FFF2-40B4-BE49-F238E27FC236}">
-                  <a16:creationId xmlns:a16="http://schemas.microsoft.com/office/drawing/2014/main" id="{BA832F17-0450-4F26-8211-070503D23059}"/>
-                </a:ext>
-              </a:extLst>
-            </p:cNvPr>
-            <p:cNvPicPr>
-              <a:picLocks noChangeAspect="1"/>
-            </p:cNvPicPr>
-            <p:nvPr/>
-          </p:nvPicPr>
-          <p:blipFill>
-            <a:blip r:embed="rId5"/>
-            <a:stretch>
-              <a:fillRect/>
-            </a:stretch>
-          </p:blipFill>
-          <p:spPr>
-            <a:xfrm>
-              <a:off x="6108225" y="4936635"/>
-              <a:ext cx="670618" cy="670618"/>
-            </a:xfrm>
-            <a:prstGeom prst="rect">
-              <a:avLst/>
-            </a:prstGeom>
-          </p:spPr>
-        </p:pic>
-        <p:pic>
-          <p:nvPicPr>
-            <p:cNvPr id="8" name="圖片 7">
-              <a:extLst>
-                <a:ext uri="{FF2B5EF4-FFF2-40B4-BE49-F238E27FC236}">
-                  <a16:creationId xmlns:a16="http://schemas.microsoft.com/office/drawing/2014/main" id="{B0CED8F6-732E-4BD2-9AF0-3C57DE38691E}"/>
-                </a:ext>
-              </a:extLst>
-            </p:cNvPr>
-            <p:cNvPicPr>
-              <a:picLocks noChangeAspect="1"/>
-            </p:cNvPicPr>
-            <p:nvPr/>
-          </p:nvPicPr>
-          <p:blipFill>
-            <a:blip r:embed="rId5"/>
-            <a:stretch>
-              <a:fillRect/>
-            </a:stretch>
-          </p:blipFill>
-          <p:spPr>
-            <a:xfrm>
-              <a:off x="6223301" y="5042902"/>
-              <a:ext cx="670618" cy="670618"/>
-            </a:xfrm>
-            <a:prstGeom prst="rect">
-              <a:avLst/>
-            </a:prstGeom>
-          </p:spPr>
-        </p:pic>
-        <p:pic>
-          <p:nvPicPr>
-            <p:cNvPr id="10" name="圖片 9">
-              <a:extLst>
-                <a:ext uri="{FF2B5EF4-FFF2-40B4-BE49-F238E27FC236}">
-                  <a16:creationId xmlns:a16="http://schemas.microsoft.com/office/drawing/2014/main" id="{2DA74B12-61E6-4400-9098-8A710721265A}"/>
-                </a:ext>
-              </a:extLst>
-            </p:cNvPr>
-            <p:cNvPicPr>
-              <a:picLocks noChangeAspect="1"/>
-            </p:cNvPicPr>
-            <p:nvPr/>
-          </p:nvPicPr>
-          <p:blipFill>
-            <a:blip r:embed="rId5"/>
-            <a:stretch>
-              <a:fillRect/>
-            </a:stretch>
-          </p:blipFill>
-          <p:spPr>
-            <a:xfrm>
-              <a:off x="6337648" y="5138269"/>
-              <a:ext cx="670618" cy="670618"/>
-            </a:xfrm>
-            <a:prstGeom prst="rect">
-              <a:avLst/>
-            </a:prstGeom>
-          </p:spPr>
-        </p:pic>
-        <p:pic>
-          <p:nvPicPr>
-            <p:cNvPr id="18" name="圖片 17">
-              <a:extLst>
-                <a:ext uri="{FF2B5EF4-FFF2-40B4-BE49-F238E27FC236}">
-                  <a16:creationId xmlns:a16="http://schemas.microsoft.com/office/drawing/2014/main" id="{8708D514-2D75-4B6B-83CA-135FE8A1436F}"/>
-                </a:ext>
-              </a:extLst>
-            </p:cNvPr>
-            <p:cNvPicPr>
-              <a:picLocks noChangeAspect="1"/>
-            </p:cNvPicPr>
-            <p:nvPr/>
-          </p:nvPicPr>
-          <p:blipFill>
-            <a:blip r:embed="rId11"/>
-            <a:stretch>
-              <a:fillRect/>
-            </a:stretch>
-          </p:blipFill>
-          <p:spPr>
-            <a:xfrm>
-              <a:off x="8096655" y="4555751"/>
-              <a:ext cx="1019263" cy="856181"/>
-            </a:xfrm>
-            <a:prstGeom prst="rect">
-              <a:avLst/>
-            </a:prstGeom>
-          </p:spPr>
-        </p:pic>
-        <p:pic>
-          <p:nvPicPr>
-            <p:cNvPr id="35" name="圖片 34">
-              <a:extLst>
-                <a:ext uri="{FF2B5EF4-FFF2-40B4-BE49-F238E27FC236}">
-                  <a16:creationId xmlns:a16="http://schemas.microsoft.com/office/drawing/2014/main" id="{561EE4E3-C437-4747-91DE-D4F37536315E}"/>
-                </a:ext>
-              </a:extLst>
-            </p:cNvPr>
-            <p:cNvPicPr>
-              <a:picLocks noChangeAspect="1"/>
-            </p:cNvPicPr>
-            <p:nvPr/>
-          </p:nvPicPr>
-          <p:blipFill>
-            <a:blip r:embed="rId12"/>
-            <a:stretch>
-              <a:fillRect/>
-            </a:stretch>
-          </p:blipFill>
-          <p:spPr>
-            <a:xfrm>
-              <a:off x="8195800" y="4645250"/>
-              <a:ext cx="1018120" cy="859611"/>
-            </a:xfrm>
-            <a:prstGeom prst="rect">
-              <a:avLst/>
-            </a:prstGeom>
-          </p:spPr>
-        </p:pic>
-        <p:pic>
-          <p:nvPicPr>
-            <p:cNvPr id="37" name="圖片 36">
-              <a:extLst>
-                <a:ext uri="{FF2B5EF4-FFF2-40B4-BE49-F238E27FC236}">
-                  <a16:creationId xmlns:a16="http://schemas.microsoft.com/office/drawing/2014/main" id="{5BF33A54-7707-4A5F-AB43-AEBCA579E1C6}"/>
-                </a:ext>
-              </a:extLst>
-            </p:cNvPr>
-            <p:cNvPicPr>
-              <a:picLocks noChangeAspect="1"/>
-            </p:cNvPicPr>
-            <p:nvPr/>
-          </p:nvPicPr>
-          <p:blipFill>
-            <a:blip r:embed="rId12"/>
-            <a:stretch>
-              <a:fillRect/>
-            </a:stretch>
-          </p:blipFill>
-          <p:spPr>
-            <a:xfrm>
-              <a:off x="8294945" y="4740211"/>
-              <a:ext cx="1018120" cy="859611"/>
-            </a:xfrm>
-            <a:prstGeom prst="rect">
-              <a:avLst/>
-            </a:prstGeom>
-          </p:spPr>
-        </p:pic>
-        <p:pic>
-          <p:nvPicPr>
-            <p:cNvPr id="39" name="圖片 38">
-              <a:extLst>
-                <a:ext uri="{FF2B5EF4-FFF2-40B4-BE49-F238E27FC236}">
-                  <a16:creationId xmlns:a16="http://schemas.microsoft.com/office/drawing/2014/main" id="{4242788A-16E6-41A1-9A9A-04B3CCC35E38}"/>
-                </a:ext>
-              </a:extLst>
-            </p:cNvPr>
-            <p:cNvPicPr>
-              <a:picLocks noChangeAspect="1"/>
-            </p:cNvPicPr>
-            <p:nvPr/>
-          </p:nvPicPr>
-          <p:blipFill>
-            <a:blip r:embed="rId12"/>
-            <a:stretch>
-              <a:fillRect/>
-            </a:stretch>
-          </p:blipFill>
-          <p:spPr>
-            <a:xfrm>
-              <a:off x="8390981" y="4842138"/>
-              <a:ext cx="1018120" cy="859611"/>
-            </a:xfrm>
-            <a:prstGeom prst="rect">
-              <a:avLst/>
-            </a:prstGeom>
-          </p:spPr>
-        </p:pic>
-        <p:pic>
-          <p:nvPicPr>
-            <p:cNvPr id="41" name="圖片 40">
-              <a:extLst>
-                <a:ext uri="{FF2B5EF4-FFF2-40B4-BE49-F238E27FC236}">
-                  <a16:creationId xmlns:a16="http://schemas.microsoft.com/office/drawing/2014/main" id="{A8B060AE-9691-4B29-8E4C-0FB63878A29C}"/>
-                </a:ext>
-              </a:extLst>
-            </p:cNvPr>
-            <p:cNvPicPr>
-              <a:picLocks noChangeAspect="1"/>
-            </p:cNvPicPr>
-            <p:nvPr/>
-          </p:nvPicPr>
-          <p:blipFill>
-            <a:blip r:embed="rId12"/>
-            <a:stretch>
-              <a:fillRect/>
-            </a:stretch>
-          </p:blipFill>
-          <p:spPr>
-            <a:xfrm>
-              <a:off x="8508063" y="4944065"/>
-              <a:ext cx="1018120" cy="859611"/>
-            </a:xfrm>
-            <a:prstGeom prst="rect">
-              <a:avLst/>
-            </a:prstGeom>
-          </p:spPr>
-        </p:pic>
-        <p:pic>
-          <p:nvPicPr>
-            <p:cNvPr id="42" name="圖片 41">
-              <a:extLst>
-                <a:ext uri="{FF2B5EF4-FFF2-40B4-BE49-F238E27FC236}">
-                  <a16:creationId xmlns:a16="http://schemas.microsoft.com/office/drawing/2014/main" id="{ED28C492-6CC5-4D96-96B4-C80166F447F2}"/>
-                </a:ext>
-              </a:extLst>
-            </p:cNvPr>
-            <p:cNvPicPr>
-              <a:picLocks noChangeAspect="1"/>
-            </p:cNvPicPr>
-            <p:nvPr/>
-          </p:nvPicPr>
-          <p:blipFill>
-            <a:blip r:embed="rId12"/>
-            <a:stretch>
-              <a:fillRect/>
-            </a:stretch>
-          </p:blipFill>
-          <p:spPr>
-            <a:xfrm>
-              <a:off x="8630254" y="5042902"/>
-              <a:ext cx="1018120" cy="859611"/>
-            </a:xfrm>
-            <a:prstGeom prst="rect">
-              <a:avLst/>
-            </a:prstGeom>
-          </p:spPr>
-        </p:pic>
-        <p:sp>
-          <p:nvSpPr>
-            <p:cNvPr id="44" name="文字方塊 43">
-              <a:extLst>
-                <a:ext uri="{FF2B5EF4-FFF2-40B4-BE49-F238E27FC236}">
-                  <a16:creationId xmlns:a16="http://schemas.microsoft.com/office/drawing/2014/main" id="{F7FB2828-1970-4285-A288-1F8E61FF8F69}"/>
-                </a:ext>
-              </a:extLst>
-            </p:cNvPr>
-            <p:cNvSpPr txBox="1"/>
-            <p:nvPr/>
-          </p:nvSpPr>
-          <p:spPr>
-            <a:xfrm>
-              <a:off x="3719816" y="6054571"/>
-              <a:ext cx="793109" cy="369332"/>
-            </a:xfrm>
-            <a:prstGeom prst="rect">
-              <a:avLst/>
-            </a:prstGeom>
-            <a:noFill/>
-          </p:spPr>
-          <p:txBody>
-            <a:bodyPr wrap="square" rtlCol="0">
-              <a:spAutoFit/>
-            </a:bodyPr>
-            <a:lstStyle/>
-            <a:p>
-              <a:r>
-                <a:rPr lang="en-US" altLang="zh-HK" dirty="0"/>
-                <a:t>n, n, 1</a:t>
-              </a:r>
-              <a:endParaRPr lang="zh-HK" altLang="en-US" dirty="0"/>
-            </a:p>
-          </p:txBody>
-        </p:sp>
-        <p:sp>
-          <p:nvSpPr>
-            <p:cNvPr id="97" name="文字方塊 96">
-              <a:extLst>
-                <a:ext uri="{FF2B5EF4-FFF2-40B4-BE49-F238E27FC236}">
-                  <a16:creationId xmlns:a16="http://schemas.microsoft.com/office/drawing/2014/main" id="{A8B7461B-4B86-4C26-A8D8-5013D72454ED}"/>
-                </a:ext>
-              </a:extLst>
-            </p:cNvPr>
-            <p:cNvSpPr txBox="1"/>
-            <p:nvPr/>
-          </p:nvSpPr>
-          <p:spPr>
-            <a:xfrm>
-              <a:off x="6100810" y="6054571"/>
-              <a:ext cx="793109" cy="369332"/>
-            </a:xfrm>
-            <a:prstGeom prst="rect">
-              <a:avLst/>
-            </a:prstGeom>
-            <a:noFill/>
-          </p:spPr>
-          <p:txBody>
-            <a:bodyPr wrap="square" rtlCol="0">
-              <a:spAutoFit/>
-            </a:bodyPr>
-            <a:lstStyle/>
-            <a:p>
-              <a:r>
-                <a:rPr lang="en-US" altLang="zh-HK" dirty="0"/>
-                <a:t>k, k, f</a:t>
-              </a:r>
-              <a:endParaRPr lang="zh-HK" altLang="en-US" dirty="0"/>
-            </a:p>
-          </p:txBody>
-        </p:sp>
-        <p:sp>
-          <p:nvSpPr>
-            <p:cNvPr id="98" name="文字方塊 97">
-              <a:extLst>
-                <a:ext uri="{FF2B5EF4-FFF2-40B4-BE49-F238E27FC236}">
-                  <a16:creationId xmlns:a16="http://schemas.microsoft.com/office/drawing/2014/main" id="{9B5A0096-3668-4A1E-A7EA-369669293D48}"/>
-                </a:ext>
-              </a:extLst>
-            </p:cNvPr>
-            <p:cNvSpPr txBox="1"/>
-            <p:nvPr/>
-          </p:nvSpPr>
-          <p:spPr>
-            <a:xfrm>
-              <a:off x="8193220" y="6054571"/>
-              <a:ext cx="1845396" cy="369332"/>
-            </a:xfrm>
-            <a:prstGeom prst="rect">
-              <a:avLst/>
-            </a:prstGeom>
-            <a:noFill/>
-          </p:spPr>
-          <p:txBody>
-            <a:bodyPr wrap="square" rtlCol="0">
-              <a:spAutoFit/>
-            </a:bodyPr>
-            <a:lstStyle/>
-            <a:p>
-              <a:r>
-                <a:rPr lang="en-US" altLang="zh-HK" dirty="0"/>
-                <a:t>(n-k+1), (n-k+1), f</a:t>
-              </a:r>
-              <a:endParaRPr lang="zh-HK" altLang="en-US" dirty="0"/>
-            </a:p>
-          </p:txBody>
-        </p:sp>
-        <p:sp>
-          <p:nvSpPr>
-            <p:cNvPr id="46" name="文字方塊 45">
-              <a:extLst>
-                <a:ext uri="{FF2B5EF4-FFF2-40B4-BE49-F238E27FC236}">
-                  <a16:creationId xmlns:a16="http://schemas.microsoft.com/office/drawing/2014/main" id="{E78531B9-F8C5-4F3B-83CF-65BB08BB768D}"/>
-                </a:ext>
-              </a:extLst>
-            </p:cNvPr>
-            <p:cNvSpPr txBox="1"/>
-            <p:nvPr/>
-          </p:nvSpPr>
-          <p:spPr>
-            <a:xfrm>
-              <a:off x="5127662" y="5042902"/>
-              <a:ext cx="371086" cy="584775"/>
-            </a:xfrm>
-            <a:prstGeom prst="rect">
-              <a:avLst/>
-            </a:prstGeom>
-            <a:noFill/>
-          </p:spPr>
-          <p:txBody>
-            <a:bodyPr wrap="square" rtlCol="0">
-              <a:spAutoFit/>
-            </a:bodyPr>
-            <a:lstStyle/>
-            <a:p>
-              <a:r>
-                <a:rPr lang="en-US" altLang="zh-HK" sz="3200" dirty="0"/>
-                <a:t>*</a:t>
-              </a:r>
-              <a:endParaRPr lang="zh-HK" altLang="en-US" sz="3200" dirty="0"/>
-            </a:p>
-          </p:txBody>
-        </p:sp>
-        <p:sp>
-          <p:nvSpPr>
-            <p:cNvPr id="99" name="文字方塊 98">
-              <a:extLst>
-                <a:ext uri="{FF2B5EF4-FFF2-40B4-BE49-F238E27FC236}">
-                  <a16:creationId xmlns:a16="http://schemas.microsoft.com/office/drawing/2014/main" id="{757F40FB-EAF6-4663-9949-65B6A5C76C4C}"/>
-                </a:ext>
-              </a:extLst>
-            </p:cNvPr>
-            <p:cNvSpPr txBox="1"/>
-            <p:nvPr/>
-          </p:nvSpPr>
-          <p:spPr>
-            <a:xfrm>
-              <a:off x="7392735" y="4983841"/>
-              <a:ext cx="371086" cy="584775"/>
-            </a:xfrm>
-            <a:prstGeom prst="rect">
-              <a:avLst/>
-            </a:prstGeom>
-            <a:noFill/>
-          </p:spPr>
-          <p:txBody>
-            <a:bodyPr wrap="square" rtlCol="0">
-              <a:spAutoFit/>
-            </a:bodyPr>
-            <a:lstStyle/>
-            <a:p>
-              <a:r>
-                <a:rPr lang="en-US" altLang="zh-HK" sz="3200" dirty="0"/>
-                <a:t>=</a:t>
-              </a:r>
-              <a:endParaRPr lang="zh-HK" altLang="en-US" sz="3200" dirty="0"/>
-            </a:p>
-          </p:txBody>
-        </p:sp>
-        <p:cxnSp>
-          <p:nvCxnSpPr>
-            <p:cNvPr id="100" name="直線單箭頭接點 99">
-              <a:extLst>
-                <a:ext uri="{FF2B5EF4-FFF2-40B4-BE49-F238E27FC236}">
-                  <a16:creationId xmlns:a16="http://schemas.microsoft.com/office/drawing/2014/main" id="{29BD2765-6721-4F6A-94E8-B8FDEADAE25E}"/>
-                </a:ext>
-              </a:extLst>
-            </p:cNvPr>
-            <p:cNvCxnSpPr/>
-            <p:nvPr/>
-          </p:nvCxnSpPr>
-          <p:spPr>
-            <a:xfrm flipH="1">
-              <a:off x="7002007" y="4965471"/>
-              <a:ext cx="315756" cy="191479"/>
-            </a:xfrm>
-            <a:prstGeom prst="straightConnector1">
-              <a:avLst/>
-            </a:prstGeom>
-            <a:ln>
-              <a:tailEnd type="triangle"/>
-            </a:ln>
-          </p:spPr>
-          <p:style>
-            <a:lnRef idx="2">
-              <a:schemeClr val="accent1"/>
-            </a:lnRef>
-            <a:fillRef idx="0">
-              <a:schemeClr val="accent1"/>
-            </a:fillRef>
-            <a:effectRef idx="1">
-              <a:schemeClr val="accent1"/>
-            </a:effectRef>
-            <a:fontRef idx="minor">
-              <a:schemeClr val="tx1"/>
-            </a:fontRef>
-          </p:style>
-        </p:cxnSp>
-        <p:grpSp>
-          <p:nvGrpSpPr>
-            <p:cNvPr id="53" name="群組 52">
-              <a:extLst>
-                <a:ext uri="{FF2B5EF4-FFF2-40B4-BE49-F238E27FC236}">
-                  <a16:creationId xmlns:a16="http://schemas.microsoft.com/office/drawing/2014/main" id="{647C5896-09A4-4888-A878-BF9158B8285E}"/>
+                  <a16:creationId xmlns:a16="http://schemas.microsoft.com/office/drawing/2014/main" id="{8409D2FB-5C9F-45CF-8656-A00DAA003C07}"/>
                 </a:ext>
               </a:extLst>
             </p:cNvPr>
@@ -6814,18 +6190,604 @@
           </p:nvGrpSpPr>
           <p:grpSpPr>
             <a:xfrm>
-              <a:off x="6497364" y="4225038"/>
-              <a:ext cx="433222" cy="396398"/>
-              <a:chOff x="6497364" y="4225038"/>
-              <a:chExt cx="433222" cy="396398"/>
+              <a:off x="3402845" y="4167402"/>
+              <a:ext cx="6682768" cy="2256501"/>
+              <a:chOff x="3402845" y="4167402"/>
+              <a:chExt cx="6682768" cy="2256501"/>
             </a:xfrm>
           </p:grpSpPr>
+          <p:sp>
+            <p:nvSpPr>
+              <p:cNvPr id="3" name="矩形 2">
+                <a:extLst>
+                  <a:ext uri="{FF2B5EF4-FFF2-40B4-BE49-F238E27FC236}">
+                    <a16:creationId xmlns:a16="http://schemas.microsoft.com/office/drawing/2014/main" id="{D846CACC-4AF0-4AAE-B4D5-E6DCF62332B6}"/>
+                  </a:ext>
+                </a:extLst>
+              </p:cNvPr>
+              <p:cNvSpPr/>
+              <p:nvPr/>
+            </p:nvSpPr>
+            <p:spPr>
+              <a:xfrm>
+                <a:off x="3402845" y="4509856"/>
+                <a:ext cx="1502644" cy="1265364"/>
+              </a:xfrm>
+              <a:prstGeom prst="rect">
+                <a:avLst/>
+              </a:prstGeom>
+            </p:spPr>
+            <p:style>
+              <a:lnRef idx="2">
+                <a:schemeClr val="accent1">
+                  <a:shade val="50000"/>
+                </a:schemeClr>
+              </a:lnRef>
+              <a:fillRef idx="1">
+                <a:schemeClr val="accent1"/>
+              </a:fillRef>
+              <a:effectRef idx="0">
+                <a:schemeClr val="accent1"/>
+              </a:effectRef>
+              <a:fontRef idx="minor">
+                <a:schemeClr val="lt1"/>
+              </a:fontRef>
+            </p:style>
+            <p:txBody>
+              <a:bodyPr rtlCol="0" anchor="ctr"/>
+              <a:lstStyle/>
+              <a:p>
+                <a:pPr algn="ctr"/>
+                <a:endParaRPr lang="zh-HK" altLang="en-US"/>
+              </a:p>
+            </p:txBody>
+          </p:sp>
+          <p:pic>
+            <p:nvPicPr>
+              <p:cNvPr id="4" name="圖片 3">
+                <a:extLst>
+                  <a:ext uri="{FF2B5EF4-FFF2-40B4-BE49-F238E27FC236}">
+                    <a16:creationId xmlns:a16="http://schemas.microsoft.com/office/drawing/2014/main" id="{DD86D3E5-F3F2-4108-A7D9-7D6273EF88B8}"/>
+                  </a:ext>
+                </a:extLst>
+              </p:cNvPr>
+              <p:cNvPicPr>
+                <a:picLocks noChangeAspect="1"/>
+              </p:cNvPicPr>
+              <p:nvPr/>
+            </p:nvPicPr>
+            <p:blipFill>
+              <a:blip r:embed="rId5"/>
+              <a:stretch>
+                <a:fillRect/>
+              </a:stretch>
+            </p:blipFill>
+            <p:spPr>
+              <a:xfrm>
+                <a:off x="5804049" y="4621436"/>
+                <a:ext cx="670618" cy="670618"/>
+              </a:xfrm>
+              <a:prstGeom prst="rect">
+                <a:avLst/>
+              </a:prstGeom>
+            </p:spPr>
+          </p:pic>
+          <p:pic>
+            <p:nvPicPr>
+              <p:cNvPr id="5" name="圖片 4">
+                <a:extLst>
+                  <a:ext uri="{FF2B5EF4-FFF2-40B4-BE49-F238E27FC236}">
+                    <a16:creationId xmlns:a16="http://schemas.microsoft.com/office/drawing/2014/main" id="{B455486C-A956-432E-AE71-BCAD4CA7D88D}"/>
+                  </a:ext>
+                </a:extLst>
+              </p:cNvPr>
+              <p:cNvPicPr>
+                <a:picLocks noChangeAspect="1"/>
+              </p:cNvPicPr>
+              <p:nvPr/>
+            </p:nvPicPr>
+            <p:blipFill>
+              <a:blip r:embed="rId5"/>
+              <a:stretch>
+                <a:fillRect/>
+              </a:stretch>
+            </p:blipFill>
+            <p:spPr>
+              <a:xfrm>
+                <a:off x="5903194" y="4725902"/>
+                <a:ext cx="670618" cy="670618"/>
+              </a:xfrm>
+              <a:prstGeom prst="rect">
+                <a:avLst/>
+              </a:prstGeom>
+            </p:spPr>
+          </p:pic>
+          <p:pic>
+            <p:nvPicPr>
+              <p:cNvPr id="6" name="圖片 5">
+                <a:extLst>
+                  <a:ext uri="{FF2B5EF4-FFF2-40B4-BE49-F238E27FC236}">
+                    <a16:creationId xmlns:a16="http://schemas.microsoft.com/office/drawing/2014/main" id="{BDBCD6B8-4108-44C2-AED7-5CF37DA09EAF}"/>
+                  </a:ext>
+                </a:extLst>
+              </p:cNvPr>
+              <p:cNvPicPr>
+                <a:picLocks noChangeAspect="1"/>
+              </p:cNvPicPr>
+              <p:nvPr/>
+            </p:nvPicPr>
+            <p:blipFill>
+              <a:blip r:embed="rId5"/>
+              <a:stretch>
+                <a:fillRect/>
+              </a:stretch>
+            </p:blipFill>
+            <p:spPr>
+              <a:xfrm>
+                <a:off x="6002339" y="4830368"/>
+                <a:ext cx="670618" cy="670618"/>
+              </a:xfrm>
+              <a:prstGeom prst="rect">
+                <a:avLst/>
+              </a:prstGeom>
+            </p:spPr>
+          </p:pic>
+          <p:pic>
+            <p:nvPicPr>
+              <p:cNvPr id="7" name="圖片 6">
+                <a:extLst>
+                  <a:ext uri="{FF2B5EF4-FFF2-40B4-BE49-F238E27FC236}">
+                    <a16:creationId xmlns:a16="http://schemas.microsoft.com/office/drawing/2014/main" id="{BA832F17-0450-4F26-8211-070503D23059}"/>
+                  </a:ext>
+                </a:extLst>
+              </p:cNvPr>
+              <p:cNvPicPr>
+                <a:picLocks noChangeAspect="1"/>
+              </p:cNvPicPr>
+              <p:nvPr/>
+            </p:nvPicPr>
+            <p:blipFill>
+              <a:blip r:embed="rId5"/>
+              <a:stretch>
+                <a:fillRect/>
+              </a:stretch>
+            </p:blipFill>
+            <p:spPr>
+              <a:xfrm>
+                <a:off x="6108225" y="4936635"/>
+                <a:ext cx="670618" cy="670618"/>
+              </a:xfrm>
+              <a:prstGeom prst="rect">
+                <a:avLst/>
+              </a:prstGeom>
+            </p:spPr>
+          </p:pic>
+          <p:pic>
+            <p:nvPicPr>
+              <p:cNvPr id="8" name="圖片 7">
+                <a:extLst>
+                  <a:ext uri="{FF2B5EF4-FFF2-40B4-BE49-F238E27FC236}">
+                    <a16:creationId xmlns:a16="http://schemas.microsoft.com/office/drawing/2014/main" id="{B0CED8F6-732E-4BD2-9AF0-3C57DE38691E}"/>
+                  </a:ext>
+                </a:extLst>
+              </p:cNvPr>
+              <p:cNvPicPr>
+                <a:picLocks noChangeAspect="1"/>
+              </p:cNvPicPr>
+              <p:nvPr/>
+            </p:nvPicPr>
+            <p:blipFill>
+              <a:blip r:embed="rId5"/>
+              <a:stretch>
+                <a:fillRect/>
+              </a:stretch>
+            </p:blipFill>
+            <p:spPr>
+              <a:xfrm>
+                <a:off x="6223301" y="5042902"/>
+                <a:ext cx="670618" cy="670618"/>
+              </a:xfrm>
+              <a:prstGeom prst="rect">
+                <a:avLst/>
+              </a:prstGeom>
+            </p:spPr>
+          </p:pic>
+          <p:pic>
+            <p:nvPicPr>
+              <p:cNvPr id="10" name="圖片 9">
+                <a:extLst>
+                  <a:ext uri="{FF2B5EF4-FFF2-40B4-BE49-F238E27FC236}">
+                    <a16:creationId xmlns:a16="http://schemas.microsoft.com/office/drawing/2014/main" id="{2DA74B12-61E6-4400-9098-8A710721265A}"/>
+                  </a:ext>
+                </a:extLst>
+              </p:cNvPr>
+              <p:cNvPicPr>
+                <a:picLocks noChangeAspect="1"/>
+              </p:cNvPicPr>
+              <p:nvPr/>
+            </p:nvPicPr>
+            <p:blipFill>
+              <a:blip r:embed="rId5"/>
+              <a:stretch>
+                <a:fillRect/>
+              </a:stretch>
+            </p:blipFill>
+            <p:spPr>
+              <a:xfrm>
+                <a:off x="6337648" y="5138269"/>
+                <a:ext cx="670618" cy="670618"/>
+              </a:xfrm>
+              <a:prstGeom prst="rect">
+                <a:avLst/>
+              </a:prstGeom>
+            </p:spPr>
+          </p:pic>
+          <p:pic>
+            <p:nvPicPr>
+              <p:cNvPr id="18" name="圖片 17">
+                <a:extLst>
+                  <a:ext uri="{FF2B5EF4-FFF2-40B4-BE49-F238E27FC236}">
+                    <a16:creationId xmlns:a16="http://schemas.microsoft.com/office/drawing/2014/main" id="{8708D514-2D75-4B6B-83CA-135FE8A1436F}"/>
+                  </a:ext>
+                </a:extLst>
+              </p:cNvPr>
+              <p:cNvPicPr>
+                <a:picLocks noChangeAspect="1"/>
+              </p:cNvPicPr>
+              <p:nvPr/>
+            </p:nvPicPr>
+            <p:blipFill>
+              <a:blip r:embed="rId11"/>
+              <a:stretch>
+                <a:fillRect/>
+              </a:stretch>
+            </p:blipFill>
+            <p:spPr>
+              <a:xfrm>
+                <a:off x="8096655" y="4555751"/>
+                <a:ext cx="1019263" cy="856181"/>
+              </a:xfrm>
+              <a:prstGeom prst="rect">
+                <a:avLst/>
+              </a:prstGeom>
+            </p:spPr>
+          </p:pic>
+          <p:pic>
+            <p:nvPicPr>
+              <p:cNvPr id="35" name="圖片 34">
+                <a:extLst>
+                  <a:ext uri="{FF2B5EF4-FFF2-40B4-BE49-F238E27FC236}">
+                    <a16:creationId xmlns:a16="http://schemas.microsoft.com/office/drawing/2014/main" id="{561EE4E3-C437-4747-91DE-D4F37536315E}"/>
+                  </a:ext>
+                </a:extLst>
+              </p:cNvPr>
+              <p:cNvPicPr>
+                <a:picLocks noChangeAspect="1"/>
+              </p:cNvPicPr>
+              <p:nvPr/>
+            </p:nvPicPr>
+            <p:blipFill>
+              <a:blip r:embed="rId12"/>
+              <a:stretch>
+                <a:fillRect/>
+              </a:stretch>
+            </p:blipFill>
+            <p:spPr>
+              <a:xfrm>
+                <a:off x="8195800" y="4645250"/>
+                <a:ext cx="1018120" cy="859611"/>
+              </a:xfrm>
+              <a:prstGeom prst="rect">
+                <a:avLst/>
+              </a:prstGeom>
+            </p:spPr>
+          </p:pic>
+          <p:pic>
+            <p:nvPicPr>
+              <p:cNvPr id="37" name="圖片 36">
+                <a:extLst>
+                  <a:ext uri="{FF2B5EF4-FFF2-40B4-BE49-F238E27FC236}">
+                    <a16:creationId xmlns:a16="http://schemas.microsoft.com/office/drawing/2014/main" id="{5BF33A54-7707-4A5F-AB43-AEBCA579E1C6}"/>
+                  </a:ext>
+                </a:extLst>
+              </p:cNvPr>
+              <p:cNvPicPr>
+                <a:picLocks noChangeAspect="1"/>
+              </p:cNvPicPr>
+              <p:nvPr/>
+            </p:nvPicPr>
+            <p:blipFill>
+              <a:blip r:embed="rId12"/>
+              <a:stretch>
+                <a:fillRect/>
+              </a:stretch>
+            </p:blipFill>
+            <p:spPr>
+              <a:xfrm>
+                <a:off x="8294945" y="4740211"/>
+                <a:ext cx="1018120" cy="859611"/>
+              </a:xfrm>
+              <a:prstGeom prst="rect">
+                <a:avLst/>
+              </a:prstGeom>
+            </p:spPr>
+          </p:pic>
+          <p:pic>
+            <p:nvPicPr>
+              <p:cNvPr id="39" name="圖片 38">
+                <a:extLst>
+                  <a:ext uri="{FF2B5EF4-FFF2-40B4-BE49-F238E27FC236}">
+                    <a16:creationId xmlns:a16="http://schemas.microsoft.com/office/drawing/2014/main" id="{4242788A-16E6-41A1-9A9A-04B3CCC35E38}"/>
+                  </a:ext>
+                </a:extLst>
+              </p:cNvPr>
+              <p:cNvPicPr>
+                <a:picLocks noChangeAspect="1"/>
+              </p:cNvPicPr>
+              <p:nvPr/>
+            </p:nvPicPr>
+            <p:blipFill>
+              <a:blip r:embed="rId12"/>
+              <a:stretch>
+                <a:fillRect/>
+              </a:stretch>
+            </p:blipFill>
+            <p:spPr>
+              <a:xfrm>
+                <a:off x="8390981" y="4842138"/>
+                <a:ext cx="1018120" cy="859611"/>
+              </a:xfrm>
+              <a:prstGeom prst="rect">
+                <a:avLst/>
+              </a:prstGeom>
+            </p:spPr>
+          </p:pic>
+          <p:pic>
+            <p:nvPicPr>
+              <p:cNvPr id="41" name="圖片 40">
+                <a:extLst>
+                  <a:ext uri="{FF2B5EF4-FFF2-40B4-BE49-F238E27FC236}">
+                    <a16:creationId xmlns:a16="http://schemas.microsoft.com/office/drawing/2014/main" id="{A8B060AE-9691-4B29-8E4C-0FB63878A29C}"/>
+                  </a:ext>
+                </a:extLst>
+              </p:cNvPr>
+              <p:cNvPicPr>
+                <a:picLocks noChangeAspect="1"/>
+              </p:cNvPicPr>
+              <p:nvPr/>
+            </p:nvPicPr>
+            <p:blipFill>
+              <a:blip r:embed="rId12"/>
+              <a:stretch>
+                <a:fillRect/>
+              </a:stretch>
+            </p:blipFill>
+            <p:spPr>
+              <a:xfrm>
+                <a:off x="8508063" y="4944065"/>
+                <a:ext cx="1018120" cy="859611"/>
+              </a:xfrm>
+              <a:prstGeom prst="rect">
+                <a:avLst/>
+              </a:prstGeom>
+            </p:spPr>
+          </p:pic>
+          <p:pic>
+            <p:nvPicPr>
+              <p:cNvPr id="42" name="圖片 41">
+                <a:extLst>
+                  <a:ext uri="{FF2B5EF4-FFF2-40B4-BE49-F238E27FC236}">
+                    <a16:creationId xmlns:a16="http://schemas.microsoft.com/office/drawing/2014/main" id="{ED28C492-6CC5-4D96-96B4-C80166F447F2}"/>
+                  </a:ext>
+                </a:extLst>
+              </p:cNvPr>
+              <p:cNvPicPr>
+                <a:picLocks noChangeAspect="1"/>
+              </p:cNvPicPr>
+              <p:nvPr/>
+            </p:nvPicPr>
+            <p:blipFill>
+              <a:blip r:embed="rId12"/>
+              <a:stretch>
+                <a:fillRect/>
+              </a:stretch>
+            </p:blipFill>
+            <p:spPr>
+              <a:xfrm>
+                <a:off x="8630254" y="5042902"/>
+                <a:ext cx="1018120" cy="859611"/>
+              </a:xfrm>
+              <a:prstGeom prst="rect">
+                <a:avLst/>
+              </a:prstGeom>
+            </p:spPr>
+          </p:pic>
+          <p:sp>
+            <p:nvSpPr>
+              <p:cNvPr id="44" name="文字方塊 43">
+                <a:extLst>
+                  <a:ext uri="{FF2B5EF4-FFF2-40B4-BE49-F238E27FC236}">
+                    <a16:creationId xmlns:a16="http://schemas.microsoft.com/office/drawing/2014/main" id="{F7FB2828-1970-4285-A288-1F8E61FF8F69}"/>
+                  </a:ext>
+                </a:extLst>
+              </p:cNvPr>
+              <p:cNvSpPr txBox="1"/>
+              <p:nvPr/>
+            </p:nvSpPr>
+            <p:spPr>
+              <a:xfrm>
+                <a:off x="3719816" y="6054571"/>
+                <a:ext cx="793109" cy="369332"/>
+              </a:xfrm>
+              <a:prstGeom prst="rect">
+                <a:avLst/>
+              </a:prstGeom>
+              <a:noFill/>
+            </p:spPr>
+            <p:txBody>
+              <a:bodyPr wrap="square" rtlCol="0">
+                <a:spAutoFit/>
+              </a:bodyPr>
+              <a:lstStyle/>
+              <a:p>
+                <a:r>
+                  <a:rPr lang="en-US" altLang="zh-HK" dirty="0"/>
+                  <a:t>n, n, 1</a:t>
+                </a:r>
+                <a:endParaRPr lang="zh-HK" altLang="en-US" dirty="0"/>
+              </a:p>
+            </p:txBody>
+          </p:sp>
+          <p:sp>
+            <p:nvSpPr>
+              <p:cNvPr id="97" name="文字方塊 96">
+                <a:extLst>
+                  <a:ext uri="{FF2B5EF4-FFF2-40B4-BE49-F238E27FC236}">
+                    <a16:creationId xmlns:a16="http://schemas.microsoft.com/office/drawing/2014/main" id="{A8B7461B-4B86-4C26-A8D8-5013D72454ED}"/>
+                  </a:ext>
+                </a:extLst>
+              </p:cNvPr>
+              <p:cNvSpPr txBox="1"/>
+              <p:nvPr/>
+            </p:nvSpPr>
+            <p:spPr>
+              <a:xfrm>
+                <a:off x="6100810" y="6054571"/>
+                <a:ext cx="793109" cy="369332"/>
+              </a:xfrm>
+              <a:prstGeom prst="rect">
+                <a:avLst/>
+              </a:prstGeom>
+              <a:noFill/>
+            </p:spPr>
+            <p:txBody>
+              <a:bodyPr wrap="square" rtlCol="0">
+                <a:spAutoFit/>
+              </a:bodyPr>
+              <a:lstStyle/>
+              <a:p>
+                <a:r>
+                  <a:rPr lang="en-US" altLang="zh-HK" dirty="0"/>
+                  <a:t>k, k, f</a:t>
+                </a:r>
+                <a:endParaRPr lang="zh-HK" altLang="en-US" dirty="0"/>
+              </a:p>
+            </p:txBody>
+          </p:sp>
+          <p:sp>
+            <p:nvSpPr>
+              <p:cNvPr id="98" name="文字方塊 97">
+                <a:extLst>
+                  <a:ext uri="{FF2B5EF4-FFF2-40B4-BE49-F238E27FC236}">
+                    <a16:creationId xmlns:a16="http://schemas.microsoft.com/office/drawing/2014/main" id="{9B5A0096-3668-4A1E-A7EA-369669293D48}"/>
+                  </a:ext>
+                </a:extLst>
+              </p:cNvPr>
+              <p:cNvSpPr txBox="1"/>
+              <p:nvPr/>
+            </p:nvSpPr>
+            <p:spPr>
+              <a:xfrm>
+                <a:off x="8193220" y="6054571"/>
+                <a:ext cx="1845396" cy="369332"/>
+              </a:xfrm>
+              <a:prstGeom prst="rect">
+                <a:avLst/>
+              </a:prstGeom>
+              <a:noFill/>
+            </p:spPr>
+            <p:txBody>
+              <a:bodyPr wrap="square" rtlCol="0">
+                <a:spAutoFit/>
+              </a:bodyPr>
+              <a:lstStyle/>
+              <a:p>
+                <a:r>
+                  <a:rPr lang="en-US" altLang="zh-HK" dirty="0"/>
+                  <a:t>(n-k+1), (n-k+1), f</a:t>
+                </a:r>
+                <a:endParaRPr lang="zh-HK" altLang="en-US" dirty="0"/>
+              </a:p>
+            </p:txBody>
+          </p:sp>
+          <p:sp>
+            <p:nvSpPr>
+              <p:cNvPr id="46" name="文字方塊 45">
+                <a:extLst>
+                  <a:ext uri="{FF2B5EF4-FFF2-40B4-BE49-F238E27FC236}">
+                    <a16:creationId xmlns:a16="http://schemas.microsoft.com/office/drawing/2014/main" id="{E78531B9-F8C5-4F3B-83CF-65BB08BB768D}"/>
+                  </a:ext>
+                </a:extLst>
+              </p:cNvPr>
+              <p:cNvSpPr txBox="1"/>
+              <p:nvPr/>
+            </p:nvSpPr>
+            <p:spPr>
+              <a:xfrm>
+                <a:off x="5127662" y="5042902"/>
+                <a:ext cx="371086" cy="584775"/>
+              </a:xfrm>
+              <a:prstGeom prst="rect">
+                <a:avLst/>
+              </a:prstGeom>
+              <a:noFill/>
+            </p:spPr>
+            <p:txBody>
+              <a:bodyPr wrap="square" rtlCol="0">
+                <a:spAutoFit/>
+              </a:bodyPr>
+              <a:lstStyle/>
+              <a:p>
+                <a:r>
+                  <a:rPr lang="en-US" altLang="zh-HK" sz="3200" dirty="0"/>
+                  <a:t>*</a:t>
+                </a:r>
+                <a:endParaRPr lang="zh-HK" altLang="en-US" sz="3200" dirty="0"/>
+              </a:p>
+            </p:txBody>
+          </p:sp>
+          <p:sp>
+            <p:nvSpPr>
+              <p:cNvPr id="99" name="文字方塊 98">
+                <a:extLst>
+                  <a:ext uri="{FF2B5EF4-FFF2-40B4-BE49-F238E27FC236}">
+                    <a16:creationId xmlns:a16="http://schemas.microsoft.com/office/drawing/2014/main" id="{757F40FB-EAF6-4663-9949-65B6A5C76C4C}"/>
+                  </a:ext>
+                </a:extLst>
+              </p:cNvPr>
+              <p:cNvSpPr txBox="1"/>
+              <p:nvPr/>
+            </p:nvSpPr>
+            <p:spPr>
+              <a:xfrm>
+                <a:off x="7392735" y="4983841"/>
+                <a:ext cx="371086" cy="584775"/>
+              </a:xfrm>
+              <a:prstGeom prst="rect">
+                <a:avLst/>
+              </a:prstGeom>
+              <a:noFill/>
+            </p:spPr>
+            <p:txBody>
+              <a:bodyPr wrap="square" rtlCol="0">
+                <a:spAutoFit/>
+              </a:bodyPr>
+              <a:lstStyle/>
+              <a:p>
+                <a:r>
+                  <a:rPr lang="en-US" altLang="zh-HK" sz="3200" dirty="0"/>
+                  <a:t>=</a:t>
+                </a:r>
+                <a:endParaRPr lang="zh-HK" altLang="en-US" sz="3200" dirty="0"/>
+              </a:p>
+            </p:txBody>
+          </p:sp>
           <p:cxnSp>
             <p:nvCxnSpPr>
-              <p:cNvPr id="48" name="直線單箭頭接點 47">
+              <p:cNvPr id="100" name="直線單箭頭接點 99">
                 <a:extLst>
                   <a:ext uri="{FF2B5EF4-FFF2-40B4-BE49-F238E27FC236}">
-                    <a16:creationId xmlns:a16="http://schemas.microsoft.com/office/drawing/2014/main" id="{A7A38FB2-FD2E-4166-BB5E-E380EE9042CC}"/>
+                    <a16:creationId xmlns:a16="http://schemas.microsoft.com/office/drawing/2014/main" id="{29BD2765-6721-4F6A-94E8-B8FDEADAE25E}"/>
                   </a:ext>
                 </a:extLst>
               </p:cNvPr>
@@ -6834,7 +6796,7 @@
             </p:nvCxnSpPr>
             <p:spPr>
               <a:xfrm flipH="1">
-                <a:off x="6497364" y="4429957"/>
+                <a:off x="7002007" y="4965471"/>
                 <a:ext cx="315756" cy="191479"/>
               </a:xfrm>
               <a:prstGeom prst="straightConnector1">
@@ -6859,12 +6821,108 @@
               </a:fontRef>
             </p:style>
           </p:cxnSp>
+          <p:grpSp>
+            <p:nvGrpSpPr>
+              <p:cNvPr id="53" name="群組 52">
+                <a:extLst>
+                  <a:ext uri="{FF2B5EF4-FFF2-40B4-BE49-F238E27FC236}">
+                    <a16:creationId xmlns:a16="http://schemas.microsoft.com/office/drawing/2014/main" id="{647C5896-09A4-4888-A878-BF9158B8285E}"/>
+                  </a:ext>
+                </a:extLst>
+              </p:cNvPr>
+              <p:cNvGrpSpPr/>
+              <p:nvPr/>
+            </p:nvGrpSpPr>
+            <p:grpSpPr>
+              <a:xfrm>
+                <a:off x="6497364" y="4225038"/>
+                <a:ext cx="433222" cy="396398"/>
+                <a:chOff x="6497364" y="4225038"/>
+                <a:chExt cx="433222" cy="396398"/>
+              </a:xfrm>
+            </p:grpSpPr>
+            <p:cxnSp>
+              <p:nvCxnSpPr>
+                <p:cNvPr id="48" name="直線單箭頭接點 47">
+                  <a:extLst>
+                    <a:ext uri="{FF2B5EF4-FFF2-40B4-BE49-F238E27FC236}">
+                      <a16:creationId xmlns:a16="http://schemas.microsoft.com/office/drawing/2014/main" id="{A7A38FB2-FD2E-4166-BB5E-E380EE9042CC}"/>
+                    </a:ext>
+                  </a:extLst>
+                </p:cNvPr>
+                <p:cNvCxnSpPr/>
+                <p:nvPr/>
+              </p:nvCxnSpPr>
+              <p:spPr>
+                <a:xfrm flipH="1">
+                  <a:off x="6497364" y="4429957"/>
+                  <a:ext cx="315756" cy="191479"/>
+                </a:xfrm>
+                <a:prstGeom prst="straightConnector1">
+                  <a:avLst/>
+                </a:prstGeom>
+                <a:ln>
+                  <a:tailEnd type="triangle"/>
+                </a:ln>
+              </p:spPr>
+              <p:style>
+                <a:lnRef idx="2">
+                  <a:schemeClr val="accent1"/>
+                </a:lnRef>
+                <a:fillRef idx="0">
+                  <a:schemeClr val="accent1"/>
+                </a:fillRef>
+                <a:effectRef idx="1">
+                  <a:schemeClr val="accent1"/>
+                </a:effectRef>
+                <a:fontRef idx="minor">
+                  <a:schemeClr val="tx1"/>
+                </a:fontRef>
+              </p:style>
+            </p:cxnSp>
+            <p:sp>
+              <p:nvSpPr>
+                <p:cNvPr id="49" name="文字方塊 48">
+                  <a:extLst>
+                    <a:ext uri="{FF2B5EF4-FFF2-40B4-BE49-F238E27FC236}">
+                      <a16:creationId xmlns:a16="http://schemas.microsoft.com/office/drawing/2014/main" id="{F965265F-29B6-4147-8CD0-0F64BEC9667B}"/>
+                    </a:ext>
+                  </a:extLst>
+                </p:cNvPr>
+                <p:cNvSpPr txBox="1"/>
+                <p:nvPr/>
+              </p:nvSpPr>
+              <p:spPr>
+                <a:xfrm>
+                  <a:off x="6776454" y="4225038"/>
+                  <a:ext cx="154132" cy="369332"/>
+                </a:xfrm>
+                <a:prstGeom prst="rect">
+                  <a:avLst/>
+                </a:prstGeom>
+                <a:noFill/>
+              </p:spPr>
+              <p:txBody>
+                <a:bodyPr wrap="square" rtlCol="0">
+                  <a:spAutoFit/>
+                </a:bodyPr>
+                <a:lstStyle/>
+                <a:p>
+                  <a:r>
+                    <a:rPr lang="en-US" altLang="zh-HK" dirty="0"/>
+                    <a:t>1</a:t>
+                  </a:r>
+                  <a:endParaRPr lang="zh-HK" altLang="en-US" dirty="0"/>
+                </a:p>
+              </p:txBody>
+            </p:sp>
+          </p:grpSp>
           <p:sp>
             <p:nvSpPr>
-              <p:cNvPr id="49" name="文字方塊 48">
+              <p:cNvPr id="51" name="文字方塊 50">
                 <a:extLst>
                   <a:ext uri="{FF2B5EF4-FFF2-40B4-BE49-F238E27FC236}">
-                    <a16:creationId xmlns:a16="http://schemas.microsoft.com/office/drawing/2014/main" id="{F965265F-29B6-4147-8CD0-0F64BEC9667B}"/>
+                    <a16:creationId xmlns:a16="http://schemas.microsoft.com/office/drawing/2014/main" id="{BF35C227-A57A-4B17-9409-B9AAAC6DE85C}"/>
                   </a:ext>
                 </a:extLst>
               </p:cNvPr>
@@ -6873,236 +6931,8 @@
             </p:nvSpPr>
             <p:spPr>
               <a:xfrm>
-                <a:off x="6776454" y="4225038"/>
-                <a:ext cx="154132" cy="369332"/>
-              </a:xfrm>
-              <a:prstGeom prst="rect">
-                <a:avLst/>
-              </a:prstGeom>
-              <a:noFill/>
-            </p:spPr>
-            <p:txBody>
-              <a:bodyPr wrap="square" rtlCol="0">
-                <a:spAutoFit/>
-              </a:bodyPr>
-              <a:lstStyle/>
-              <a:p>
-                <a:r>
-                  <a:rPr lang="en-US" altLang="zh-HK" dirty="0"/>
-                  <a:t>1</a:t>
-                </a:r>
-                <a:endParaRPr lang="zh-HK" altLang="en-US" dirty="0"/>
-              </a:p>
-            </p:txBody>
-          </p:sp>
-        </p:grpSp>
-        <p:sp>
-          <p:nvSpPr>
-            <p:cNvPr id="51" name="文字方塊 50">
-              <a:extLst>
-                <a:ext uri="{FF2B5EF4-FFF2-40B4-BE49-F238E27FC236}">
-                  <a16:creationId xmlns:a16="http://schemas.microsoft.com/office/drawing/2014/main" id="{BF35C227-A57A-4B17-9409-B9AAAC6DE85C}"/>
-                </a:ext>
-              </a:extLst>
-            </p:cNvPr>
-            <p:cNvSpPr txBox="1"/>
-            <p:nvPr/>
-          </p:nvSpPr>
-          <p:spPr>
-            <a:xfrm>
-              <a:off x="7275653" y="4751969"/>
-              <a:ext cx="164606" cy="369332"/>
-            </a:xfrm>
-            <a:prstGeom prst="rect">
-              <a:avLst/>
-            </a:prstGeom>
-            <a:noFill/>
-          </p:spPr>
-          <p:txBody>
-            <a:bodyPr wrap="square" rtlCol="0">
-              <a:spAutoFit/>
-            </a:bodyPr>
-            <a:lstStyle/>
-            <a:p>
-              <a:r>
-                <a:rPr lang="en-US" altLang="zh-HK" dirty="0"/>
-                <a:t>f</a:t>
-              </a:r>
-              <a:endParaRPr lang="zh-HK" altLang="en-US" dirty="0"/>
-            </a:p>
-          </p:txBody>
-        </p:sp>
-        <p:grpSp>
-          <p:nvGrpSpPr>
-            <p:cNvPr id="102" name="群組 101">
-              <a:extLst>
-                <a:ext uri="{FF2B5EF4-FFF2-40B4-BE49-F238E27FC236}">
-                  <a16:creationId xmlns:a16="http://schemas.microsoft.com/office/drawing/2014/main" id="{A6D08280-9385-4A2D-964A-B44B105C843B}"/>
-                </a:ext>
-              </a:extLst>
-            </p:cNvPr>
-            <p:cNvGrpSpPr/>
-            <p:nvPr/>
-          </p:nvGrpSpPr>
-          <p:grpSpPr>
-            <a:xfrm>
-              <a:off x="9115918" y="4167402"/>
-              <a:ext cx="433222" cy="396398"/>
-              <a:chOff x="6497364" y="4225038"/>
-              <a:chExt cx="433222" cy="396398"/>
-            </a:xfrm>
-          </p:grpSpPr>
-          <p:cxnSp>
-            <p:nvCxnSpPr>
-              <p:cNvPr id="103" name="直線單箭頭接點 102">
-                <a:extLst>
-                  <a:ext uri="{FF2B5EF4-FFF2-40B4-BE49-F238E27FC236}">
-                    <a16:creationId xmlns:a16="http://schemas.microsoft.com/office/drawing/2014/main" id="{DDC4EC55-B425-4C6C-B43B-B44285488F1C}"/>
-                  </a:ext>
-                </a:extLst>
-              </p:cNvPr>
-              <p:cNvCxnSpPr/>
-              <p:nvPr/>
-            </p:nvCxnSpPr>
-            <p:spPr>
-              <a:xfrm flipH="1">
-                <a:off x="6497364" y="4429957"/>
-                <a:ext cx="315756" cy="191479"/>
-              </a:xfrm>
-              <a:prstGeom prst="straightConnector1">
-                <a:avLst/>
-              </a:prstGeom>
-              <a:ln>
-                <a:tailEnd type="triangle"/>
-              </a:ln>
-            </p:spPr>
-            <p:style>
-              <a:lnRef idx="2">
-                <a:schemeClr val="accent1"/>
-              </a:lnRef>
-              <a:fillRef idx="0">
-                <a:schemeClr val="accent1"/>
-              </a:fillRef>
-              <a:effectRef idx="1">
-                <a:schemeClr val="accent1"/>
-              </a:effectRef>
-              <a:fontRef idx="minor">
-                <a:schemeClr val="tx1"/>
-              </a:fontRef>
-            </p:style>
-          </p:cxnSp>
-          <p:sp>
-            <p:nvSpPr>
-              <p:cNvPr id="104" name="文字方塊 103">
-                <a:extLst>
-                  <a:ext uri="{FF2B5EF4-FFF2-40B4-BE49-F238E27FC236}">
-                    <a16:creationId xmlns:a16="http://schemas.microsoft.com/office/drawing/2014/main" id="{99F3A210-B843-4292-86A7-86E968B1A077}"/>
-                  </a:ext>
-                </a:extLst>
-              </p:cNvPr>
-              <p:cNvSpPr txBox="1"/>
-              <p:nvPr/>
-            </p:nvSpPr>
-            <p:spPr>
-              <a:xfrm>
-                <a:off x="6776454" y="4225038"/>
-                <a:ext cx="154132" cy="369332"/>
-              </a:xfrm>
-              <a:prstGeom prst="rect">
-                <a:avLst/>
-              </a:prstGeom>
-              <a:noFill/>
-            </p:spPr>
-            <p:txBody>
-              <a:bodyPr wrap="square" rtlCol="0">
-                <a:spAutoFit/>
-              </a:bodyPr>
-              <a:lstStyle/>
-              <a:p>
-                <a:r>
-                  <a:rPr lang="en-US" altLang="zh-HK" dirty="0"/>
-                  <a:t>1</a:t>
-                </a:r>
-                <a:endParaRPr lang="zh-HK" altLang="en-US" dirty="0"/>
-              </a:p>
-            </p:txBody>
-          </p:sp>
-        </p:grpSp>
-        <p:grpSp>
-          <p:nvGrpSpPr>
-            <p:cNvPr id="105" name="群組 104">
-              <a:extLst>
-                <a:ext uri="{FF2B5EF4-FFF2-40B4-BE49-F238E27FC236}">
-                  <a16:creationId xmlns:a16="http://schemas.microsoft.com/office/drawing/2014/main" id="{88F3AF23-C369-4F33-950C-EA9A34918983}"/>
-                </a:ext>
-              </a:extLst>
-            </p:cNvPr>
-            <p:cNvGrpSpPr/>
-            <p:nvPr/>
-          </p:nvGrpSpPr>
-          <p:grpSpPr>
-            <a:xfrm>
-              <a:off x="9652391" y="4658401"/>
-              <a:ext cx="433222" cy="396398"/>
-              <a:chOff x="6497364" y="4225038"/>
-              <a:chExt cx="433222" cy="396398"/>
-            </a:xfrm>
-          </p:grpSpPr>
-          <p:cxnSp>
-            <p:nvCxnSpPr>
-              <p:cNvPr id="106" name="直線單箭頭接點 105">
-                <a:extLst>
-                  <a:ext uri="{FF2B5EF4-FFF2-40B4-BE49-F238E27FC236}">
-                    <a16:creationId xmlns:a16="http://schemas.microsoft.com/office/drawing/2014/main" id="{371CF24B-4282-4590-9241-E458C58BC1FD}"/>
-                  </a:ext>
-                </a:extLst>
-              </p:cNvPr>
-              <p:cNvCxnSpPr/>
-              <p:nvPr/>
-            </p:nvCxnSpPr>
-            <p:spPr>
-              <a:xfrm flipH="1">
-                <a:off x="6497364" y="4429957"/>
-                <a:ext cx="315756" cy="191479"/>
-              </a:xfrm>
-              <a:prstGeom prst="straightConnector1">
-                <a:avLst/>
-              </a:prstGeom>
-              <a:ln>
-                <a:tailEnd type="triangle"/>
-              </a:ln>
-            </p:spPr>
-            <p:style>
-              <a:lnRef idx="2">
-                <a:schemeClr val="accent1"/>
-              </a:lnRef>
-              <a:fillRef idx="0">
-                <a:schemeClr val="accent1"/>
-              </a:fillRef>
-              <a:effectRef idx="1">
-                <a:schemeClr val="accent1"/>
-              </a:effectRef>
-              <a:fontRef idx="minor">
-                <a:schemeClr val="tx1"/>
-              </a:fontRef>
-            </p:style>
-          </p:cxnSp>
-          <p:sp>
-            <p:nvSpPr>
-              <p:cNvPr id="107" name="文字方塊 106">
-                <a:extLst>
-                  <a:ext uri="{FF2B5EF4-FFF2-40B4-BE49-F238E27FC236}">
-                    <a16:creationId xmlns:a16="http://schemas.microsoft.com/office/drawing/2014/main" id="{E74F5F0B-D069-4328-B322-001A2DF7639C}"/>
-                  </a:ext>
-                </a:extLst>
-              </p:cNvPr>
-              <p:cNvSpPr txBox="1"/>
-              <p:nvPr/>
-            </p:nvSpPr>
-            <p:spPr>
-              <a:xfrm>
-                <a:off x="6776454" y="4225038"/>
-                <a:ext cx="154132" cy="369332"/>
+                <a:off x="7275653" y="4751969"/>
+                <a:ext cx="164606" cy="369332"/>
               </a:xfrm>
               <a:prstGeom prst="rect">
                 <a:avLst/>
@@ -7123,12 +6953,446 @@
               </a:p>
             </p:txBody>
           </p:sp>
+          <p:grpSp>
+            <p:nvGrpSpPr>
+              <p:cNvPr id="102" name="群組 101">
+                <a:extLst>
+                  <a:ext uri="{FF2B5EF4-FFF2-40B4-BE49-F238E27FC236}">
+                    <a16:creationId xmlns:a16="http://schemas.microsoft.com/office/drawing/2014/main" id="{A6D08280-9385-4A2D-964A-B44B105C843B}"/>
+                  </a:ext>
+                </a:extLst>
+              </p:cNvPr>
+              <p:cNvGrpSpPr/>
+              <p:nvPr/>
+            </p:nvGrpSpPr>
+            <p:grpSpPr>
+              <a:xfrm>
+                <a:off x="9115918" y="4167402"/>
+                <a:ext cx="433222" cy="396398"/>
+                <a:chOff x="6497364" y="4225038"/>
+                <a:chExt cx="433222" cy="396398"/>
+              </a:xfrm>
+            </p:grpSpPr>
+            <p:cxnSp>
+              <p:nvCxnSpPr>
+                <p:cNvPr id="103" name="直線單箭頭接點 102">
+                  <a:extLst>
+                    <a:ext uri="{FF2B5EF4-FFF2-40B4-BE49-F238E27FC236}">
+                      <a16:creationId xmlns:a16="http://schemas.microsoft.com/office/drawing/2014/main" id="{DDC4EC55-B425-4C6C-B43B-B44285488F1C}"/>
+                    </a:ext>
+                  </a:extLst>
+                </p:cNvPr>
+                <p:cNvCxnSpPr/>
+                <p:nvPr/>
+              </p:nvCxnSpPr>
+              <p:spPr>
+                <a:xfrm flipH="1">
+                  <a:off x="6497364" y="4429957"/>
+                  <a:ext cx="315756" cy="191479"/>
+                </a:xfrm>
+                <a:prstGeom prst="straightConnector1">
+                  <a:avLst/>
+                </a:prstGeom>
+                <a:ln>
+                  <a:tailEnd type="triangle"/>
+                </a:ln>
+              </p:spPr>
+              <p:style>
+                <a:lnRef idx="2">
+                  <a:schemeClr val="accent1"/>
+                </a:lnRef>
+                <a:fillRef idx="0">
+                  <a:schemeClr val="accent1"/>
+                </a:fillRef>
+                <a:effectRef idx="1">
+                  <a:schemeClr val="accent1"/>
+                </a:effectRef>
+                <a:fontRef idx="minor">
+                  <a:schemeClr val="tx1"/>
+                </a:fontRef>
+              </p:style>
+            </p:cxnSp>
+            <p:sp>
+              <p:nvSpPr>
+                <p:cNvPr id="104" name="文字方塊 103">
+                  <a:extLst>
+                    <a:ext uri="{FF2B5EF4-FFF2-40B4-BE49-F238E27FC236}">
+                      <a16:creationId xmlns:a16="http://schemas.microsoft.com/office/drawing/2014/main" id="{99F3A210-B843-4292-86A7-86E968B1A077}"/>
+                    </a:ext>
+                  </a:extLst>
+                </p:cNvPr>
+                <p:cNvSpPr txBox="1"/>
+                <p:nvPr/>
+              </p:nvSpPr>
+              <p:spPr>
+                <a:xfrm>
+                  <a:off x="6776454" y="4225038"/>
+                  <a:ext cx="154132" cy="369332"/>
+                </a:xfrm>
+                <a:prstGeom prst="rect">
+                  <a:avLst/>
+                </a:prstGeom>
+                <a:noFill/>
+              </p:spPr>
+              <p:txBody>
+                <a:bodyPr wrap="square" rtlCol="0">
+                  <a:spAutoFit/>
+                </a:bodyPr>
+                <a:lstStyle/>
+                <a:p>
+                  <a:r>
+                    <a:rPr lang="en-US" altLang="zh-HK" dirty="0"/>
+                    <a:t>1</a:t>
+                  </a:r>
+                  <a:endParaRPr lang="zh-HK" altLang="en-US" dirty="0"/>
+                </a:p>
+              </p:txBody>
+            </p:sp>
+          </p:grpSp>
+          <p:grpSp>
+            <p:nvGrpSpPr>
+              <p:cNvPr id="105" name="群組 104">
+                <a:extLst>
+                  <a:ext uri="{FF2B5EF4-FFF2-40B4-BE49-F238E27FC236}">
+                    <a16:creationId xmlns:a16="http://schemas.microsoft.com/office/drawing/2014/main" id="{88F3AF23-C369-4F33-950C-EA9A34918983}"/>
+                  </a:ext>
+                </a:extLst>
+              </p:cNvPr>
+              <p:cNvGrpSpPr/>
+              <p:nvPr/>
+            </p:nvGrpSpPr>
+            <p:grpSpPr>
+              <a:xfrm>
+                <a:off x="9652391" y="4658401"/>
+                <a:ext cx="433222" cy="396398"/>
+                <a:chOff x="6497364" y="4225038"/>
+                <a:chExt cx="433222" cy="396398"/>
+              </a:xfrm>
+            </p:grpSpPr>
+            <p:cxnSp>
+              <p:nvCxnSpPr>
+                <p:cNvPr id="106" name="直線單箭頭接點 105">
+                  <a:extLst>
+                    <a:ext uri="{FF2B5EF4-FFF2-40B4-BE49-F238E27FC236}">
+                      <a16:creationId xmlns:a16="http://schemas.microsoft.com/office/drawing/2014/main" id="{371CF24B-4282-4590-9241-E458C58BC1FD}"/>
+                    </a:ext>
+                  </a:extLst>
+                </p:cNvPr>
+                <p:cNvCxnSpPr/>
+                <p:nvPr/>
+              </p:nvCxnSpPr>
+              <p:spPr>
+                <a:xfrm flipH="1">
+                  <a:off x="6497364" y="4429957"/>
+                  <a:ext cx="315756" cy="191479"/>
+                </a:xfrm>
+                <a:prstGeom prst="straightConnector1">
+                  <a:avLst/>
+                </a:prstGeom>
+                <a:ln>
+                  <a:tailEnd type="triangle"/>
+                </a:ln>
+              </p:spPr>
+              <p:style>
+                <a:lnRef idx="2">
+                  <a:schemeClr val="accent1"/>
+                </a:lnRef>
+                <a:fillRef idx="0">
+                  <a:schemeClr val="accent1"/>
+                </a:fillRef>
+                <a:effectRef idx="1">
+                  <a:schemeClr val="accent1"/>
+                </a:effectRef>
+                <a:fontRef idx="minor">
+                  <a:schemeClr val="tx1"/>
+                </a:fontRef>
+              </p:style>
+            </p:cxnSp>
+            <p:sp>
+              <p:nvSpPr>
+                <p:cNvPr id="107" name="文字方塊 106">
+                  <a:extLst>
+                    <a:ext uri="{FF2B5EF4-FFF2-40B4-BE49-F238E27FC236}">
+                      <a16:creationId xmlns:a16="http://schemas.microsoft.com/office/drawing/2014/main" id="{E74F5F0B-D069-4328-B322-001A2DF7639C}"/>
+                    </a:ext>
+                  </a:extLst>
+                </p:cNvPr>
+                <p:cNvSpPr txBox="1"/>
+                <p:nvPr/>
+              </p:nvSpPr>
+              <p:spPr>
+                <a:xfrm>
+                  <a:off x="6776454" y="4225038"/>
+                  <a:ext cx="154132" cy="369332"/>
+                </a:xfrm>
+                <a:prstGeom prst="rect">
+                  <a:avLst/>
+                </a:prstGeom>
+                <a:noFill/>
+              </p:spPr>
+              <p:txBody>
+                <a:bodyPr wrap="square" rtlCol="0">
+                  <a:spAutoFit/>
+                </a:bodyPr>
+                <a:lstStyle/>
+                <a:p>
+                  <a:r>
+                    <a:rPr lang="en-US" altLang="zh-HK" dirty="0"/>
+                    <a:t>f</a:t>
+                  </a:r>
+                  <a:endParaRPr lang="zh-HK" altLang="en-US" dirty="0"/>
+                </a:p>
+              </p:txBody>
+            </p:sp>
+          </p:grpSp>
         </p:grpSp>
+        <p:cxnSp>
+          <p:nvCxnSpPr>
+            <p:cNvPr id="31" name="直線單箭頭接點 30">
+              <a:extLst>
+                <a:ext uri="{FF2B5EF4-FFF2-40B4-BE49-F238E27FC236}">
+                  <a16:creationId xmlns:a16="http://schemas.microsoft.com/office/drawing/2014/main" id="{57FA7EFB-E429-486E-B822-E2579A3C6C3F}"/>
+                </a:ext>
+              </a:extLst>
+            </p:cNvPr>
+            <p:cNvCxnSpPr/>
+            <p:nvPr/>
+          </p:nvCxnSpPr>
+          <p:spPr>
+            <a:xfrm>
+              <a:off x="6337648" y="5902513"/>
+              <a:ext cx="664359" cy="0"/>
+            </a:xfrm>
+            <a:prstGeom prst="straightConnector1">
+              <a:avLst/>
+            </a:prstGeom>
+            <a:ln>
+              <a:headEnd type="triangle"/>
+              <a:tailEnd type="triangle"/>
+            </a:ln>
+          </p:spPr>
+          <p:style>
+            <a:lnRef idx="2">
+              <a:schemeClr val="accent1"/>
+            </a:lnRef>
+            <a:fillRef idx="0">
+              <a:schemeClr val="accent1"/>
+            </a:fillRef>
+            <a:effectRef idx="1">
+              <a:schemeClr val="accent1"/>
+            </a:effectRef>
+            <a:fontRef idx="minor">
+              <a:schemeClr val="tx1"/>
+            </a:fontRef>
+          </p:style>
+        </p:cxnSp>
+        <p:sp>
+          <p:nvSpPr>
+            <p:cNvPr id="101" name="文字方塊 100">
+              <a:extLst>
+                <a:ext uri="{FF2B5EF4-FFF2-40B4-BE49-F238E27FC236}">
+                  <a16:creationId xmlns:a16="http://schemas.microsoft.com/office/drawing/2014/main" id="{DB5AC106-16A5-432C-B983-C78E486EF36B}"/>
+                </a:ext>
+              </a:extLst>
+            </p:cNvPr>
+            <p:cNvSpPr txBox="1"/>
+            <p:nvPr/>
+          </p:nvSpPr>
+          <p:spPr>
+            <a:xfrm>
+              <a:off x="6527477" y="5631519"/>
+              <a:ext cx="154132" cy="369332"/>
+            </a:xfrm>
+            <a:prstGeom prst="rect">
+              <a:avLst/>
+            </a:prstGeom>
+            <a:noFill/>
+          </p:spPr>
+          <p:txBody>
+            <a:bodyPr wrap="square" rtlCol="0">
+              <a:spAutoFit/>
+            </a:bodyPr>
+            <a:lstStyle/>
+            <a:p>
+              <a:r>
+                <a:rPr lang="en-US" altLang="zh-CN" dirty="0"/>
+                <a:t>k</a:t>
+              </a:r>
+              <a:endParaRPr lang="zh-HK" altLang="en-US" dirty="0"/>
+            </a:p>
+          </p:txBody>
+        </p:sp>
+        <p:cxnSp>
+          <p:nvCxnSpPr>
+            <p:cNvPr id="108" name="直線單箭頭接點 107">
+              <a:extLst>
+                <a:ext uri="{FF2B5EF4-FFF2-40B4-BE49-F238E27FC236}">
+                  <a16:creationId xmlns:a16="http://schemas.microsoft.com/office/drawing/2014/main" id="{E4C0EC7F-175F-4EEF-AB9E-58B5768DD9C7}"/>
+                </a:ext>
+              </a:extLst>
+            </p:cNvPr>
+            <p:cNvCxnSpPr>
+              <a:cxnSpLocks/>
+            </p:cNvCxnSpPr>
+            <p:nvPr/>
+          </p:nvCxnSpPr>
+          <p:spPr>
+            <a:xfrm flipV="1">
+              <a:off x="7111359" y="5151216"/>
+              <a:ext cx="7316" cy="642981"/>
+            </a:xfrm>
+            <a:prstGeom prst="straightConnector1">
+              <a:avLst/>
+            </a:prstGeom>
+            <a:ln>
+              <a:headEnd type="triangle"/>
+              <a:tailEnd type="triangle"/>
+            </a:ln>
+          </p:spPr>
+          <p:style>
+            <a:lnRef idx="2">
+              <a:schemeClr val="accent1"/>
+            </a:lnRef>
+            <a:fillRef idx="0">
+              <a:schemeClr val="accent1"/>
+            </a:fillRef>
+            <a:effectRef idx="1">
+              <a:schemeClr val="accent1"/>
+            </a:effectRef>
+            <a:fontRef idx="minor">
+              <a:schemeClr val="tx1"/>
+            </a:fontRef>
+          </p:style>
+        </p:cxnSp>
+        <p:sp>
+          <p:nvSpPr>
+            <p:cNvPr id="109" name="文字方塊 108">
+              <a:extLst>
+                <a:ext uri="{FF2B5EF4-FFF2-40B4-BE49-F238E27FC236}">
+                  <a16:creationId xmlns:a16="http://schemas.microsoft.com/office/drawing/2014/main" id="{6C2B88BA-897D-45AA-BE10-DCAD5CF7A04D}"/>
+                </a:ext>
+              </a:extLst>
+            </p:cNvPr>
+            <p:cNvSpPr txBox="1"/>
+            <p:nvPr/>
+          </p:nvSpPr>
+          <p:spPr>
+            <a:xfrm>
+              <a:off x="7060074" y="5296543"/>
+              <a:ext cx="154132" cy="369332"/>
+            </a:xfrm>
+            <a:prstGeom prst="rect">
+              <a:avLst/>
+            </a:prstGeom>
+            <a:noFill/>
+          </p:spPr>
+          <p:txBody>
+            <a:bodyPr wrap="square" rtlCol="0">
+              <a:spAutoFit/>
+            </a:bodyPr>
+            <a:lstStyle/>
+            <a:p>
+              <a:r>
+                <a:rPr lang="en-US" altLang="zh-CN" dirty="0"/>
+                <a:t>k</a:t>
+              </a:r>
+              <a:endParaRPr lang="zh-HK" altLang="en-US" dirty="0"/>
+            </a:p>
+          </p:txBody>
+        </p:sp>
       </p:grpSp>
     </p:spTree>
     <p:extLst>
       <p:ext uri="{BB962C8B-B14F-4D97-AF65-F5344CB8AC3E}">
         <p14:creationId xmlns:p14="http://schemas.microsoft.com/office/powerpoint/2010/main" val="2813082791"/>
+      </p:ext>
+    </p:extLst>
+  </p:cSld>
+  <p:clrMapOvr>
+    <a:masterClrMapping/>
+  </p:clrMapOvr>
+</p:sld>
+</file>
+
+<file path=ppt/slides/slide4.xml><?xml version="1.0" encoding="utf-8"?>
+<p:sld xmlns:a="http://schemas.openxmlformats.org/drawingml/2006/main" xmlns:r="http://schemas.openxmlformats.org/officeDocument/2006/relationships" xmlns:p="http://schemas.openxmlformats.org/presentationml/2006/main">
+  <p:cSld>
+    <p:spTree>
+      <p:nvGrpSpPr>
+        <p:cNvPr id="1" name=""/>
+        <p:cNvGrpSpPr/>
+        <p:nvPr/>
+      </p:nvGrpSpPr>
+      <p:grpSpPr>
+        <a:xfrm>
+          <a:off x="0" y="0"/>
+          <a:ext cx="0" cy="0"/>
+          <a:chOff x="0" y="0"/>
+          <a:chExt cx="0" cy="0"/>
+        </a:xfrm>
+      </p:grpSpPr>
+      <p:pic>
+        <p:nvPicPr>
+          <p:cNvPr id="4" name="圖片 3">
+            <a:extLst>
+              <a:ext uri="{FF2B5EF4-FFF2-40B4-BE49-F238E27FC236}">
+                <a16:creationId xmlns:a16="http://schemas.microsoft.com/office/drawing/2014/main" id="{BA94E214-257B-4CA1-B599-4519D6EBA854}"/>
+              </a:ext>
+            </a:extLst>
+          </p:cNvPr>
+          <p:cNvPicPr>
+            <a:picLocks noChangeAspect="1"/>
+          </p:cNvPicPr>
+          <p:nvPr/>
+        </p:nvPicPr>
+        <p:blipFill rotWithShape="1">
+          <a:blip r:embed="rId2"/>
+          <a:srcRect b="85502"/>
+          <a:stretch/>
+        </p:blipFill>
+        <p:spPr>
+          <a:xfrm>
+            <a:off x="1156306" y="346229"/>
+            <a:ext cx="6934734" cy="1997476"/>
+          </a:xfrm>
+          <a:prstGeom prst="rect">
+            <a:avLst/>
+          </a:prstGeom>
+        </p:spPr>
+      </p:pic>
+      <p:pic>
+        <p:nvPicPr>
+          <p:cNvPr id="5" name="圖片 4">
+            <a:extLst>
+              <a:ext uri="{FF2B5EF4-FFF2-40B4-BE49-F238E27FC236}">
+                <a16:creationId xmlns:a16="http://schemas.microsoft.com/office/drawing/2014/main" id="{E49474A0-EEF4-40B6-B8DB-0D7864F1352B}"/>
+              </a:ext>
+            </a:extLst>
+          </p:cNvPr>
+          <p:cNvPicPr>
+            <a:picLocks noChangeAspect="1"/>
+          </p:cNvPicPr>
+          <p:nvPr/>
+        </p:nvPicPr>
+        <p:blipFill rotWithShape="1">
+          <a:blip r:embed="rId3"/>
+          <a:srcRect b="88867"/>
+          <a:stretch/>
+        </p:blipFill>
+        <p:spPr>
+          <a:xfrm>
+            <a:off x="3264348" y="3630966"/>
+            <a:ext cx="7569354" cy="1686757"/>
+          </a:xfrm>
+          <a:prstGeom prst="rect">
+            <a:avLst/>
+          </a:prstGeom>
+        </p:spPr>
+      </p:pic>
+    </p:spTree>
+    <p:extLst>
+      <p:ext uri="{BB962C8B-B14F-4D97-AF65-F5344CB8AC3E}">
+        <p14:creationId xmlns:p14="http://schemas.microsoft.com/office/powerpoint/2010/main" val="1557905876"/>
       </p:ext>
     </p:extLst>
   </p:cSld>

</xml_diff>